<commit_message>
Settings com campo de pesquisa a 50% e docs/decks alinhados (410 testes em 31 classes, inventario da pasta Docs, secao de decks de documentacao nos READMEs); Funcionalidades.pptx regenerado
</commit_message>
<xml_diff>
--- a/OllamaArena/Docs/Funcionalidades.pptx
+++ b/OllamaArena/Docs/Funcionalidades.pptx
@@ -153,7 +153,7 @@
           <p:cNvPr id="2" name="Título 1">
             <a:extLst>
               <a:ext uri="{FF2B5EF4-FFF2-40B4-BE49-F238E27FC236}">
-                <a16:creationId xmlns:a16="http://schemas.microsoft.com/office/drawing/2014/main" id="{BB5A805A-B235-F1F1-E829-4E98AB599E1D}"/>
+                <a16:creationId xmlns:a16="http://schemas.microsoft.com/office/drawing/2014/main" id="{D15CF22B-85F1-A692-0E91-FCEC4416620C}"/>
               </a:ext>
             </a:extLst>
           </p:cNvPr>
@@ -190,7 +190,7 @@
           <p:cNvPr id="3" name="Subtítulo 2">
             <a:extLst>
               <a:ext uri="{FF2B5EF4-FFF2-40B4-BE49-F238E27FC236}">
-                <a16:creationId xmlns:a16="http://schemas.microsoft.com/office/drawing/2014/main" id="{79541FBD-8668-1481-88EF-5B697CB23790}"/>
+                <a16:creationId xmlns:a16="http://schemas.microsoft.com/office/drawing/2014/main" id="{10642445-0164-F020-5530-682D0D10E624}"/>
               </a:ext>
             </a:extLst>
           </p:cNvPr>
@@ -260,7 +260,7 @@
           <p:cNvPr id="4" name="Marcador de Posição da Data 3">
             <a:extLst>
               <a:ext uri="{FF2B5EF4-FFF2-40B4-BE49-F238E27FC236}">
-                <a16:creationId xmlns:a16="http://schemas.microsoft.com/office/drawing/2014/main" id="{92C1A1E7-83A9-7C63-980C-61B5BFA01916}"/>
+                <a16:creationId xmlns:a16="http://schemas.microsoft.com/office/drawing/2014/main" id="{A6CE3A81-83DE-AD37-885D-34EF1B0BF72B}"/>
               </a:ext>
             </a:extLst>
           </p:cNvPr>
@@ -276,9 +276,9 @@
           <a:bodyPr/>
           <a:lstStyle/>
           <a:p>
-            <a:fld id="{14089DB3-50E1-4287-8A19-3FED6D76FC0D}" type="datetimeFigureOut">
+            <a:fld id="{7BF0C43D-FB6B-47F3-B10D-68B223D2E940}" type="datetimeFigureOut">
               <a:rPr lang="pt-PT" smtClean="0"/>
-              <a:t>06/10/2026</a:t>
+              <a:t>13/10/2026</a:t>
             </a:fld>
             <a:endParaRPr lang="pt-PT"/>
           </a:p>
@@ -289,7 +289,7 @@
           <p:cNvPr id="5" name="Marcador de Posição do Rodapé 4">
             <a:extLst>
               <a:ext uri="{FF2B5EF4-FFF2-40B4-BE49-F238E27FC236}">
-                <a16:creationId xmlns:a16="http://schemas.microsoft.com/office/drawing/2014/main" id="{3F031A58-006E-CAF6-644D-23FD7BD49B9C}"/>
+                <a16:creationId xmlns:a16="http://schemas.microsoft.com/office/drawing/2014/main" id="{6F9B290D-1221-C3A8-974A-7EA2F3FE20EA}"/>
               </a:ext>
             </a:extLst>
           </p:cNvPr>
@@ -314,7 +314,7 @@
           <p:cNvPr id="6" name="Marcador de Posição do Número do Diapositivo 5">
             <a:extLst>
               <a:ext uri="{FF2B5EF4-FFF2-40B4-BE49-F238E27FC236}">
-                <a16:creationId xmlns:a16="http://schemas.microsoft.com/office/drawing/2014/main" id="{89C2A190-E0EB-D80D-773B-F79EDB4D81F1}"/>
+                <a16:creationId xmlns:a16="http://schemas.microsoft.com/office/drawing/2014/main" id="{12855B70-DCAF-E868-2945-6FA32F395EF7}"/>
               </a:ext>
             </a:extLst>
           </p:cNvPr>
@@ -330,7 +330,7 @@
           <a:bodyPr/>
           <a:lstStyle/>
           <a:p>
-            <a:fld id="{B1FC2AA8-E6FD-4FF5-BC96-8248C53506A3}" type="slidenum">
+            <a:fld id="{F53C86CB-7EC3-4464-9F44-14EE0647213E}" type="slidenum">
               <a:rPr lang="pt-PT" smtClean="0"/>
               <a:t>‹nº›</a:t>
             </a:fld>
@@ -341,7 +341,7 @@
     </p:spTree>
     <p:extLst>
       <p:ext uri="{BB962C8B-B14F-4D97-AF65-F5344CB8AC3E}">
-        <p14:creationId xmlns:p14="http://schemas.microsoft.com/office/powerpoint/2010/main" val="3434970979"/>
+        <p14:creationId xmlns:p14="http://schemas.microsoft.com/office/powerpoint/2010/main" val="2982407207"/>
       </p:ext>
     </p:extLst>
   </p:cSld>
@@ -373,7 +373,7 @@
           <p:cNvPr id="2" name="Título 1">
             <a:extLst>
               <a:ext uri="{FF2B5EF4-FFF2-40B4-BE49-F238E27FC236}">
-                <a16:creationId xmlns:a16="http://schemas.microsoft.com/office/drawing/2014/main" id="{DF309A03-382A-298C-A359-F3919B684A80}"/>
+                <a16:creationId xmlns:a16="http://schemas.microsoft.com/office/drawing/2014/main" id="{393C20DB-6D74-C3E1-6687-F4B260613382}"/>
               </a:ext>
             </a:extLst>
           </p:cNvPr>
@@ -401,7 +401,7 @@
           <p:cNvPr id="3" name="Marcador de Posição de Texto Vertical 2">
             <a:extLst>
               <a:ext uri="{FF2B5EF4-FFF2-40B4-BE49-F238E27FC236}">
-                <a16:creationId xmlns:a16="http://schemas.microsoft.com/office/drawing/2014/main" id="{F24713E5-2895-EB1B-8BC6-7C0515AC607E}"/>
+                <a16:creationId xmlns:a16="http://schemas.microsoft.com/office/drawing/2014/main" id="{9386960A-E3E9-BBF8-5E9A-FBF2455CDD57}"/>
               </a:ext>
             </a:extLst>
           </p:cNvPr>
@@ -458,7 +458,7 @@
           <p:cNvPr id="4" name="Marcador de Posição da Data 3">
             <a:extLst>
               <a:ext uri="{FF2B5EF4-FFF2-40B4-BE49-F238E27FC236}">
-                <a16:creationId xmlns:a16="http://schemas.microsoft.com/office/drawing/2014/main" id="{E5D64989-1D5C-22F8-09B8-C93D4172C828}"/>
+                <a16:creationId xmlns:a16="http://schemas.microsoft.com/office/drawing/2014/main" id="{2452BA51-E65A-D38E-89A1-B941696203CA}"/>
               </a:ext>
             </a:extLst>
           </p:cNvPr>
@@ -474,9 +474,9 @@
           <a:bodyPr/>
           <a:lstStyle/>
           <a:p>
-            <a:fld id="{14089DB3-50E1-4287-8A19-3FED6D76FC0D}" type="datetimeFigureOut">
+            <a:fld id="{7BF0C43D-FB6B-47F3-B10D-68B223D2E940}" type="datetimeFigureOut">
               <a:rPr lang="pt-PT" smtClean="0"/>
-              <a:t>06/10/2026</a:t>
+              <a:t>13/10/2026</a:t>
             </a:fld>
             <a:endParaRPr lang="pt-PT"/>
           </a:p>
@@ -487,7 +487,7 @@
           <p:cNvPr id="5" name="Marcador de Posição do Rodapé 4">
             <a:extLst>
               <a:ext uri="{FF2B5EF4-FFF2-40B4-BE49-F238E27FC236}">
-                <a16:creationId xmlns:a16="http://schemas.microsoft.com/office/drawing/2014/main" id="{7517F24F-BD38-A5AB-A700-2A63FA34C8A2}"/>
+                <a16:creationId xmlns:a16="http://schemas.microsoft.com/office/drawing/2014/main" id="{FE027E74-E2AD-7FB5-1465-B7DCF0BB5858}"/>
               </a:ext>
             </a:extLst>
           </p:cNvPr>
@@ -512,7 +512,7 @@
           <p:cNvPr id="6" name="Marcador de Posição do Número do Diapositivo 5">
             <a:extLst>
               <a:ext uri="{FF2B5EF4-FFF2-40B4-BE49-F238E27FC236}">
-                <a16:creationId xmlns:a16="http://schemas.microsoft.com/office/drawing/2014/main" id="{2E0BA838-B89E-C9C7-12B4-83052047C387}"/>
+                <a16:creationId xmlns:a16="http://schemas.microsoft.com/office/drawing/2014/main" id="{F0EBF568-28A7-1AC4-793E-26AE7007985B}"/>
               </a:ext>
             </a:extLst>
           </p:cNvPr>
@@ -528,7 +528,7 @@
           <a:bodyPr/>
           <a:lstStyle/>
           <a:p>
-            <a:fld id="{B1FC2AA8-E6FD-4FF5-BC96-8248C53506A3}" type="slidenum">
+            <a:fld id="{F53C86CB-7EC3-4464-9F44-14EE0647213E}" type="slidenum">
               <a:rPr lang="pt-PT" smtClean="0"/>
               <a:t>‹nº›</a:t>
             </a:fld>
@@ -539,7 +539,7 @@
     </p:spTree>
     <p:extLst>
       <p:ext uri="{BB962C8B-B14F-4D97-AF65-F5344CB8AC3E}">
-        <p14:creationId xmlns:p14="http://schemas.microsoft.com/office/powerpoint/2010/main" val="3992205722"/>
+        <p14:creationId xmlns:p14="http://schemas.microsoft.com/office/powerpoint/2010/main" val="1504631575"/>
       </p:ext>
     </p:extLst>
   </p:cSld>
@@ -571,7 +571,7 @@
           <p:cNvPr id="2" name="Título Vertical 1">
             <a:extLst>
               <a:ext uri="{FF2B5EF4-FFF2-40B4-BE49-F238E27FC236}">
-                <a16:creationId xmlns:a16="http://schemas.microsoft.com/office/drawing/2014/main" id="{1D9E6423-414D-ADDC-A1E5-980087A41A05}"/>
+                <a16:creationId xmlns:a16="http://schemas.microsoft.com/office/drawing/2014/main" id="{437B2593-B894-E258-5E4D-E7A587CAF466}"/>
               </a:ext>
             </a:extLst>
           </p:cNvPr>
@@ -604,7 +604,7 @@
           <p:cNvPr id="3" name="Marcador de Posição de Texto Vertical 2">
             <a:extLst>
               <a:ext uri="{FF2B5EF4-FFF2-40B4-BE49-F238E27FC236}">
-                <a16:creationId xmlns:a16="http://schemas.microsoft.com/office/drawing/2014/main" id="{0094DA38-89B7-D52E-B2D7-D992E5436F2E}"/>
+                <a16:creationId xmlns:a16="http://schemas.microsoft.com/office/drawing/2014/main" id="{3FE321CC-0CB1-0B7F-A090-AEEACC1233DE}"/>
               </a:ext>
             </a:extLst>
           </p:cNvPr>
@@ -666,7 +666,7 @@
           <p:cNvPr id="4" name="Marcador de Posição da Data 3">
             <a:extLst>
               <a:ext uri="{FF2B5EF4-FFF2-40B4-BE49-F238E27FC236}">
-                <a16:creationId xmlns:a16="http://schemas.microsoft.com/office/drawing/2014/main" id="{8E7A95D3-A7F9-CD4D-65B3-56F91E59E0F8}"/>
+                <a16:creationId xmlns:a16="http://schemas.microsoft.com/office/drawing/2014/main" id="{D560410E-AA3F-F6CA-7D64-F806634D878E}"/>
               </a:ext>
             </a:extLst>
           </p:cNvPr>
@@ -682,9 +682,9 @@
           <a:bodyPr/>
           <a:lstStyle/>
           <a:p>
-            <a:fld id="{14089DB3-50E1-4287-8A19-3FED6D76FC0D}" type="datetimeFigureOut">
+            <a:fld id="{7BF0C43D-FB6B-47F3-B10D-68B223D2E940}" type="datetimeFigureOut">
               <a:rPr lang="pt-PT" smtClean="0"/>
-              <a:t>06/10/2026</a:t>
+              <a:t>13/10/2026</a:t>
             </a:fld>
             <a:endParaRPr lang="pt-PT"/>
           </a:p>
@@ -695,7 +695,7 @@
           <p:cNvPr id="5" name="Marcador de Posição do Rodapé 4">
             <a:extLst>
               <a:ext uri="{FF2B5EF4-FFF2-40B4-BE49-F238E27FC236}">
-                <a16:creationId xmlns:a16="http://schemas.microsoft.com/office/drawing/2014/main" id="{2EC1BB17-4950-1783-AF05-C5993BD7E582}"/>
+                <a16:creationId xmlns:a16="http://schemas.microsoft.com/office/drawing/2014/main" id="{B439AFEB-D21C-962A-2E0D-BE866FC8121D}"/>
               </a:ext>
             </a:extLst>
           </p:cNvPr>
@@ -720,7 +720,7 @@
           <p:cNvPr id="6" name="Marcador de Posição do Número do Diapositivo 5">
             <a:extLst>
               <a:ext uri="{FF2B5EF4-FFF2-40B4-BE49-F238E27FC236}">
-                <a16:creationId xmlns:a16="http://schemas.microsoft.com/office/drawing/2014/main" id="{0A0D8B3B-1DA0-D8BF-E6DC-A3179A881308}"/>
+                <a16:creationId xmlns:a16="http://schemas.microsoft.com/office/drawing/2014/main" id="{31FA3784-F61E-9E55-BFC5-0E02329361CD}"/>
               </a:ext>
             </a:extLst>
           </p:cNvPr>
@@ -736,7 +736,7 @@
           <a:bodyPr/>
           <a:lstStyle/>
           <a:p>
-            <a:fld id="{B1FC2AA8-E6FD-4FF5-BC96-8248C53506A3}" type="slidenum">
+            <a:fld id="{F53C86CB-7EC3-4464-9F44-14EE0647213E}" type="slidenum">
               <a:rPr lang="pt-PT" smtClean="0"/>
               <a:t>‹nº›</a:t>
             </a:fld>
@@ -747,7 +747,7 @@
     </p:spTree>
     <p:extLst>
       <p:ext uri="{BB962C8B-B14F-4D97-AF65-F5344CB8AC3E}">
-        <p14:creationId xmlns:p14="http://schemas.microsoft.com/office/powerpoint/2010/main" val="2486566557"/>
+        <p14:creationId xmlns:p14="http://schemas.microsoft.com/office/powerpoint/2010/main" val="1882914421"/>
       </p:ext>
     </p:extLst>
   </p:cSld>
@@ -779,7 +779,7 @@
           <p:cNvPr id="2" name="Título 1">
             <a:extLst>
               <a:ext uri="{FF2B5EF4-FFF2-40B4-BE49-F238E27FC236}">
-                <a16:creationId xmlns:a16="http://schemas.microsoft.com/office/drawing/2014/main" id="{85361EF2-55C2-BA4B-E552-4DFD3FF983E6}"/>
+                <a16:creationId xmlns:a16="http://schemas.microsoft.com/office/drawing/2014/main" id="{63BEFDEC-93CF-1B93-00CB-C330FCD67792}"/>
               </a:ext>
             </a:extLst>
           </p:cNvPr>
@@ -807,7 +807,7 @@
           <p:cNvPr id="3" name="Marcador de Posição de Conteúdo 2">
             <a:extLst>
               <a:ext uri="{FF2B5EF4-FFF2-40B4-BE49-F238E27FC236}">
-                <a16:creationId xmlns:a16="http://schemas.microsoft.com/office/drawing/2014/main" id="{F73537B1-BAE5-3972-6E4B-EFFE85B1C37B}"/>
+                <a16:creationId xmlns:a16="http://schemas.microsoft.com/office/drawing/2014/main" id="{4C2DE8BF-3398-4ACA-5512-65A266C10FD8}"/>
               </a:ext>
             </a:extLst>
           </p:cNvPr>
@@ -864,7 +864,7 @@
           <p:cNvPr id="4" name="Marcador de Posição da Data 3">
             <a:extLst>
               <a:ext uri="{FF2B5EF4-FFF2-40B4-BE49-F238E27FC236}">
-                <a16:creationId xmlns:a16="http://schemas.microsoft.com/office/drawing/2014/main" id="{CAD15F43-362A-8A3A-71BD-B10D81D5789D}"/>
+                <a16:creationId xmlns:a16="http://schemas.microsoft.com/office/drawing/2014/main" id="{F51CFE0D-5249-BFCE-616A-072D6AAB1DA3}"/>
               </a:ext>
             </a:extLst>
           </p:cNvPr>
@@ -880,9 +880,9 @@
           <a:bodyPr/>
           <a:lstStyle/>
           <a:p>
-            <a:fld id="{14089DB3-50E1-4287-8A19-3FED6D76FC0D}" type="datetimeFigureOut">
+            <a:fld id="{7BF0C43D-FB6B-47F3-B10D-68B223D2E940}" type="datetimeFigureOut">
               <a:rPr lang="pt-PT" smtClean="0"/>
-              <a:t>06/10/2026</a:t>
+              <a:t>13/10/2026</a:t>
             </a:fld>
             <a:endParaRPr lang="pt-PT"/>
           </a:p>
@@ -893,7 +893,7 @@
           <p:cNvPr id="5" name="Marcador de Posição do Rodapé 4">
             <a:extLst>
               <a:ext uri="{FF2B5EF4-FFF2-40B4-BE49-F238E27FC236}">
-                <a16:creationId xmlns:a16="http://schemas.microsoft.com/office/drawing/2014/main" id="{5A5DC0A0-D335-4AC9-68E0-DB190394A79C}"/>
+                <a16:creationId xmlns:a16="http://schemas.microsoft.com/office/drawing/2014/main" id="{53841A21-2B2D-E7C8-7558-8F5E70DDD02F}"/>
               </a:ext>
             </a:extLst>
           </p:cNvPr>
@@ -918,7 +918,7 @@
           <p:cNvPr id="6" name="Marcador de Posição do Número do Diapositivo 5">
             <a:extLst>
               <a:ext uri="{FF2B5EF4-FFF2-40B4-BE49-F238E27FC236}">
-                <a16:creationId xmlns:a16="http://schemas.microsoft.com/office/drawing/2014/main" id="{50DFDA63-5D41-BC1B-0AFD-314116F24A97}"/>
+                <a16:creationId xmlns:a16="http://schemas.microsoft.com/office/drawing/2014/main" id="{B2684590-5218-4E00-F55F-AAA65413BFE6}"/>
               </a:ext>
             </a:extLst>
           </p:cNvPr>
@@ -934,7 +934,7 @@
           <a:bodyPr/>
           <a:lstStyle/>
           <a:p>
-            <a:fld id="{B1FC2AA8-E6FD-4FF5-BC96-8248C53506A3}" type="slidenum">
+            <a:fld id="{F53C86CB-7EC3-4464-9F44-14EE0647213E}" type="slidenum">
               <a:rPr lang="pt-PT" smtClean="0"/>
               <a:t>‹nº›</a:t>
             </a:fld>
@@ -945,7 +945,7 @@
     </p:spTree>
     <p:extLst>
       <p:ext uri="{BB962C8B-B14F-4D97-AF65-F5344CB8AC3E}">
-        <p14:creationId xmlns:p14="http://schemas.microsoft.com/office/powerpoint/2010/main" val="1340056922"/>
+        <p14:creationId xmlns:p14="http://schemas.microsoft.com/office/powerpoint/2010/main" val="11193558"/>
       </p:ext>
     </p:extLst>
   </p:cSld>
@@ -977,7 +977,7 @@
           <p:cNvPr id="2" name="Título 1">
             <a:extLst>
               <a:ext uri="{FF2B5EF4-FFF2-40B4-BE49-F238E27FC236}">
-                <a16:creationId xmlns:a16="http://schemas.microsoft.com/office/drawing/2014/main" id="{48E0BD80-D041-5CAB-5AE8-8314B378FB4D}"/>
+                <a16:creationId xmlns:a16="http://schemas.microsoft.com/office/drawing/2014/main" id="{0F4A66E1-D4EA-1DEC-AEC6-C4F668B3648F}"/>
               </a:ext>
             </a:extLst>
           </p:cNvPr>
@@ -1014,7 +1014,7 @@
           <p:cNvPr id="3" name="Marcador de Posição do Texto 2">
             <a:extLst>
               <a:ext uri="{FF2B5EF4-FFF2-40B4-BE49-F238E27FC236}">
-                <a16:creationId xmlns:a16="http://schemas.microsoft.com/office/drawing/2014/main" id="{9670A9C7-773D-7CEA-E2F5-8F7CE8BF1325}"/>
+                <a16:creationId xmlns:a16="http://schemas.microsoft.com/office/drawing/2014/main" id="{33A7CDDC-21AC-9C3C-6D08-70B2FFF8CCFB}"/>
               </a:ext>
             </a:extLst>
           </p:cNvPr>
@@ -1139,7 +1139,7 @@
           <p:cNvPr id="4" name="Marcador de Posição da Data 3">
             <a:extLst>
               <a:ext uri="{FF2B5EF4-FFF2-40B4-BE49-F238E27FC236}">
-                <a16:creationId xmlns:a16="http://schemas.microsoft.com/office/drawing/2014/main" id="{0640290E-485C-AE52-95AF-C979BA26D142}"/>
+                <a16:creationId xmlns:a16="http://schemas.microsoft.com/office/drawing/2014/main" id="{74E64BCC-7544-5DC9-E059-1AC1286EE258}"/>
               </a:ext>
             </a:extLst>
           </p:cNvPr>
@@ -1155,9 +1155,9 @@
           <a:bodyPr/>
           <a:lstStyle/>
           <a:p>
-            <a:fld id="{14089DB3-50E1-4287-8A19-3FED6D76FC0D}" type="datetimeFigureOut">
+            <a:fld id="{7BF0C43D-FB6B-47F3-B10D-68B223D2E940}" type="datetimeFigureOut">
               <a:rPr lang="pt-PT" smtClean="0"/>
-              <a:t>06/10/2026</a:t>
+              <a:t>13/10/2026</a:t>
             </a:fld>
             <a:endParaRPr lang="pt-PT"/>
           </a:p>
@@ -1168,7 +1168,7 @@
           <p:cNvPr id="5" name="Marcador de Posição do Rodapé 4">
             <a:extLst>
               <a:ext uri="{FF2B5EF4-FFF2-40B4-BE49-F238E27FC236}">
-                <a16:creationId xmlns:a16="http://schemas.microsoft.com/office/drawing/2014/main" id="{EC3FADE0-DDEF-223E-48CE-2984F25177E6}"/>
+                <a16:creationId xmlns:a16="http://schemas.microsoft.com/office/drawing/2014/main" id="{EB3B9951-D32C-08CC-8E8A-A342CAB940A7}"/>
               </a:ext>
             </a:extLst>
           </p:cNvPr>
@@ -1193,7 +1193,7 @@
           <p:cNvPr id="6" name="Marcador de Posição do Número do Diapositivo 5">
             <a:extLst>
               <a:ext uri="{FF2B5EF4-FFF2-40B4-BE49-F238E27FC236}">
-                <a16:creationId xmlns:a16="http://schemas.microsoft.com/office/drawing/2014/main" id="{342BFEDC-FF7A-FD5D-8F7D-31E82A602646}"/>
+                <a16:creationId xmlns:a16="http://schemas.microsoft.com/office/drawing/2014/main" id="{379C4C21-A658-408E-226C-7900059D4D2D}"/>
               </a:ext>
             </a:extLst>
           </p:cNvPr>
@@ -1209,7 +1209,7 @@
           <a:bodyPr/>
           <a:lstStyle/>
           <a:p>
-            <a:fld id="{B1FC2AA8-E6FD-4FF5-BC96-8248C53506A3}" type="slidenum">
+            <a:fld id="{F53C86CB-7EC3-4464-9F44-14EE0647213E}" type="slidenum">
               <a:rPr lang="pt-PT" smtClean="0"/>
               <a:t>‹nº›</a:t>
             </a:fld>
@@ -1220,7 +1220,7 @@
     </p:spTree>
     <p:extLst>
       <p:ext uri="{BB962C8B-B14F-4D97-AF65-F5344CB8AC3E}">
-        <p14:creationId xmlns:p14="http://schemas.microsoft.com/office/powerpoint/2010/main" val="1222320195"/>
+        <p14:creationId xmlns:p14="http://schemas.microsoft.com/office/powerpoint/2010/main" val="699860757"/>
       </p:ext>
     </p:extLst>
   </p:cSld>
@@ -1252,7 +1252,7 @@
           <p:cNvPr id="2" name="Título 1">
             <a:extLst>
               <a:ext uri="{FF2B5EF4-FFF2-40B4-BE49-F238E27FC236}">
-                <a16:creationId xmlns:a16="http://schemas.microsoft.com/office/drawing/2014/main" id="{ADA01812-E9A2-3AA9-07B2-637215BB3CC9}"/>
+                <a16:creationId xmlns:a16="http://schemas.microsoft.com/office/drawing/2014/main" id="{A78818BF-2CC3-92AE-87F6-27C469E85411}"/>
               </a:ext>
             </a:extLst>
           </p:cNvPr>
@@ -1280,7 +1280,7 @@
           <p:cNvPr id="3" name="Marcador de Posição de Conteúdo 2">
             <a:extLst>
               <a:ext uri="{FF2B5EF4-FFF2-40B4-BE49-F238E27FC236}">
-                <a16:creationId xmlns:a16="http://schemas.microsoft.com/office/drawing/2014/main" id="{A5591766-5BED-FC32-C6B7-923509818409}"/>
+                <a16:creationId xmlns:a16="http://schemas.microsoft.com/office/drawing/2014/main" id="{833E0565-DE6C-E6C2-560E-DA2A6A64BCFD}"/>
               </a:ext>
             </a:extLst>
           </p:cNvPr>
@@ -1342,7 +1342,7 @@
           <p:cNvPr id="4" name="Marcador de Posição de Conteúdo 3">
             <a:extLst>
               <a:ext uri="{FF2B5EF4-FFF2-40B4-BE49-F238E27FC236}">
-                <a16:creationId xmlns:a16="http://schemas.microsoft.com/office/drawing/2014/main" id="{1D451047-EB23-9348-4555-0E41A9A829FD}"/>
+                <a16:creationId xmlns:a16="http://schemas.microsoft.com/office/drawing/2014/main" id="{B2A25E04-18BD-8E99-4648-84027AA5666F}"/>
               </a:ext>
             </a:extLst>
           </p:cNvPr>
@@ -1404,7 +1404,7 @@
           <p:cNvPr id="5" name="Marcador de Posição da Data 4">
             <a:extLst>
               <a:ext uri="{FF2B5EF4-FFF2-40B4-BE49-F238E27FC236}">
-                <a16:creationId xmlns:a16="http://schemas.microsoft.com/office/drawing/2014/main" id="{03D40F06-A978-4A0F-2C72-ED2DCD142007}"/>
+                <a16:creationId xmlns:a16="http://schemas.microsoft.com/office/drawing/2014/main" id="{0606F34A-0F06-00B4-60C6-64FDC8A36EAB}"/>
               </a:ext>
             </a:extLst>
           </p:cNvPr>
@@ -1420,9 +1420,9 @@
           <a:bodyPr/>
           <a:lstStyle/>
           <a:p>
-            <a:fld id="{14089DB3-50E1-4287-8A19-3FED6D76FC0D}" type="datetimeFigureOut">
+            <a:fld id="{7BF0C43D-FB6B-47F3-B10D-68B223D2E940}" type="datetimeFigureOut">
               <a:rPr lang="pt-PT" smtClean="0"/>
-              <a:t>06/10/2026</a:t>
+              <a:t>13/10/2026</a:t>
             </a:fld>
             <a:endParaRPr lang="pt-PT"/>
           </a:p>
@@ -1433,7 +1433,7 @@
           <p:cNvPr id="6" name="Marcador de Posição do Rodapé 5">
             <a:extLst>
               <a:ext uri="{FF2B5EF4-FFF2-40B4-BE49-F238E27FC236}">
-                <a16:creationId xmlns:a16="http://schemas.microsoft.com/office/drawing/2014/main" id="{E7FE8AA4-0A07-B953-1161-DDA938902129}"/>
+                <a16:creationId xmlns:a16="http://schemas.microsoft.com/office/drawing/2014/main" id="{22295A64-D8CA-B458-61D1-EEEE117B5064}"/>
               </a:ext>
             </a:extLst>
           </p:cNvPr>
@@ -1458,7 +1458,7 @@
           <p:cNvPr id="7" name="Marcador de Posição do Número do Diapositivo 6">
             <a:extLst>
               <a:ext uri="{FF2B5EF4-FFF2-40B4-BE49-F238E27FC236}">
-                <a16:creationId xmlns:a16="http://schemas.microsoft.com/office/drawing/2014/main" id="{B169D3AE-8DE3-9367-8AAD-753769D1FC11}"/>
+                <a16:creationId xmlns:a16="http://schemas.microsoft.com/office/drawing/2014/main" id="{BAFEB56A-765F-8B14-7C08-265642513635}"/>
               </a:ext>
             </a:extLst>
           </p:cNvPr>
@@ -1474,7 +1474,7 @@
           <a:bodyPr/>
           <a:lstStyle/>
           <a:p>
-            <a:fld id="{B1FC2AA8-E6FD-4FF5-BC96-8248C53506A3}" type="slidenum">
+            <a:fld id="{F53C86CB-7EC3-4464-9F44-14EE0647213E}" type="slidenum">
               <a:rPr lang="pt-PT" smtClean="0"/>
               <a:t>‹nº›</a:t>
             </a:fld>
@@ -1485,7 +1485,7 @@
     </p:spTree>
     <p:extLst>
       <p:ext uri="{BB962C8B-B14F-4D97-AF65-F5344CB8AC3E}">
-        <p14:creationId xmlns:p14="http://schemas.microsoft.com/office/powerpoint/2010/main" val="611995072"/>
+        <p14:creationId xmlns:p14="http://schemas.microsoft.com/office/powerpoint/2010/main" val="1659285008"/>
       </p:ext>
     </p:extLst>
   </p:cSld>
@@ -1517,7 +1517,7 @@
           <p:cNvPr id="2" name="Título 1">
             <a:extLst>
               <a:ext uri="{FF2B5EF4-FFF2-40B4-BE49-F238E27FC236}">
-                <a16:creationId xmlns:a16="http://schemas.microsoft.com/office/drawing/2014/main" id="{2FF7FA43-0361-E6B5-17EA-B7D388D24B2A}"/>
+                <a16:creationId xmlns:a16="http://schemas.microsoft.com/office/drawing/2014/main" id="{89D8622B-BBE4-33FF-39EA-C4037D4C8B5B}"/>
               </a:ext>
             </a:extLst>
           </p:cNvPr>
@@ -1550,7 +1550,7 @@
           <p:cNvPr id="3" name="Marcador de Posição do Texto 2">
             <a:extLst>
               <a:ext uri="{FF2B5EF4-FFF2-40B4-BE49-F238E27FC236}">
-                <a16:creationId xmlns:a16="http://schemas.microsoft.com/office/drawing/2014/main" id="{F7702EB1-2EE0-D354-516D-3BDE5D98F45F}"/>
+                <a16:creationId xmlns:a16="http://schemas.microsoft.com/office/drawing/2014/main" id="{D8BD74CF-33C6-8526-7E33-0EFA12F1482A}"/>
               </a:ext>
             </a:extLst>
           </p:cNvPr>
@@ -1621,7 +1621,7 @@
           <p:cNvPr id="4" name="Marcador de Posição de Conteúdo 3">
             <a:extLst>
               <a:ext uri="{FF2B5EF4-FFF2-40B4-BE49-F238E27FC236}">
-                <a16:creationId xmlns:a16="http://schemas.microsoft.com/office/drawing/2014/main" id="{AB56A7FF-AE3D-86DE-049E-559298C1F038}"/>
+                <a16:creationId xmlns:a16="http://schemas.microsoft.com/office/drawing/2014/main" id="{464112BA-C574-6CF2-736A-1A1A34368317}"/>
               </a:ext>
             </a:extLst>
           </p:cNvPr>
@@ -1683,7 +1683,7 @@
           <p:cNvPr id="5" name="Marcador de Posição do Texto 4">
             <a:extLst>
               <a:ext uri="{FF2B5EF4-FFF2-40B4-BE49-F238E27FC236}">
-                <a16:creationId xmlns:a16="http://schemas.microsoft.com/office/drawing/2014/main" id="{90DE8FBE-10D2-F112-1A49-C7ADD59DDB77}"/>
+                <a16:creationId xmlns:a16="http://schemas.microsoft.com/office/drawing/2014/main" id="{F14CDFC6-264B-9ED2-2C92-A2ABD332137D}"/>
               </a:ext>
             </a:extLst>
           </p:cNvPr>
@@ -1754,7 +1754,7 @@
           <p:cNvPr id="6" name="Marcador de Posição de Conteúdo 5">
             <a:extLst>
               <a:ext uri="{FF2B5EF4-FFF2-40B4-BE49-F238E27FC236}">
-                <a16:creationId xmlns:a16="http://schemas.microsoft.com/office/drawing/2014/main" id="{CB3AC65E-EFCA-8C0D-A979-468152077544}"/>
+                <a16:creationId xmlns:a16="http://schemas.microsoft.com/office/drawing/2014/main" id="{E49A3395-6D20-942B-9AE2-5020FD867ED7}"/>
               </a:ext>
             </a:extLst>
           </p:cNvPr>
@@ -1816,7 +1816,7 @@
           <p:cNvPr id="7" name="Marcador de Posição da Data 6">
             <a:extLst>
               <a:ext uri="{FF2B5EF4-FFF2-40B4-BE49-F238E27FC236}">
-                <a16:creationId xmlns:a16="http://schemas.microsoft.com/office/drawing/2014/main" id="{802E2DD2-CC1D-096B-1232-72602223C258}"/>
+                <a16:creationId xmlns:a16="http://schemas.microsoft.com/office/drawing/2014/main" id="{C7A897DA-4B33-495F-8FAC-0FCEC993FA06}"/>
               </a:ext>
             </a:extLst>
           </p:cNvPr>
@@ -1832,9 +1832,9 @@
           <a:bodyPr/>
           <a:lstStyle/>
           <a:p>
-            <a:fld id="{14089DB3-50E1-4287-8A19-3FED6D76FC0D}" type="datetimeFigureOut">
+            <a:fld id="{7BF0C43D-FB6B-47F3-B10D-68B223D2E940}" type="datetimeFigureOut">
               <a:rPr lang="pt-PT" smtClean="0"/>
-              <a:t>06/10/2026</a:t>
+              <a:t>13/10/2026</a:t>
             </a:fld>
             <a:endParaRPr lang="pt-PT"/>
           </a:p>
@@ -1845,7 +1845,7 @@
           <p:cNvPr id="8" name="Marcador de Posição do Rodapé 7">
             <a:extLst>
               <a:ext uri="{FF2B5EF4-FFF2-40B4-BE49-F238E27FC236}">
-                <a16:creationId xmlns:a16="http://schemas.microsoft.com/office/drawing/2014/main" id="{AFF6D48C-6149-53A6-2966-E3D35400C918}"/>
+                <a16:creationId xmlns:a16="http://schemas.microsoft.com/office/drawing/2014/main" id="{4D0561EF-9DC9-5B78-7940-50398472F006}"/>
               </a:ext>
             </a:extLst>
           </p:cNvPr>
@@ -1870,7 +1870,7 @@
           <p:cNvPr id="9" name="Marcador de Posição do Número do Diapositivo 8">
             <a:extLst>
               <a:ext uri="{FF2B5EF4-FFF2-40B4-BE49-F238E27FC236}">
-                <a16:creationId xmlns:a16="http://schemas.microsoft.com/office/drawing/2014/main" id="{450045C6-7DE2-54C0-2612-7F1CAD6BA23B}"/>
+                <a16:creationId xmlns:a16="http://schemas.microsoft.com/office/drawing/2014/main" id="{14F282A3-A6CC-0EB4-8027-5211B600AFDC}"/>
               </a:ext>
             </a:extLst>
           </p:cNvPr>
@@ -1886,7 +1886,7 @@
           <a:bodyPr/>
           <a:lstStyle/>
           <a:p>
-            <a:fld id="{B1FC2AA8-E6FD-4FF5-BC96-8248C53506A3}" type="slidenum">
+            <a:fld id="{F53C86CB-7EC3-4464-9F44-14EE0647213E}" type="slidenum">
               <a:rPr lang="pt-PT" smtClean="0"/>
               <a:t>‹nº›</a:t>
             </a:fld>
@@ -1897,7 +1897,7 @@
     </p:spTree>
     <p:extLst>
       <p:ext uri="{BB962C8B-B14F-4D97-AF65-F5344CB8AC3E}">
-        <p14:creationId xmlns:p14="http://schemas.microsoft.com/office/powerpoint/2010/main" val="1167815433"/>
+        <p14:creationId xmlns:p14="http://schemas.microsoft.com/office/powerpoint/2010/main" val="885336113"/>
       </p:ext>
     </p:extLst>
   </p:cSld>
@@ -1929,7 +1929,7 @@
           <p:cNvPr id="2" name="Título 1">
             <a:extLst>
               <a:ext uri="{FF2B5EF4-FFF2-40B4-BE49-F238E27FC236}">
-                <a16:creationId xmlns:a16="http://schemas.microsoft.com/office/drawing/2014/main" id="{3AEB821B-291C-BAAD-E90F-3CC17EE9F2C6}"/>
+                <a16:creationId xmlns:a16="http://schemas.microsoft.com/office/drawing/2014/main" id="{D3235F95-D9CB-2499-AF15-EDF984A17568}"/>
               </a:ext>
             </a:extLst>
           </p:cNvPr>
@@ -1957,7 +1957,7 @@
           <p:cNvPr id="3" name="Marcador de Posição da Data 2">
             <a:extLst>
               <a:ext uri="{FF2B5EF4-FFF2-40B4-BE49-F238E27FC236}">
-                <a16:creationId xmlns:a16="http://schemas.microsoft.com/office/drawing/2014/main" id="{B00AF941-D85F-BDD2-0716-32BAB23DA8BD}"/>
+                <a16:creationId xmlns:a16="http://schemas.microsoft.com/office/drawing/2014/main" id="{D4E34EA8-12D8-481B-3670-7740AE6AF696}"/>
               </a:ext>
             </a:extLst>
           </p:cNvPr>
@@ -1973,9 +1973,9 @@
           <a:bodyPr/>
           <a:lstStyle/>
           <a:p>
-            <a:fld id="{14089DB3-50E1-4287-8A19-3FED6D76FC0D}" type="datetimeFigureOut">
+            <a:fld id="{7BF0C43D-FB6B-47F3-B10D-68B223D2E940}" type="datetimeFigureOut">
               <a:rPr lang="pt-PT" smtClean="0"/>
-              <a:t>06/10/2026</a:t>
+              <a:t>13/10/2026</a:t>
             </a:fld>
             <a:endParaRPr lang="pt-PT"/>
           </a:p>
@@ -1986,7 +1986,7 @@
           <p:cNvPr id="4" name="Marcador de Posição do Rodapé 3">
             <a:extLst>
               <a:ext uri="{FF2B5EF4-FFF2-40B4-BE49-F238E27FC236}">
-                <a16:creationId xmlns:a16="http://schemas.microsoft.com/office/drawing/2014/main" id="{3CD89380-E09C-CF32-C249-440D1C0E80D3}"/>
+                <a16:creationId xmlns:a16="http://schemas.microsoft.com/office/drawing/2014/main" id="{45D8D07A-05CE-523B-5A8E-792620BFAFDE}"/>
               </a:ext>
             </a:extLst>
           </p:cNvPr>
@@ -2011,7 +2011,7 @@
           <p:cNvPr id="5" name="Marcador de Posição do Número do Diapositivo 4">
             <a:extLst>
               <a:ext uri="{FF2B5EF4-FFF2-40B4-BE49-F238E27FC236}">
-                <a16:creationId xmlns:a16="http://schemas.microsoft.com/office/drawing/2014/main" id="{BA884DC7-58C5-5E9D-77BE-3F3CB9DD0F4B}"/>
+                <a16:creationId xmlns:a16="http://schemas.microsoft.com/office/drawing/2014/main" id="{3299576E-21B2-71FB-EAE2-EF983A485DDD}"/>
               </a:ext>
             </a:extLst>
           </p:cNvPr>
@@ -2027,7 +2027,7 @@
           <a:bodyPr/>
           <a:lstStyle/>
           <a:p>
-            <a:fld id="{B1FC2AA8-E6FD-4FF5-BC96-8248C53506A3}" type="slidenum">
+            <a:fld id="{F53C86CB-7EC3-4464-9F44-14EE0647213E}" type="slidenum">
               <a:rPr lang="pt-PT" smtClean="0"/>
               <a:t>‹nº›</a:t>
             </a:fld>
@@ -2038,7 +2038,7 @@
     </p:spTree>
     <p:extLst>
       <p:ext uri="{BB962C8B-B14F-4D97-AF65-F5344CB8AC3E}">
-        <p14:creationId xmlns:p14="http://schemas.microsoft.com/office/powerpoint/2010/main" val="825554462"/>
+        <p14:creationId xmlns:p14="http://schemas.microsoft.com/office/powerpoint/2010/main" val="3609941610"/>
       </p:ext>
     </p:extLst>
   </p:cSld>
@@ -2070,7 +2070,7 @@
           <p:cNvPr id="2" name="Marcador de Posição da Data 1">
             <a:extLst>
               <a:ext uri="{FF2B5EF4-FFF2-40B4-BE49-F238E27FC236}">
-                <a16:creationId xmlns:a16="http://schemas.microsoft.com/office/drawing/2014/main" id="{CE7B98DE-3CA0-D9BF-B8E7-D6894A784A74}"/>
+                <a16:creationId xmlns:a16="http://schemas.microsoft.com/office/drawing/2014/main" id="{4289D699-0D0D-2727-9759-948E03C6F091}"/>
               </a:ext>
             </a:extLst>
           </p:cNvPr>
@@ -2086,9 +2086,9 @@
           <a:bodyPr/>
           <a:lstStyle/>
           <a:p>
-            <a:fld id="{14089DB3-50E1-4287-8A19-3FED6D76FC0D}" type="datetimeFigureOut">
+            <a:fld id="{7BF0C43D-FB6B-47F3-B10D-68B223D2E940}" type="datetimeFigureOut">
               <a:rPr lang="pt-PT" smtClean="0"/>
-              <a:t>06/10/2026</a:t>
+              <a:t>13/10/2026</a:t>
             </a:fld>
             <a:endParaRPr lang="pt-PT"/>
           </a:p>
@@ -2099,7 +2099,7 @@
           <p:cNvPr id="3" name="Marcador de Posição do Rodapé 2">
             <a:extLst>
               <a:ext uri="{FF2B5EF4-FFF2-40B4-BE49-F238E27FC236}">
-                <a16:creationId xmlns:a16="http://schemas.microsoft.com/office/drawing/2014/main" id="{15F2C9A1-6D77-666C-6EE9-209AE6CB5852}"/>
+                <a16:creationId xmlns:a16="http://schemas.microsoft.com/office/drawing/2014/main" id="{57C11762-1843-AF10-EC47-C7632BDA5FC9}"/>
               </a:ext>
             </a:extLst>
           </p:cNvPr>
@@ -2124,7 +2124,7 @@
           <p:cNvPr id="4" name="Marcador de Posição do Número do Diapositivo 3">
             <a:extLst>
               <a:ext uri="{FF2B5EF4-FFF2-40B4-BE49-F238E27FC236}">
-                <a16:creationId xmlns:a16="http://schemas.microsoft.com/office/drawing/2014/main" id="{5CC31CB4-C97F-F73B-8954-4E0C146840C3}"/>
+                <a16:creationId xmlns:a16="http://schemas.microsoft.com/office/drawing/2014/main" id="{AC49E59C-2D81-A90B-E4FB-D9356C92C45F}"/>
               </a:ext>
             </a:extLst>
           </p:cNvPr>
@@ -2140,7 +2140,7 @@
           <a:bodyPr/>
           <a:lstStyle/>
           <a:p>
-            <a:fld id="{B1FC2AA8-E6FD-4FF5-BC96-8248C53506A3}" type="slidenum">
+            <a:fld id="{F53C86CB-7EC3-4464-9F44-14EE0647213E}" type="slidenum">
               <a:rPr lang="pt-PT" smtClean="0"/>
               <a:t>‹nº›</a:t>
             </a:fld>
@@ -2151,7 +2151,7 @@
     </p:spTree>
     <p:extLst>
       <p:ext uri="{BB962C8B-B14F-4D97-AF65-F5344CB8AC3E}">
-        <p14:creationId xmlns:p14="http://schemas.microsoft.com/office/powerpoint/2010/main" val="2258835659"/>
+        <p14:creationId xmlns:p14="http://schemas.microsoft.com/office/powerpoint/2010/main" val="1544534316"/>
       </p:ext>
     </p:extLst>
   </p:cSld>
@@ -2183,7 +2183,7 @@
           <p:cNvPr id="2" name="Título 1">
             <a:extLst>
               <a:ext uri="{FF2B5EF4-FFF2-40B4-BE49-F238E27FC236}">
-                <a16:creationId xmlns:a16="http://schemas.microsoft.com/office/drawing/2014/main" id="{F9FC6808-6E62-6115-796C-4DB7967AD937}"/>
+                <a16:creationId xmlns:a16="http://schemas.microsoft.com/office/drawing/2014/main" id="{66C37954-53CC-1C11-AB26-463AB04A77D9}"/>
               </a:ext>
             </a:extLst>
           </p:cNvPr>
@@ -2220,7 +2220,7 @@
           <p:cNvPr id="3" name="Marcador de Posição de Conteúdo 2">
             <a:extLst>
               <a:ext uri="{FF2B5EF4-FFF2-40B4-BE49-F238E27FC236}">
-                <a16:creationId xmlns:a16="http://schemas.microsoft.com/office/drawing/2014/main" id="{0A44AD81-2DD9-1521-2E42-16C0300D5751}"/>
+                <a16:creationId xmlns:a16="http://schemas.microsoft.com/office/drawing/2014/main" id="{C6C44884-26BE-0810-3FE0-7CFAD63531D6}"/>
               </a:ext>
             </a:extLst>
           </p:cNvPr>
@@ -2310,7 +2310,7 @@
           <p:cNvPr id="4" name="Marcador de Posição do Texto 3">
             <a:extLst>
               <a:ext uri="{FF2B5EF4-FFF2-40B4-BE49-F238E27FC236}">
-                <a16:creationId xmlns:a16="http://schemas.microsoft.com/office/drawing/2014/main" id="{15674D6A-3918-C8D5-FEEB-D23EFF5F6269}"/>
+                <a16:creationId xmlns:a16="http://schemas.microsoft.com/office/drawing/2014/main" id="{B7C8FC65-91E9-D147-A128-67562B6B88AA}"/>
               </a:ext>
             </a:extLst>
           </p:cNvPr>
@@ -2381,7 +2381,7 @@
           <p:cNvPr id="5" name="Marcador de Posição da Data 4">
             <a:extLst>
               <a:ext uri="{FF2B5EF4-FFF2-40B4-BE49-F238E27FC236}">
-                <a16:creationId xmlns:a16="http://schemas.microsoft.com/office/drawing/2014/main" id="{B11E93AC-5279-1363-0774-13E05BC7064E}"/>
+                <a16:creationId xmlns:a16="http://schemas.microsoft.com/office/drawing/2014/main" id="{24133730-9904-25A2-862A-F10ED018DD65}"/>
               </a:ext>
             </a:extLst>
           </p:cNvPr>
@@ -2397,9 +2397,9 @@
           <a:bodyPr/>
           <a:lstStyle/>
           <a:p>
-            <a:fld id="{14089DB3-50E1-4287-8A19-3FED6D76FC0D}" type="datetimeFigureOut">
+            <a:fld id="{7BF0C43D-FB6B-47F3-B10D-68B223D2E940}" type="datetimeFigureOut">
               <a:rPr lang="pt-PT" smtClean="0"/>
-              <a:t>06/10/2026</a:t>
+              <a:t>13/10/2026</a:t>
             </a:fld>
             <a:endParaRPr lang="pt-PT"/>
           </a:p>
@@ -2410,7 +2410,7 @@
           <p:cNvPr id="6" name="Marcador de Posição do Rodapé 5">
             <a:extLst>
               <a:ext uri="{FF2B5EF4-FFF2-40B4-BE49-F238E27FC236}">
-                <a16:creationId xmlns:a16="http://schemas.microsoft.com/office/drawing/2014/main" id="{CCD998BC-BDEE-051A-A032-878E83CD3D2C}"/>
+                <a16:creationId xmlns:a16="http://schemas.microsoft.com/office/drawing/2014/main" id="{83C36694-7F5B-1218-7651-8C1351519BAB}"/>
               </a:ext>
             </a:extLst>
           </p:cNvPr>
@@ -2435,7 +2435,7 @@
           <p:cNvPr id="7" name="Marcador de Posição do Número do Diapositivo 6">
             <a:extLst>
               <a:ext uri="{FF2B5EF4-FFF2-40B4-BE49-F238E27FC236}">
-                <a16:creationId xmlns:a16="http://schemas.microsoft.com/office/drawing/2014/main" id="{FF5D8B4B-EFCB-9160-66EF-9CAC2C450281}"/>
+                <a16:creationId xmlns:a16="http://schemas.microsoft.com/office/drawing/2014/main" id="{7C4BBF5E-0DF2-CD8D-ED82-585528766BCD}"/>
               </a:ext>
             </a:extLst>
           </p:cNvPr>
@@ -2451,7 +2451,7 @@
           <a:bodyPr/>
           <a:lstStyle/>
           <a:p>
-            <a:fld id="{B1FC2AA8-E6FD-4FF5-BC96-8248C53506A3}" type="slidenum">
+            <a:fld id="{F53C86CB-7EC3-4464-9F44-14EE0647213E}" type="slidenum">
               <a:rPr lang="pt-PT" smtClean="0"/>
               <a:t>‹nº›</a:t>
             </a:fld>
@@ -2462,7 +2462,7 @@
     </p:spTree>
     <p:extLst>
       <p:ext uri="{BB962C8B-B14F-4D97-AF65-F5344CB8AC3E}">
-        <p14:creationId xmlns:p14="http://schemas.microsoft.com/office/powerpoint/2010/main" val="1212886157"/>
+        <p14:creationId xmlns:p14="http://schemas.microsoft.com/office/powerpoint/2010/main" val="1883690956"/>
       </p:ext>
     </p:extLst>
   </p:cSld>
@@ -2494,7 +2494,7 @@
           <p:cNvPr id="2" name="Título 1">
             <a:extLst>
               <a:ext uri="{FF2B5EF4-FFF2-40B4-BE49-F238E27FC236}">
-                <a16:creationId xmlns:a16="http://schemas.microsoft.com/office/drawing/2014/main" id="{38742E5F-0FA0-6B89-6961-FA39B710CA07}"/>
+                <a16:creationId xmlns:a16="http://schemas.microsoft.com/office/drawing/2014/main" id="{BF073E56-5202-AFE9-0894-9ABAF5D8CE0F}"/>
               </a:ext>
             </a:extLst>
           </p:cNvPr>
@@ -2531,7 +2531,7 @@
           <p:cNvPr id="3" name="Marcador de Posição da Imagem 2">
             <a:extLst>
               <a:ext uri="{FF2B5EF4-FFF2-40B4-BE49-F238E27FC236}">
-                <a16:creationId xmlns:a16="http://schemas.microsoft.com/office/drawing/2014/main" id="{C98D2670-5194-742D-6B0B-65584C40BDD1}"/>
+                <a16:creationId xmlns:a16="http://schemas.microsoft.com/office/drawing/2014/main" id="{DB6AC2F9-9553-8C18-6B07-A85FC6B220CC}"/>
               </a:ext>
             </a:extLst>
           </p:cNvPr>
@@ -2598,7 +2598,7 @@
           <p:cNvPr id="4" name="Marcador de Posição do Texto 3">
             <a:extLst>
               <a:ext uri="{FF2B5EF4-FFF2-40B4-BE49-F238E27FC236}">
-                <a16:creationId xmlns:a16="http://schemas.microsoft.com/office/drawing/2014/main" id="{DAFE6E1C-EC59-E22B-997F-25C25665DEF5}"/>
+                <a16:creationId xmlns:a16="http://schemas.microsoft.com/office/drawing/2014/main" id="{D4C7EF99-64A6-5ADB-8479-C51C597395FF}"/>
               </a:ext>
             </a:extLst>
           </p:cNvPr>
@@ -2669,7 +2669,7 @@
           <p:cNvPr id="5" name="Marcador de Posição da Data 4">
             <a:extLst>
               <a:ext uri="{FF2B5EF4-FFF2-40B4-BE49-F238E27FC236}">
-                <a16:creationId xmlns:a16="http://schemas.microsoft.com/office/drawing/2014/main" id="{06CB4F5C-5609-5E7A-700C-135560094934}"/>
+                <a16:creationId xmlns:a16="http://schemas.microsoft.com/office/drawing/2014/main" id="{859B3A36-A690-E1EC-7455-71245EC0B3A5}"/>
               </a:ext>
             </a:extLst>
           </p:cNvPr>
@@ -2685,9 +2685,9 @@
           <a:bodyPr/>
           <a:lstStyle/>
           <a:p>
-            <a:fld id="{14089DB3-50E1-4287-8A19-3FED6D76FC0D}" type="datetimeFigureOut">
+            <a:fld id="{7BF0C43D-FB6B-47F3-B10D-68B223D2E940}" type="datetimeFigureOut">
               <a:rPr lang="pt-PT" smtClean="0"/>
-              <a:t>06/10/2026</a:t>
+              <a:t>13/10/2026</a:t>
             </a:fld>
             <a:endParaRPr lang="pt-PT"/>
           </a:p>
@@ -2698,7 +2698,7 @@
           <p:cNvPr id="6" name="Marcador de Posição do Rodapé 5">
             <a:extLst>
               <a:ext uri="{FF2B5EF4-FFF2-40B4-BE49-F238E27FC236}">
-                <a16:creationId xmlns:a16="http://schemas.microsoft.com/office/drawing/2014/main" id="{D41CDF0F-054B-AC79-15DB-BB05F83BAEAF}"/>
+                <a16:creationId xmlns:a16="http://schemas.microsoft.com/office/drawing/2014/main" id="{D73D7BD8-E3CE-878B-160C-448EBE2AACFA}"/>
               </a:ext>
             </a:extLst>
           </p:cNvPr>
@@ -2723,7 +2723,7 @@
           <p:cNvPr id="7" name="Marcador de Posição do Número do Diapositivo 6">
             <a:extLst>
               <a:ext uri="{FF2B5EF4-FFF2-40B4-BE49-F238E27FC236}">
-                <a16:creationId xmlns:a16="http://schemas.microsoft.com/office/drawing/2014/main" id="{60E79E0E-2F6E-68D5-DFC0-AEE3F961EB21}"/>
+                <a16:creationId xmlns:a16="http://schemas.microsoft.com/office/drawing/2014/main" id="{26DB3241-D486-2E16-8E03-F646C4CE796C}"/>
               </a:ext>
             </a:extLst>
           </p:cNvPr>
@@ -2739,7 +2739,7 @@
           <a:bodyPr/>
           <a:lstStyle/>
           <a:p>
-            <a:fld id="{B1FC2AA8-E6FD-4FF5-BC96-8248C53506A3}" type="slidenum">
+            <a:fld id="{F53C86CB-7EC3-4464-9F44-14EE0647213E}" type="slidenum">
               <a:rPr lang="pt-PT" smtClean="0"/>
               <a:t>‹nº›</a:t>
             </a:fld>
@@ -2750,7 +2750,7 @@
     </p:spTree>
     <p:extLst>
       <p:ext uri="{BB962C8B-B14F-4D97-AF65-F5344CB8AC3E}">
-        <p14:creationId xmlns:p14="http://schemas.microsoft.com/office/powerpoint/2010/main" val="2079467375"/>
+        <p14:creationId xmlns:p14="http://schemas.microsoft.com/office/powerpoint/2010/main" val="1416607134"/>
       </p:ext>
     </p:extLst>
   </p:cSld>
@@ -2787,7 +2787,7 @@
           <p:cNvPr id="2" name="Marcador de Posição do Título 1">
             <a:extLst>
               <a:ext uri="{FF2B5EF4-FFF2-40B4-BE49-F238E27FC236}">
-                <a16:creationId xmlns:a16="http://schemas.microsoft.com/office/drawing/2014/main" id="{62CB4637-A67A-B53D-4D78-38BB1C9625B8}"/>
+                <a16:creationId xmlns:a16="http://schemas.microsoft.com/office/drawing/2014/main" id="{F093B805-28E8-D8DB-3A6A-2E95A161C007}"/>
               </a:ext>
             </a:extLst>
           </p:cNvPr>
@@ -2825,7 +2825,7 @@
           <p:cNvPr id="3" name="Marcador de Posição do Texto 2">
             <a:extLst>
               <a:ext uri="{FF2B5EF4-FFF2-40B4-BE49-F238E27FC236}">
-                <a16:creationId xmlns:a16="http://schemas.microsoft.com/office/drawing/2014/main" id="{67A4334F-61CF-74CF-540D-239A13190838}"/>
+                <a16:creationId xmlns:a16="http://schemas.microsoft.com/office/drawing/2014/main" id="{5D90EE95-AE3D-32C5-B601-9FF387E50D89}"/>
               </a:ext>
             </a:extLst>
           </p:cNvPr>
@@ -2892,7 +2892,7 @@
           <p:cNvPr id="4" name="Marcador de Posição da Data 3">
             <a:extLst>
               <a:ext uri="{FF2B5EF4-FFF2-40B4-BE49-F238E27FC236}">
-                <a16:creationId xmlns:a16="http://schemas.microsoft.com/office/drawing/2014/main" id="{7DCBEDDB-12F2-A4DB-20F2-A77491458ED0}"/>
+                <a16:creationId xmlns:a16="http://schemas.microsoft.com/office/drawing/2014/main" id="{014A3658-0147-A87B-BF15-93B91463F94D}"/>
               </a:ext>
             </a:extLst>
           </p:cNvPr>
@@ -2926,9 +2926,9 @@
             </a:lvl1pPr>
           </a:lstStyle>
           <a:p>
-            <a:fld id="{14089DB3-50E1-4287-8A19-3FED6D76FC0D}" type="datetimeFigureOut">
+            <a:fld id="{7BF0C43D-FB6B-47F3-B10D-68B223D2E940}" type="datetimeFigureOut">
               <a:rPr lang="pt-PT" smtClean="0"/>
-              <a:t>06/10/2026</a:t>
+              <a:t>13/10/2026</a:t>
             </a:fld>
             <a:endParaRPr lang="pt-PT"/>
           </a:p>
@@ -2939,7 +2939,7 @@
           <p:cNvPr id="5" name="Marcador de Posição do Rodapé 4">
             <a:extLst>
               <a:ext uri="{FF2B5EF4-FFF2-40B4-BE49-F238E27FC236}">
-                <a16:creationId xmlns:a16="http://schemas.microsoft.com/office/drawing/2014/main" id="{50E92BA3-4406-8FA6-B694-9554BD6613DA}"/>
+                <a16:creationId xmlns:a16="http://schemas.microsoft.com/office/drawing/2014/main" id="{0F5EB94B-FAF4-E8CE-B6F8-F92897666DFF}"/>
               </a:ext>
             </a:extLst>
           </p:cNvPr>
@@ -2982,7 +2982,7 @@
           <p:cNvPr id="6" name="Marcador de Posição do Número do Diapositivo 5">
             <a:extLst>
               <a:ext uri="{FF2B5EF4-FFF2-40B4-BE49-F238E27FC236}">
-                <a16:creationId xmlns:a16="http://schemas.microsoft.com/office/drawing/2014/main" id="{20269ECF-72FA-D2DB-CB07-7A216F7DBD9A}"/>
+                <a16:creationId xmlns:a16="http://schemas.microsoft.com/office/drawing/2014/main" id="{60B11340-6BEC-11AE-55A2-76DE8A6B7ACA}"/>
               </a:ext>
             </a:extLst>
           </p:cNvPr>
@@ -3016,7 +3016,7 @@
             </a:lvl1pPr>
           </a:lstStyle>
           <a:p>
-            <a:fld id="{B1FC2AA8-E6FD-4FF5-BC96-8248C53506A3}" type="slidenum">
+            <a:fld id="{F53C86CB-7EC3-4464-9F44-14EE0647213E}" type="slidenum">
               <a:rPr lang="pt-PT" smtClean="0"/>
               <a:t>‹nº›</a:t>
             </a:fld>
@@ -3027,7 +3027,7 @@
     </p:spTree>
     <p:extLst>
       <p:ext uri="{BB962C8B-B14F-4D97-AF65-F5344CB8AC3E}">
-        <p14:creationId xmlns:p14="http://schemas.microsoft.com/office/powerpoint/2010/main" val="3763803939"/>
+        <p14:creationId xmlns:p14="http://schemas.microsoft.com/office/powerpoint/2010/main" val="411662818"/>
       </p:ext>
     </p:extLst>
   </p:cSld>
@@ -3369,7 +3369,7 @@
           <p:cNvPr id="2" name="CaixaDeTexto 1">
             <a:extLst>
               <a:ext uri="{FF2B5EF4-FFF2-40B4-BE49-F238E27FC236}">
-                <a16:creationId xmlns:a16="http://schemas.microsoft.com/office/drawing/2014/main" id="{0C6349E7-9308-3FC8-9A55-B1B3F439B0FD}"/>
+                <a16:creationId xmlns:a16="http://schemas.microsoft.com/office/drawing/2014/main" id="{47DA6713-6500-687D-9828-D65EBCAE71F3}"/>
               </a:ext>
             </a:extLst>
           </p:cNvPr>
@@ -3410,7 +3410,7 @@
           <p:cNvPr id="3" name="Retângulo 2">
             <a:extLst>
               <a:ext uri="{FF2B5EF4-FFF2-40B4-BE49-F238E27FC236}">
-                <a16:creationId xmlns:a16="http://schemas.microsoft.com/office/drawing/2014/main" id="{25D50B94-088E-89F1-831F-94A36AC6CA5A}"/>
+                <a16:creationId xmlns:a16="http://schemas.microsoft.com/office/drawing/2014/main" id="{D0BD4A9C-8053-2470-BE5B-0728057E6A16}"/>
               </a:ext>
             </a:extLst>
           </p:cNvPr>
@@ -3478,7 +3478,7 @@
           <p:cNvPr id="4" name="CaixaDeTexto 3">
             <a:extLst>
               <a:ext uri="{FF2B5EF4-FFF2-40B4-BE49-F238E27FC236}">
-                <a16:creationId xmlns:a16="http://schemas.microsoft.com/office/drawing/2014/main" id="{20FC7BBA-7005-8E40-A8D1-14B60AE1EFB4}"/>
+                <a16:creationId xmlns:a16="http://schemas.microsoft.com/office/drawing/2014/main" id="{32E6E6AD-B138-81D0-6A9D-014389B6245E}"/>
               </a:ext>
             </a:extLst>
           </p:cNvPr>
@@ -3519,7 +3519,7 @@
           <p:cNvPr id="5" name="CaixaDeTexto 4">
             <a:extLst>
               <a:ext uri="{FF2B5EF4-FFF2-40B4-BE49-F238E27FC236}">
-                <a16:creationId xmlns:a16="http://schemas.microsoft.com/office/drawing/2014/main" id="{58B066A8-E0E0-1005-232B-10686A85F334}"/>
+                <a16:creationId xmlns:a16="http://schemas.microsoft.com/office/drawing/2014/main" id="{6EDFB3B0-67B6-1607-AEE5-27E22E1D758D}"/>
               </a:ext>
             </a:extLst>
           </p:cNvPr>
@@ -3560,7 +3560,7 @@
           <p:cNvPr id="6" name="Retângulo 5">
             <a:extLst>
               <a:ext uri="{FF2B5EF4-FFF2-40B4-BE49-F238E27FC236}">
-                <a16:creationId xmlns:a16="http://schemas.microsoft.com/office/drawing/2014/main" id="{A43C2151-867C-F654-43B9-0F0FEDDCCC86}"/>
+                <a16:creationId xmlns:a16="http://schemas.microsoft.com/office/drawing/2014/main" id="{125F69A2-D12E-8997-C281-DAEFBCDB9D95}"/>
               </a:ext>
             </a:extLst>
           </p:cNvPr>
@@ -3628,7 +3628,7 @@
           <p:cNvPr id="7" name="CaixaDeTexto 6">
             <a:extLst>
               <a:ext uri="{FF2B5EF4-FFF2-40B4-BE49-F238E27FC236}">
-                <a16:creationId xmlns:a16="http://schemas.microsoft.com/office/drawing/2014/main" id="{94A0641D-D7DE-15A8-E266-A22310D76C52}"/>
+                <a16:creationId xmlns:a16="http://schemas.microsoft.com/office/drawing/2014/main" id="{504F054A-1F7F-52FF-54F8-C8C5FCBB38B9}"/>
               </a:ext>
             </a:extLst>
           </p:cNvPr>
@@ -3668,7 +3668,7 @@
           <p:cNvPr id="8" name="CaixaDeTexto 7">
             <a:extLst>
               <a:ext uri="{FF2B5EF4-FFF2-40B4-BE49-F238E27FC236}">
-                <a16:creationId xmlns:a16="http://schemas.microsoft.com/office/drawing/2014/main" id="{07C13188-85DA-34A7-4648-FB8757A909ED}"/>
+                <a16:creationId xmlns:a16="http://schemas.microsoft.com/office/drawing/2014/main" id="{4F1F285A-2627-20DB-F94A-C3675E1C56AD}"/>
               </a:ext>
             </a:extLst>
           </p:cNvPr>
@@ -3707,7 +3707,7 @@
     </p:spTree>
     <p:extLst>
       <p:ext uri="{BB962C8B-B14F-4D97-AF65-F5344CB8AC3E}">
-        <p14:creationId xmlns:p14="http://schemas.microsoft.com/office/powerpoint/2010/main" val="3732310911"/>
+        <p14:creationId xmlns:p14="http://schemas.microsoft.com/office/powerpoint/2010/main" val="271567904"/>
       </p:ext>
     </p:extLst>
   </p:cSld>
@@ -3770,7 +3770,7 @@
           <p:cNvPr id="2" name="CaixaDeTexto 1">
             <a:extLst>
               <a:ext uri="{FF2B5EF4-FFF2-40B4-BE49-F238E27FC236}">
-                <a16:creationId xmlns:a16="http://schemas.microsoft.com/office/drawing/2014/main" id="{AD080A18-AD95-3F92-72B4-1C4903071E89}"/>
+                <a16:creationId xmlns:a16="http://schemas.microsoft.com/office/drawing/2014/main" id="{79B736E3-A91F-A918-2B01-96F9C4EDF966}"/>
               </a:ext>
             </a:extLst>
           </p:cNvPr>
@@ -3810,7 +3810,7 @@
           <p:cNvPr id="3" name="Retângulo 2">
             <a:extLst>
               <a:ext uri="{FF2B5EF4-FFF2-40B4-BE49-F238E27FC236}">
-                <a16:creationId xmlns:a16="http://schemas.microsoft.com/office/drawing/2014/main" id="{D67C58D4-356B-9E25-95A7-E029926B7787}"/>
+                <a16:creationId xmlns:a16="http://schemas.microsoft.com/office/drawing/2014/main" id="{D66D257F-85AE-85C0-2758-A8190501DF67}"/>
               </a:ext>
             </a:extLst>
           </p:cNvPr>
@@ -3878,7 +3878,7 @@
           <p:cNvPr id="4" name="Retângulo 3">
             <a:extLst>
               <a:ext uri="{FF2B5EF4-FFF2-40B4-BE49-F238E27FC236}">
-                <a16:creationId xmlns:a16="http://schemas.microsoft.com/office/drawing/2014/main" id="{A595C603-7912-E3EC-2F9B-291B3C8CDE80}"/>
+                <a16:creationId xmlns:a16="http://schemas.microsoft.com/office/drawing/2014/main" id="{BCFCE02F-8562-4C51-83B2-AE7E701286C9}"/>
               </a:ext>
             </a:extLst>
           </p:cNvPr>
@@ -3946,7 +3946,7 @@
           <p:cNvPr id="5" name="CaixaDeTexto 4">
             <a:extLst>
               <a:ext uri="{FF2B5EF4-FFF2-40B4-BE49-F238E27FC236}">
-                <a16:creationId xmlns:a16="http://schemas.microsoft.com/office/drawing/2014/main" id="{EE29A329-C57B-195F-4013-8AC952296450}"/>
+                <a16:creationId xmlns:a16="http://schemas.microsoft.com/office/drawing/2014/main" id="{39B3A4A6-27C5-FC5D-C5E5-935DBDFE4F39}"/>
               </a:ext>
             </a:extLst>
           </p:cNvPr>
@@ -3986,7 +3986,7 @@
           <p:cNvPr id="6" name="CaixaDeTexto 5">
             <a:extLst>
               <a:ext uri="{FF2B5EF4-FFF2-40B4-BE49-F238E27FC236}">
-                <a16:creationId xmlns:a16="http://schemas.microsoft.com/office/drawing/2014/main" id="{F7B8CA41-4B75-B732-9287-A725D772A767}"/>
+                <a16:creationId xmlns:a16="http://schemas.microsoft.com/office/drawing/2014/main" id="{EC6B731B-81BF-A9D9-5B3F-CC3715B3A2FD}"/>
               </a:ext>
             </a:extLst>
           </p:cNvPr>
@@ -4027,7 +4027,7 @@
           <p:cNvPr id="7" name="CaixaDeTexto 6">
             <a:extLst>
               <a:ext uri="{FF2B5EF4-FFF2-40B4-BE49-F238E27FC236}">
-                <a16:creationId xmlns:a16="http://schemas.microsoft.com/office/drawing/2014/main" id="{1DA3A3E4-2E0B-E4FC-9DFB-E9D7C2A5EAB7}"/>
+                <a16:creationId xmlns:a16="http://schemas.microsoft.com/office/drawing/2014/main" id="{108D1055-7C43-C989-89ED-9EC880CC24C9}"/>
               </a:ext>
             </a:extLst>
           </p:cNvPr>
@@ -4258,7 +4258,7 @@
     </p:spTree>
     <p:extLst>
       <p:ext uri="{BB962C8B-B14F-4D97-AF65-F5344CB8AC3E}">
-        <p14:creationId xmlns:p14="http://schemas.microsoft.com/office/powerpoint/2010/main" val="3171401365"/>
+        <p14:creationId xmlns:p14="http://schemas.microsoft.com/office/powerpoint/2010/main" val="251533985"/>
       </p:ext>
     </p:extLst>
   </p:cSld>
@@ -4321,7 +4321,7 @@
           <p:cNvPr id="2" name="CaixaDeTexto 1">
             <a:extLst>
               <a:ext uri="{FF2B5EF4-FFF2-40B4-BE49-F238E27FC236}">
-                <a16:creationId xmlns:a16="http://schemas.microsoft.com/office/drawing/2014/main" id="{DBAFA6E1-80A0-A0F9-DEA6-A78487DFBE30}"/>
+                <a16:creationId xmlns:a16="http://schemas.microsoft.com/office/drawing/2014/main" id="{DD472D2E-97CC-1940-8010-9575E3CE9294}"/>
               </a:ext>
             </a:extLst>
           </p:cNvPr>
@@ -4361,7 +4361,7 @@
           <p:cNvPr id="3" name="Retângulo 2">
             <a:extLst>
               <a:ext uri="{FF2B5EF4-FFF2-40B4-BE49-F238E27FC236}">
-                <a16:creationId xmlns:a16="http://schemas.microsoft.com/office/drawing/2014/main" id="{BE39A40F-564B-0EF5-9746-29EC5F2AC28C}"/>
+                <a16:creationId xmlns:a16="http://schemas.microsoft.com/office/drawing/2014/main" id="{FB6A5CAF-1227-4634-44D0-4673C1930487}"/>
               </a:ext>
             </a:extLst>
           </p:cNvPr>
@@ -4429,7 +4429,7 @@
           <p:cNvPr id="4" name="Retângulo 3">
             <a:extLst>
               <a:ext uri="{FF2B5EF4-FFF2-40B4-BE49-F238E27FC236}">
-                <a16:creationId xmlns:a16="http://schemas.microsoft.com/office/drawing/2014/main" id="{FD6596E0-B135-DA23-36DE-FAF0867455F6}"/>
+                <a16:creationId xmlns:a16="http://schemas.microsoft.com/office/drawing/2014/main" id="{977CFE08-B3A1-3928-845E-BBA6CE5F310E}"/>
               </a:ext>
             </a:extLst>
           </p:cNvPr>
@@ -4497,7 +4497,7 @@
           <p:cNvPr id="5" name="CaixaDeTexto 4">
             <a:extLst>
               <a:ext uri="{FF2B5EF4-FFF2-40B4-BE49-F238E27FC236}">
-                <a16:creationId xmlns:a16="http://schemas.microsoft.com/office/drawing/2014/main" id="{E14A7121-8B53-69DE-FF9F-D2663939E3D8}"/>
+                <a16:creationId xmlns:a16="http://schemas.microsoft.com/office/drawing/2014/main" id="{7BF7545C-B235-431F-BE40-70B8BB1A644D}"/>
               </a:ext>
             </a:extLst>
           </p:cNvPr>
@@ -4537,7 +4537,7 @@
           <p:cNvPr id="6" name="CaixaDeTexto 5">
             <a:extLst>
               <a:ext uri="{FF2B5EF4-FFF2-40B4-BE49-F238E27FC236}">
-                <a16:creationId xmlns:a16="http://schemas.microsoft.com/office/drawing/2014/main" id="{568ADED1-8BFB-137C-C9E2-AF7DB3BD780F}"/>
+                <a16:creationId xmlns:a16="http://schemas.microsoft.com/office/drawing/2014/main" id="{CB08F671-338A-2E3A-FD38-49232A542480}"/>
               </a:ext>
             </a:extLst>
           </p:cNvPr>
@@ -4578,7 +4578,7 @@
           <p:cNvPr id="7" name="CaixaDeTexto 6">
             <a:extLst>
               <a:ext uri="{FF2B5EF4-FFF2-40B4-BE49-F238E27FC236}">
-                <a16:creationId xmlns:a16="http://schemas.microsoft.com/office/drawing/2014/main" id="{20527889-BB10-5458-F19E-AEDF5327A06C}"/>
+                <a16:creationId xmlns:a16="http://schemas.microsoft.com/office/drawing/2014/main" id="{6FF9D2F0-ADBD-05DB-09A0-6E51A78EB7A2}"/>
               </a:ext>
             </a:extLst>
           </p:cNvPr>
@@ -4791,7 +4791,7 @@
     </p:spTree>
     <p:extLst>
       <p:ext uri="{BB962C8B-B14F-4D97-AF65-F5344CB8AC3E}">
-        <p14:creationId xmlns:p14="http://schemas.microsoft.com/office/powerpoint/2010/main" val="4178318345"/>
+        <p14:creationId xmlns:p14="http://schemas.microsoft.com/office/powerpoint/2010/main" val="3695483678"/>
       </p:ext>
     </p:extLst>
   </p:cSld>
@@ -4854,7 +4854,7 @@
           <p:cNvPr id="2" name="CaixaDeTexto 1">
             <a:extLst>
               <a:ext uri="{FF2B5EF4-FFF2-40B4-BE49-F238E27FC236}">
-                <a16:creationId xmlns:a16="http://schemas.microsoft.com/office/drawing/2014/main" id="{F6C94017-790A-17BB-A0D8-D587797474BE}"/>
+                <a16:creationId xmlns:a16="http://schemas.microsoft.com/office/drawing/2014/main" id="{463E1B42-7278-D204-2913-B20C74E167BB}"/>
               </a:ext>
             </a:extLst>
           </p:cNvPr>
@@ -4894,7 +4894,7 @@
           <p:cNvPr id="3" name="Retângulo 2">
             <a:extLst>
               <a:ext uri="{FF2B5EF4-FFF2-40B4-BE49-F238E27FC236}">
-                <a16:creationId xmlns:a16="http://schemas.microsoft.com/office/drawing/2014/main" id="{D29B16EB-150D-AC6B-D05F-621D762F247C}"/>
+                <a16:creationId xmlns:a16="http://schemas.microsoft.com/office/drawing/2014/main" id="{9EB8BB33-903E-D5F7-80A1-DE81F47D4F2D}"/>
               </a:ext>
             </a:extLst>
           </p:cNvPr>
@@ -4962,7 +4962,7 @@
           <p:cNvPr id="4" name="Retângulo 3">
             <a:extLst>
               <a:ext uri="{FF2B5EF4-FFF2-40B4-BE49-F238E27FC236}">
-                <a16:creationId xmlns:a16="http://schemas.microsoft.com/office/drawing/2014/main" id="{BE85D03D-13DA-2BB9-71D4-C0A4F4E7674B}"/>
+                <a16:creationId xmlns:a16="http://schemas.microsoft.com/office/drawing/2014/main" id="{953F7E58-C209-CE6B-4C6D-5B2781C69486}"/>
               </a:ext>
             </a:extLst>
           </p:cNvPr>
@@ -5030,7 +5030,7 @@
           <p:cNvPr id="5" name="CaixaDeTexto 4">
             <a:extLst>
               <a:ext uri="{FF2B5EF4-FFF2-40B4-BE49-F238E27FC236}">
-                <a16:creationId xmlns:a16="http://schemas.microsoft.com/office/drawing/2014/main" id="{47759C8B-B477-564D-80E1-F762DCA58F25}"/>
+                <a16:creationId xmlns:a16="http://schemas.microsoft.com/office/drawing/2014/main" id="{3E62623E-8E0B-2F6B-915F-CE62ED628A80}"/>
               </a:ext>
             </a:extLst>
           </p:cNvPr>
@@ -5070,7 +5070,7 @@
           <p:cNvPr id="6" name="CaixaDeTexto 5">
             <a:extLst>
               <a:ext uri="{FF2B5EF4-FFF2-40B4-BE49-F238E27FC236}">
-                <a16:creationId xmlns:a16="http://schemas.microsoft.com/office/drawing/2014/main" id="{46417B10-5DFF-5DE8-22C0-FCD7C43A5E33}"/>
+                <a16:creationId xmlns:a16="http://schemas.microsoft.com/office/drawing/2014/main" id="{0E33E7B7-DE0F-5C17-1481-892F447BB4D9}"/>
               </a:ext>
             </a:extLst>
           </p:cNvPr>
@@ -5111,7 +5111,7 @@
           <p:cNvPr id="7" name="Retângulo: Cantos Arredondados 6">
             <a:extLst>
               <a:ext uri="{FF2B5EF4-FFF2-40B4-BE49-F238E27FC236}">
-                <a16:creationId xmlns:a16="http://schemas.microsoft.com/office/drawing/2014/main" id="{6FC338B3-D1AB-D92C-4436-4385C367FE7A}"/>
+                <a16:creationId xmlns:a16="http://schemas.microsoft.com/office/drawing/2014/main" id="{30244FA2-62CC-3513-9552-0BCCC6CD6618}"/>
               </a:ext>
             </a:extLst>
           </p:cNvPr>
@@ -5165,7 +5165,7 @@
           <p:cNvPr id="8" name="CaixaDeTexto 7">
             <a:extLst>
               <a:ext uri="{FF2B5EF4-FFF2-40B4-BE49-F238E27FC236}">
-                <a16:creationId xmlns:a16="http://schemas.microsoft.com/office/drawing/2014/main" id="{F848B0BE-6217-65F3-FA2A-D5BFBE97EED4}"/>
+                <a16:creationId xmlns:a16="http://schemas.microsoft.com/office/drawing/2014/main" id="{2001092A-EA19-EBF3-C4C5-67B3740DFF81}"/>
               </a:ext>
             </a:extLst>
           </p:cNvPr>
@@ -5205,7 +5205,7 @@
           <p:cNvPr id="9" name="CaixaDeTexto 8">
             <a:extLst>
               <a:ext uri="{FF2B5EF4-FFF2-40B4-BE49-F238E27FC236}">
-                <a16:creationId xmlns:a16="http://schemas.microsoft.com/office/drawing/2014/main" id="{7582110B-B350-EEEC-D4B3-D143CE3CA705}"/>
+                <a16:creationId xmlns:a16="http://schemas.microsoft.com/office/drawing/2014/main" id="{E9CAC4EB-C039-DC11-AD5F-C77604C812F8}"/>
               </a:ext>
             </a:extLst>
           </p:cNvPr>
@@ -5298,7 +5298,7 @@
           <p:cNvPr id="10" name="CaixaDeTexto 9">
             <a:extLst>
               <a:ext uri="{FF2B5EF4-FFF2-40B4-BE49-F238E27FC236}">
-                <a16:creationId xmlns:a16="http://schemas.microsoft.com/office/drawing/2014/main" id="{B2A9B779-4268-464C-5BFD-79FF4DF1352B}"/>
+                <a16:creationId xmlns:a16="http://schemas.microsoft.com/office/drawing/2014/main" id="{8F22D494-A51F-23A1-EA11-3C27A8A0EAC6}"/>
               </a:ext>
             </a:extLst>
           </p:cNvPr>
@@ -5338,7 +5338,7 @@
           <p:cNvPr id="11" name="Retângulo: Cantos Arredondados 10">
             <a:extLst>
               <a:ext uri="{FF2B5EF4-FFF2-40B4-BE49-F238E27FC236}">
-                <a16:creationId xmlns:a16="http://schemas.microsoft.com/office/drawing/2014/main" id="{183E5BEA-1C22-899B-E6DB-7B26C9FB2FE0}"/>
+                <a16:creationId xmlns:a16="http://schemas.microsoft.com/office/drawing/2014/main" id="{D22B8EE6-FC9F-1F8A-C24A-ED4C8148E1D1}"/>
               </a:ext>
             </a:extLst>
           </p:cNvPr>
@@ -5392,7 +5392,7 @@
           <p:cNvPr id="12" name="CaixaDeTexto 11">
             <a:extLst>
               <a:ext uri="{FF2B5EF4-FFF2-40B4-BE49-F238E27FC236}">
-                <a16:creationId xmlns:a16="http://schemas.microsoft.com/office/drawing/2014/main" id="{50947B57-333D-A5E1-90C2-89E0B8759506}"/>
+                <a16:creationId xmlns:a16="http://schemas.microsoft.com/office/drawing/2014/main" id="{C6A716C7-B1B2-37A6-FE49-05CEFCA122DE}"/>
               </a:ext>
             </a:extLst>
           </p:cNvPr>
@@ -5432,7 +5432,7 @@
           <p:cNvPr id="13" name="CaixaDeTexto 12">
             <a:extLst>
               <a:ext uri="{FF2B5EF4-FFF2-40B4-BE49-F238E27FC236}">
-                <a16:creationId xmlns:a16="http://schemas.microsoft.com/office/drawing/2014/main" id="{E56BE8F6-C5AD-09A5-0E09-F5517DA7749B}"/>
+                <a16:creationId xmlns:a16="http://schemas.microsoft.com/office/drawing/2014/main" id="{23870E70-647E-FE60-1479-C31DA7EFD21C}"/>
               </a:ext>
             </a:extLst>
           </p:cNvPr>
@@ -5557,7 +5557,7 @@
           <p:cNvPr id="14" name="Retângulo: Cantos Arredondados 13">
             <a:extLst>
               <a:ext uri="{FF2B5EF4-FFF2-40B4-BE49-F238E27FC236}">
-                <a16:creationId xmlns:a16="http://schemas.microsoft.com/office/drawing/2014/main" id="{496D3FE0-F7EE-C24D-502E-E9C454152AD5}"/>
+                <a16:creationId xmlns:a16="http://schemas.microsoft.com/office/drawing/2014/main" id="{84A91BC3-D1A6-2E26-DB07-DFF19A0FCE3A}"/>
               </a:ext>
             </a:extLst>
           </p:cNvPr>
@@ -5611,7 +5611,7 @@
           <p:cNvPr id="15" name="CaixaDeTexto 14">
             <a:extLst>
               <a:ext uri="{FF2B5EF4-FFF2-40B4-BE49-F238E27FC236}">
-                <a16:creationId xmlns:a16="http://schemas.microsoft.com/office/drawing/2014/main" id="{91095EB1-6369-4946-4D23-3DF12420BABF}"/>
+                <a16:creationId xmlns:a16="http://schemas.microsoft.com/office/drawing/2014/main" id="{660F33AA-7ACA-CE39-B373-9E2F604F9D55}"/>
               </a:ext>
             </a:extLst>
           </p:cNvPr>
@@ -5649,7 +5649,7 @@
     </p:spTree>
     <p:extLst>
       <p:ext uri="{BB962C8B-B14F-4D97-AF65-F5344CB8AC3E}">
-        <p14:creationId xmlns:p14="http://schemas.microsoft.com/office/powerpoint/2010/main" val="2097130946"/>
+        <p14:creationId xmlns:p14="http://schemas.microsoft.com/office/powerpoint/2010/main" val="232081942"/>
       </p:ext>
     </p:extLst>
   </p:cSld>
@@ -5712,7 +5712,7 @@
           <p:cNvPr id="2" name="CaixaDeTexto 1">
             <a:extLst>
               <a:ext uri="{FF2B5EF4-FFF2-40B4-BE49-F238E27FC236}">
-                <a16:creationId xmlns:a16="http://schemas.microsoft.com/office/drawing/2014/main" id="{899D886A-9857-7068-B32C-E1F9D2ED1CD9}"/>
+                <a16:creationId xmlns:a16="http://schemas.microsoft.com/office/drawing/2014/main" id="{6C27CE31-95FE-DE56-F2A1-619A3A13834F}"/>
               </a:ext>
             </a:extLst>
           </p:cNvPr>
@@ -5752,7 +5752,7 @@
           <p:cNvPr id="3" name="Retângulo 2">
             <a:extLst>
               <a:ext uri="{FF2B5EF4-FFF2-40B4-BE49-F238E27FC236}">
-                <a16:creationId xmlns:a16="http://schemas.microsoft.com/office/drawing/2014/main" id="{E3FB625D-DC1A-78ED-F4FE-EC312B0E73BE}"/>
+                <a16:creationId xmlns:a16="http://schemas.microsoft.com/office/drawing/2014/main" id="{6C60DCBD-11A9-EDB0-8021-88213A563129}"/>
               </a:ext>
             </a:extLst>
           </p:cNvPr>
@@ -5820,7 +5820,7 @@
           <p:cNvPr id="4" name="Retângulo 3">
             <a:extLst>
               <a:ext uri="{FF2B5EF4-FFF2-40B4-BE49-F238E27FC236}">
-                <a16:creationId xmlns:a16="http://schemas.microsoft.com/office/drawing/2014/main" id="{7D5920DC-529D-E82F-6DA8-DADE0A503078}"/>
+                <a16:creationId xmlns:a16="http://schemas.microsoft.com/office/drawing/2014/main" id="{8CB9EF8C-66A4-7FA4-23B7-ED6A0F3DCB7B}"/>
               </a:ext>
             </a:extLst>
           </p:cNvPr>
@@ -5888,7 +5888,7 @@
           <p:cNvPr id="5" name="CaixaDeTexto 4">
             <a:extLst>
               <a:ext uri="{FF2B5EF4-FFF2-40B4-BE49-F238E27FC236}">
-                <a16:creationId xmlns:a16="http://schemas.microsoft.com/office/drawing/2014/main" id="{5F96D1C5-B9C1-6CC1-6C01-76D1D02F85F7}"/>
+                <a16:creationId xmlns:a16="http://schemas.microsoft.com/office/drawing/2014/main" id="{76CAA5A9-36F7-21A8-94BF-96CDE2828EB4}"/>
               </a:ext>
             </a:extLst>
           </p:cNvPr>
@@ -5928,7 +5928,7 @@
           <p:cNvPr id="6" name="CaixaDeTexto 5">
             <a:extLst>
               <a:ext uri="{FF2B5EF4-FFF2-40B4-BE49-F238E27FC236}">
-                <a16:creationId xmlns:a16="http://schemas.microsoft.com/office/drawing/2014/main" id="{6CA9489E-8EF2-6038-807B-DFFC50FC973E}"/>
+                <a16:creationId xmlns:a16="http://schemas.microsoft.com/office/drawing/2014/main" id="{A5CAB7EE-C866-8564-1908-78A65B530E1F}"/>
               </a:ext>
             </a:extLst>
           </p:cNvPr>
@@ -5969,7 +5969,7 @@
           <p:cNvPr id="7" name="CaixaDeTexto 6">
             <a:extLst>
               <a:ext uri="{FF2B5EF4-FFF2-40B4-BE49-F238E27FC236}">
-                <a16:creationId xmlns:a16="http://schemas.microsoft.com/office/drawing/2014/main" id="{2E3B7A11-91D3-54E6-B860-0F828BEA7104}"/>
+                <a16:creationId xmlns:a16="http://schemas.microsoft.com/office/drawing/2014/main" id="{FB37114C-01F4-A2EB-541A-743711D827C1}"/>
               </a:ext>
             </a:extLst>
           </p:cNvPr>
@@ -6182,7 +6182,7 @@
     </p:spTree>
     <p:extLst>
       <p:ext uri="{BB962C8B-B14F-4D97-AF65-F5344CB8AC3E}">
-        <p14:creationId xmlns:p14="http://schemas.microsoft.com/office/powerpoint/2010/main" val="3390628848"/>
+        <p14:creationId xmlns:p14="http://schemas.microsoft.com/office/powerpoint/2010/main" val="2068625074"/>
       </p:ext>
     </p:extLst>
   </p:cSld>
@@ -6245,7 +6245,7 @@
           <p:cNvPr id="2" name="CaixaDeTexto 1">
             <a:extLst>
               <a:ext uri="{FF2B5EF4-FFF2-40B4-BE49-F238E27FC236}">
-                <a16:creationId xmlns:a16="http://schemas.microsoft.com/office/drawing/2014/main" id="{39E0136A-386A-0B88-B35E-BC2C9E7ED6DD}"/>
+                <a16:creationId xmlns:a16="http://schemas.microsoft.com/office/drawing/2014/main" id="{76ADB1D7-5C6B-3D97-0748-25CA25814A07}"/>
               </a:ext>
             </a:extLst>
           </p:cNvPr>
@@ -6285,7 +6285,7 @@
           <p:cNvPr id="3" name="Retângulo 2">
             <a:extLst>
               <a:ext uri="{FF2B5EF4-FFF2-40B4-BE49-F238E27FC236}">
-                <a16:creationId xmlns:a16="http://schemas.microsoft.com/office/drawing/2014/main" id="{EF310220-1503-0A2B-1AC5-0132FB4563DA}"/>
+                <a16:creationId xmlns:a16="http://schemas.microsoft.com/office/drawing/2014/main" id="{CC662F11-A4C7-E26D-459E-42333D5448A0}"/>
               </a:ext>
             </a:extLst>
           </p:cNvPr>
@@ -6353,7 +6353,7 @@
           <p:cNvPr id="4" name="Retângulo 3">
             <a:extLst>
               <a:ext uri="{FF2B5EF4-FFF2-40B4-BE49-F238E27FC236}">
-                <a16:creationId xmlns:a16="http://schemas.microsoft.com/office/drawing/2014/main" id="{46839068-29C3-9F19-ACB3-AD6F890CCD08}"/>
+                <a16:creationId xmlns:a16="http://schemas.microsoft.com/office/drawing/2014/main" id="{C21582CC-4FE9-C759-02AE-64125D8E1C3E}"/>
               </a:ext>
             </a:extLst>
           </p:cNvPr>
@@ -6421,7 +6421,7 @@
           <p:cNvPr id="5" name="CaixaDeTexto 4">
             <a:extLst>
               <a:ext uri="{FF2B5EF4-FFF2-40B4-BE49-F238E27FC236}">
-                <a16:creationId xmlns:a16="http://schemas.microsoft.com/office/drawing/2014/main" id="{C9D7FC4F-1A37-C0D2-F32B-8245A0498050}"/>
+                <a16:creationId xmlns:a16="http://schemas.microsoft.com/office/drawing/2014/main" id="{90621CFF-F97F-DAFF-17EF-B8D57654DA34}"/>
               </a:ext>
             </a:extLst>
           </p:cNvPr>
@@ -6461,7 +6461,7 @@
           <p:cNvPr id="6" name="CaixaDeTexto 5">
             <a:extLst>
               <a:ext uri="{FF2B5EF4-FFF2-40B4-BE49-F238E27FC236}">
-                <a16:creationId xmlns:a16="http://schemas.microsoft.com/office/drawing/2014/main" id="{34BCE979-98D9-9C74-BA4A-E525473E2D5E}"/>
+                <a16:creationId xmlns:a16="http://schemas.microsoft.com/office/drawing/2014/main" id="{E963532F-052D-3CC5-EB7D-F340B9F597E3}"/>
               </a:ext>
             </a:extLst>
           </p:cNvPr>
@@ -6502,7 +6502,7 @@
           <p:cNvPr id="7" name="CaixaDeTexto 6">
             <a:extLst>
               <a:ext uri="{FF2B5EF4-FFF2-40B4-BE49-F238E27FC236}">
-                <a16:creationId xmlns:a16="http://schemas.microsoft.com/office/drawing/2014/main" id="{919CC51D-579C-9F16-FBC4-F6304B251B75}"/>
+                <a16:creationId xmlns:a16="http://schemas.microsoft.com/office/drawing/2014/main" id="{B31590CA-29AE-8277-AB34-17D646B909AB}"/>
               </a:ext>
             </a:extLst>
           </p:cNvPr>
@@ -6663,7 +6663,7 @@
     </p:spTree>
     <p:extLst>
       <p:ext uri="{BB962C8B-B14F-4D97-AF65-F5344CB8AC3E}">
-        <p14:creationId xmlns:p14="http://schemas.microsoft.com/office/powerpoint/2010/main" val="3917953560"/>
+        <p14:creationId xmlns:p14="http://schemas.microsoft.com/office/powerpoint/2010/main" val="18123093"/>
       </p:ext>
     </p:extLst>
   </p:cSld>
@@ -6726,7 +6726,7 @@
           <p:cNvPr id="2" name="CaixaDeTexto 1">
             <a:extLst>
               <a:ext uri="{FF2B5EF4-FFF2-40B4-BE49-F238E27FC236}">
-                <a16:creationId xmlns:a16="http://schemas.microsoft.com/office/drawing/2014/main" id="{2AF09937-788A-FA48-8B14-11B7F3A15365}"/>
+                <a16:creationId xmlns:a16="http://schemas.microsoft.com/office/drawing/2014/main" id="{7B335623-94E1-E496-50AD-E08B9A31C6E8}"/>
               </a:ext>
             </a:extLst>
           </p:cNvPr>
@@ -6766,7 +6766,7 @@
           <p:cNvPr id="3" name="Retângulo 2">
             <a:extLst>
               <a:ext uri="{FF2B5EF4-FFF2-40B4-BE49-F238E27FC236}">
-                <a16:creationId xmlns:a16="http://schemas.microsoft.com/office/drawing/2014/main" id="{20CFA959-0D67-F291-5543-796E86BFF3D3}"/>
+                <a16:creationId xmlns:a16="http://schemas.microsoft.com/office/drawing/2014/main" id="{7D917641-0D93-5427-44B1-71E1044D5AA6}"/>
               </a:ext>
             </a:extLst>
           </p:cNvPr>
@@ -6834,7 +6834,7 @@
           <p:cNvPr id="4" name="Retângulo 3">
             <a:extLst>
               <a:ext uri="{FF2B5EF4-FFF2-40B4-BE49-F238E27FC236}">
-                <a16:creationId xmlns:a16="http://schemas.microsoft.com/office/drawing/2014/main" id="{99663154-C493-BC8D-A950-CEA085ACA3A2}"/>
+                <a16:creationId xmlns:a16="http://schemas.microsoft.com/office/drawing/2014/main" id="{715C8A53-F683-FDA7-0210-702CA5043B57}"/>
               </a:ext>
             </a:extLst>
           </p:cNvPr>
@@ -6902,7 +6902,7 @@
           <p:cNvPr id="5" name="CaixaDeTexto 4">
             <a:extLst>
               <a:ext uri="{FF2B5EF4-FFF2-40B4-BE49-F238E27FC236}">
-                <a16:creationId xmlns:a16="http://schemas.microsoft.com/office/drawing/2014/main" id="{D00B0CB7-CC2D-1224-10AD-789C0648EE8A}"/>
+                <a16:creationId xmlns:a16="http://schemas.microsoft.com/office/drawing/2014/main" id="{D417C32E-6A73-66DA-F960-5098F3315F88}"/>
               </a:ext>
             </a:extLst>
           </p:cNvPr>
@@ -6942,7 +6942,7 @@
           <p:cNvPr id="6" name="CaixaDeTexto 5">
             <a:extLst>
               <a:ext uri="{FF2B5EF4-FFF2-40B4-BE49-F238E27FC236}">
-                <a16:creationId xmlns:a16="http://schemas.microsoft.com/office/drawing/2014/main" id="{0F4510D2-54ED-417A-BB76-CE4E352DAF30}"/>
+                <a16:creationId xmlns:a16="http://schemas.microsoft.com/office/drawing/2014/main" id="{D9310141-A0AB-ED32-715F-F62A5B976E10}"/>
               </a:ext>
             </a:extLst>
           </p:cNvPr>
@@ -6983,7 +6983,7 @@
           <p:cNvPr id="7" name="Retângulo: Cantos Arredondados 6">
             <a:extLst>
               <a:ext uri="{FF2B5EF4-FFF2-40B4-BE49-F238E27FC236}">
-                <a16:creationId xmlns:a16="http://schemas.microsoft.com/office/drawing/2014/main" id="{3283669B-791B-53DB-3E09-62EADDAB82DA}"/>
+                <a16:creationId xmlns:a16="http://schemas.microsoft.com/office/drawing/2014/main" id="{5A17F114-386D-5E69-9468-C63DCDDD891B}"/>
               </a:ext>
             </a:extLst>
           </p:cNvPr>
@@ -7037,7 +7037,7 @@
           <p:cNvPr id="8" name="CaixaDeTexto 7">
             <a:extLst>
               <a:ext uri="{FF2B5EF4-FFF2-40B4-BE49-F238E27FC236}">
-                <a16:creationId xmlns:a16="http://schemas.microsoft.com/office/drawing/2014/main" id="{611ED170-6BBB-2809-1E79-605179A09DC0}"/>
+                <a16:creationId xmlns:a16="http://schemas.microsoft.com/office/drawing/2014/main" id="{906ACAC2-DB71-B370-0673-5B8141F337E1}"/>
               </a:ext>
             </a:extLst>
           </p:cNvPr>
@@ -7077,7 +7077,7 @@
           <p:cNvPr id="9" name="CaixaDeTexto 8">
             <a:extLst>
               <a:ext uri="{FF2B5EF4-FFF2-40B4-BE49-F238E27FC236}">
-                <a16:creationId xmlns:a16="http://schemas.microsoft.com/office/drawing/2014/main" id="{7DA1C305-F5D9-41C8-D264-693DC88C729F}"/>
+                <a16:creationId xmlns:a16="http://schemas.microsoft.com/office/drawing/2014/main" id="{A770F378-BF37-1BBF-2F3C-41751A7EBB6C}"/>
               </a:ext>
             </a:extLst>
           </p:cNvPr>
@@ -7117,7 +7117,7 @@
           <p:cNvPr id="10" name="CaixaDeTexto 9">
             <a:extLst>
               <a:ext uri="{FF2B5EF4-FFF2-40B4-BE49-F238E27FC236}">
-                <a16:creationId xmlns:a16="http://schemas.microsoft.com/office/drawing/2014/main" id="{CDF006E8-AD18-0A32-9305-340440F9E20D}"/>
+                <a16:creationId xmlns:a16="http://schemas.microsoft.com/office/drawing/2014/main" id="{161C3BDB-4F38-8A1D-DD0A-8C9B23D605A8}"/>
               </a:ext>
             </a:extLst>
           </p:cNvPr>
@@ -7210,7 +7210,7 @@
           <p:cNvPr id="11" name="Retângulo: Cantos Arredondados 10">
             <a:extLst>
               <a:ext uri="{FF2B5EF4-FFF2-40B4-BE49-F238E27FC236}">
-                <a16:creationId xmlns:a16="http://schemas.microsoft.com/office/drawing/2014/main" id="{02496E6A-16D0-437E-60C9-3169381ECA2F}"/>
+                <a16:creationId xmlns:a16="http://schemas.microsoft.com/office/drawing/2014/main" id="{8C686BCF-F7C3-70D8-CF82-D611C7351074}"/>
               </a:ext>
             </a:extLst>
           </p:cNvPr>
@@ -7264,7 +7264,7 @@
           <p:cNvPr id="12" name="CaixaDeTexto 11">
             <a:extLst>
               <a:ext uri="{FF2B5EF4-FFF2-40B4-BE49-F238E27FC236}">
-                <a16:creationId xmlns:a16="http://schemas.microsoft.com/office/drawing/2014/main" id="{B9E71074-E9F3-C7B1-015C-FBE38DF9328C}"/>
+                <a16:creationId xmlns:a16="http://schemas.microsoft.com/office/drawing/2014/main" id="{B2FE4800-EA46-B983-2949-EEFF6F1BDAF5}"/>
               </a:ext>
             </a:extLst>
           </p:cNvPr>
@@ -7304,7 +7304,7 @@
           <p:cNvPr id="13" name="CaixaDeTexto 12">
             <a:extLst>
               <a:ext uri="{FF2B5EF4-FFF2-40B4-BE49-F238E27FC236}">
-                <a16:creationId xmlns:a16="http://schemas.microsoft.com/office/drawing/2014/main" id="{33545ED0-8C2A-0F56-E69E-9E1E81B3748E}"/>
+                <a16:creationId xmlns:a16="http://schemas.microsoft.com/office/drawing/2014/main" id="{6A3FF7DF-5AAE-9FD9-35D8-1E3840646407}"/>
               </a:ext>
             </a:extLst>
           </p:cNvPr>
@@ -7344,7 +7344,7 @@
           <p:cNvPr id="14" name="CaixaDeTexto 13">
             <a:extLst>
               <a:ext uri="{FF2B5EF4-FFF2-40B4-BE49-F238E27FC236}">
-                <a16:creationId xmlns:a16="http://schemas.microsoft.com/office/drawing/2014/main" id="{2CA28845-1700-A1CC-E6F3-F4E9E22C055A}"/>
+                <a16:creationId xmlns:a16="http://schemas.microsoft.com/office/drawing/2014/main" id="{4B9A7D79-3262-145F-5A01-781866BB244B}"/>
               </a:ext>
             </a:extLst>
           </p:cNvPr>
@@ -7437,7 +7437,7 @@
           <p:cNvPr id="15" name="Retângulo: Cantos Arredondados 14">
             <a:extLst>
               <a:ext uri="{FF2B5EF4-FFF2-40B4-BE49-F238E27FC236}">
-                <a16:creationId xmlns:a16="http://schemas.microsoft.com/office/drawing/2014/main" id="{8311EB33-5229-209E-267A-E5E5A5BBF689}"/>
+                <a16:creationId xmlns:a16="http://schemas.microsoft.com/office/drawing/2014/main" id="{B0D96ECC-B9ED-39FB-0312-213B99E62028}"/>
               </a:ext>
             </a:extLst>
           </p:cNvPr>
@@ -7491,7 +7491,7 @@
           <p:cNvPr id="16" name="CaixaDeTexto 15">
             <a:extLst>
               <a:ext uri="{FF2B5EF4-FFF2-40B4-BE49-F238E27FC236}">
-                <a16:creationId xmlns:a16="http://schemas.microsoft.com/office/drawing/2014/main" id="{A189C492-F784-5021-4432-FDFC6C1E8C12}"/>
+                <a16:creationId xmlns:a16="http://schemas.microsoft.com/office/drawing/2014/main" id="{789E1405-D4EC-3746-14D6-828804C7CE17}"/>
               </a:ext>
             </a:extLst>
           </p:cNvPr>
@@ -7531,7 +7531,7 @@
           <p:cNvPr id="17" name="CaixaDeTexto 16">
             <a:extLst>
               <a:ext uri="{FF2B5EF4-FFF2-40B4-BE49-F238E27FC236}">
-                <a16:creationId xmlns:a16="http://schemas.microsoft.com/office/drawing/2014/main" id="{F246286F-2284-A635-F604-3DC69A5D8A17}"/>
+                <a16:creationId xmlns:a16="http://schemas.microsoft.com/office/drawing/2014/main" id="{6F4744FE-A4AC-2901-497F-C1122CDE026D}"/>
               </a:ext>
             </a:extLst>
           </p:cNvPr>
@@ -7571,7 +7571,7 @@
           <p:cNvPr id="18" name="CaixaDeTexto 17">
             <a:extLst>
               <a:ext uri="{FF2B5EF4-FFF2-40B4-BE49-F238E27FC236}">
-                <a16:creationId xmlns:a16="http://schemas.microsoft.com/office/drawing/2014/main" id="{EE66CD7A-B9CA-7AAF-5E10-152DBCAFDD82}"/>
+                <a16:creationId xmlns:a16="http://schemas.microsoft.com/office/drawing/2014/main" id="{CBC9CEC0-7DB7-0328-DA58-A88F4E99026C}"/>
               </a:ext>
             </a:extLst>
           </p:cNvPr>
@@ -7662,7 +7662,7 @@
     </p:spTree>
     <p:extLst>
       <p:ext uri="{BB962C8B-B14F-4D97-AF65-F5344CB8AC3E}">
-        <p14:creationId xmlns:p14="http://schemas.microsoft.com/office/powerpoint/2010/main" val="3905606661"/>
+        <p14:creationId xmlns:p14="http://schemas.microsoft.com/office/powerpoint/2010/main" val="872191787"/>
       </p:ext>
     </p:extLst>
   </p:cSld>
@@ -7725,7 +7725,7 @@
           <p:cNvPr id="2" name="CaixaDeTexto 1">
             <a:extLst>
               <a:ext uri="{FF2B5EF4-FFF2-40B4-BE49-F238E27FC236}">
-                <a16:creationId xmlns:a16="http://schemas.microsoft.com/office/drawing/2014/main" id="{B1BE0490-6EA2-F0E4-2FDB-03B383A67ED8}"/>
+                <a16:creationId xmlns:a16="http://schemas.microsoft.com/office/drawing/2014/main" id="{B0EA6685-F37C-7735-8A51-33AFD1406F2E}"/>
               </a:ext>
             </a:extLst>
           </p:cNvPr>
@@ -7765,7 +7765,7 @@
           <p:cNvPr id="3" name="Retângulo 2">
             <a:extLst>
               <a:ext uri="{FF2B5EF4-FFF2-40B4-BE49-F238E27FC236}">
-                <a16:creationId xmlns:a16="http://schemas.microsoft.com/office/drawing/2014/main" id="{5ACE888B-1B58-3DD4-CD4F-206CAFA2467B}"/>
+                <a16:creationId xmlns:a16="http://schemas.microsoft.com/office/drawing/2014/main" id="{5B5286CC-3E25-CF1C-8EEB-4F0636C9527A}"/>
               </a:ext>
             </a:extLst>
           </p:cNvPr>
@@ -7833,7 +7833,7 @@
           <p:cNvPr id="4" name="Retângulo 3">
             <a:extLst>
               <a:ext uri="{FF2B5EF4-FFF2-40B4-BE49-F238E27FC236}">
-                <a16:creationId xmlns:a16="http://schemas.microsoft.com/office/drawing/2014/main" id="{73561AD9-91ED-1DC2-39C7-D39C6A2B9AAA}"/>
+                <a16:creationId xmlns:a16="http://schemas.microsoft.com/office/drawing/2014/main" id="{8998A50B-971C-A097-D7D9-027D992840DC}"/>
               </a:ext>
             </a:extLst>
           </p:cNvPr>
@@ -7901,7 +7901,7 @@
           <p:cNvPr id="5" name="CaixaDeTexto 4">
             <a:extLst>
               <a:ext uri="{FF2B5EF4-FFF2-40B4-BE49-F238E27FC236}">
-                <a16:creationId xmlns:a16="http://schemas.microsoft.com/office/drawing/2014/main" id="{114FBA0F-F23A-180A-739B-A80D9E450929}"/>
+                <a16:creationId xmlns:a16="http://schemas.microsoft.com/office/drawing/2014/main" id="{5326262A-D7D3-CDD1-9B5D-E8014619E73F}"/>
               </a:ext>
             </a:extLst>
           </p:cNvPr>
@@ -7941,7 +7941,7 @@
           <p:cNvPr id="6" name="CaixaDeTexto 5">
             <a:extLst>
               <a:ext uri="{FF2B5EF4-FFF2-40B4-BE49-F238E27FC236}">
-                <a16:creationId xmlns:a16="http://schemas.microsoft.com/office/drawing/2014/main" id="{0D07326A-A44D-94AA-C9AE-508DE24A502E}"/>
+                <a16:creationId xmlns:a16="http://schemas.microsoft.com/office/drawing/2014/main" id="{0F4E331C-FEAD-2860-9CA2-FDCD9B3CBF54}"/>
               </a:ext>
             </a:extLst>
           </p:cNvPr>
@@ -7982,7 +7982,7 @@
           <p:cNvPr id="7" name="Tabela 6">
             <a:extLst>
               <a:ext uri="{FF2B5EF4-FFF2-40B4-BE49-F238E27FC236}">
-                <a16:creationId xmlns:a16="http://schemas.microsoft.com/office/drawing/2014/main" id="{E99F3623-89EF-A5F2-9607-59C43052E5DF}"/>
+                <a16:creationId xmlns:a16="http://schemas.microsoft.com/office/drawing/2014/main" id="{47E6A5B6-77DE-BC36-61EA-FBB2F0E256CB}"/>
               </a:ext>
             </a:extLst>
           </p:cNvPr>
@@ -7992,7 +7992,7 @@
           <p:nvPr>
             <p:extLst>
               <p:ext uri="{D42A27DB-BD31-4B8C-83A1-F6EECF244321}">
-                <p14:modId xmlns:p14="http://schemas.microsoft.com/office/powerpoint/2010/main" val="508416690"/>
+                <p14:modId xmlns:p14="http://schemas.microsoft.com/office/powerpoint/2010/main" val="1719935758"/>
               </p:ext>
             </p:extLst>
           </p:nvPr>
@@ -8011,14 +8011,14 @@
                 <a:gridCol w="3556000">
                   <a:extLst>
                     <a:ext uri="{9D8B030D-6E8A-4147-A177-3AD203B41FA5}">
-                      <a16:colId xmlns:a16="http://schemas.microsoft.com/office/drawing/2014/main" val="1694454506"/>
+                      <a16:colId xmlns:a16="http://schemas.microsoft.com/office/drawing/2014/main" val="2614936706"/>
                     </a:ext>
                   </a:extLst>
                 </a:gridCol>
                 <a:gridCol w="7112000">
                   <a:extLst>
                     <a:ext uri="{9D8B030D-6E8A-4147-A177-3AD203B41FA5}">
-                      <a16:colId xmlns:a16="http://schemas.microsoft.com/office/drawing/2014/main" val="4213529102"/>
+                      <a16:colId xmlns:a16="http://schemas.microsoft.com/office/drawing/2014/main" val="2837150891"/>
                     </a:ext>
                   </a:extLst>
                 </a:gridCol>
@@ -8072,7 +8072,7 @@
                 </a:tc>
                 <a:extLst>
                   <a:ext uri="{0D108BD9-81ED-4DB2-BD59-A6C34878D82A}">
-                    <a16:rowId xmlns:a16="http://schemas.microsoft.com/office/drawing/2014/main" val="1220240369"/>
+                    <a16:rowId xmlns:a16="http://schemas.microsoft.com/office/drawing/2014/main" val="2687806204"/>
                   </a:ext>
                 </a:extLst>
               </a:tr>
@@ -8125,7 +8125,7 @@
                 </a:tc>
                 <a:extLst>
                   <a:ext uri="{0D108BD9-81ED-4DB2-BD59-A6C34878D82A}">
-                    <a16:rowId xmlns:a16="http://schemas.microsoft.com/office/drawing/2014/main" val="1366858288"/>
+                    <a16:rowId xmlns:a16="http://schemas.microsoft.com/office/drawing/2014/main" val="3284663159"/>
                   </a:ext>
                 </a:extLst>
               </a:tr>
@@ -8178,7 +8178,7 @@
                 </a:tc>
                 <a:extLst>
                   <a:ext uri="{0D108BD9-81ED-4DB2-BD59-A6C34878D82A}">
-                    <a16:rowId xmlns:a16="http://schemas.microsoft.com/office/drawing/2014/main" val="255369348"/>
+                    <a16:rowId xmlns:a16="http://schemas.microsoft.com/office/drawing/2014/main" val="2016393236"/>
                   </a:ext>
                 </a:extLst>
               </a:tr>
@@ -8237,7 +8237,7 @@
                 </a:tc>
                 <a:extLst>
                   <a:ext uri="{0D108BD9-81ED-4DB2-BD59-A6C34878D82A}">
-                    <a16:rowId xmlns:a16="http://schemas.microsoft.com/office/drawing/2014/main" val="2187173776"/>
+                    <a16:rowId xmlns:a16="http://schemas.microsoft.com/office/drawing/2014/main" val="3252550617"/>
                   </a:ext>
                 </a:extLst>
               </a:tr>
@@ -8290,7 +8290,7 @@
                 </a:tc>
                 <a:extLst>
                   <a:ext uri="{0D108BD9-81ED-4DB2-BD59-A6C34878D82A}">
-                    <a16:rowId xmlns:a16="http://schemas.microsoft.com/office/drawing/2014/main" val="3916456869"/>
+                    <a16:rowId xmlns:a16="http://schemas.microsoft.com/office/drawing/2014/main" val="1951984995"/>
                   </a:ext>
                 </a:extLst>
               </a:tr>
@@ -8343,7 +8343,7 @@
                 </a:tc>
                 <a:extLst>
                   <a:ext uri="{0D108BD9-81ED-4DB2-BD59-A6C34878D82A}">
-                    <a16:rowId xmlns:a16="http://schemas.microsoft.com/office/drawing/2014/main" val="2612954000"/>
+                    <a16:rowId xmlns:a16="http://schemas.microsoft.com/office/drawing/2014/main" val="1208686671"/>
                   </a:ext>
                 </a:extLst>
               </a:tr>
@@ -8396,7 +8396,7 @@
                 </a:tc>
                 <a:extLst>
                   <a:ext uri="{0D108BD9-81ED-4DB2-BD59-A6C34878D82A}">
-                    <a16:rowId xmlns:a16="http://schemas.microsoft.com/office/drawing/2014/main" val="3631272431"/>
+                    <a16:rowId xmlns:a16="http://schemas.microsoft.com/office/drawing/2014/main" val="736878277"/>
                   </a:ext>
                 </a:extLst>
               </a:tr>
@@ -8449,7 +8449,7 @@
                 </a:tc>
                 <a:extLst>
                   <a:ext uri="{0D108BD9-81ED-4DB2-BD59-A6C34878D82A}">
-                    <a16:rowId xmlns:a16="http://schemas.microsoft.com/office/drawing/2014/main" val="1082644580"/>
+                    <a16:rowId xmlns:a16="http://schemas.microsoft.com/office/drawing/2014/main" val="2246300102"/>
                   </a:ext>
                 </a:extLst>
               </a:tr>
@@ -8502,7 +8502,7 @@
                 </a:tc>
                 <a:extLst>
                   <a:ext uri="{0D108BD9-81ED-4DB2-BD59-A6C34878D82A}">
-                    <a16:rowId xmlns:a16="http://schemas.microsoft.com/office/drawing/2014/main" val="2598824602"/>
+                    <a16:rowId xmlns:a16="http://schemas.microsoft.com/office/drawing/2014/main" val="1164136564"/>
                   </a:ext>
                 </a:extLst>
               </a:tr>
@@ -8555,7 +8555,7 @@
                 </a:tc>
                 <a:extLst>
                   <a:ext uri="{0D108BD9-81ED-4DB2-BD59-A6C34878D82A}">
-                    <a16:rowId xmlns:a16="http://schemas.microsoft.com/office/drawing/2014/main" val="1144709749"/>
+                    <a16:rowId xmlns:a16="http://schemas.microsoft.com/office/drawing/2014/main" val="3351796419"/>
                   </a:ext>
                 </a:extLst>
               </a:tr>
@@ -8566,7 +8566,7 @@
     </p:spTree>
     <p:extLst>
       <p:ext uri="{BB962C8B-B14F-4D97-AF65-F5344CB8AC3E}">
-        <p14:creationId xmlns:p14="http://schemas.microsoft.com/office/powerpoint/2010/main" val="1015229751"/>
+        <p14:creationId xmlns:p14="http://schemas.microsoft.com/office/powerpoint/2010/main" val="2078870967"/>
       </p:ext>
     </p:extLst>
   </p:cSld>
@@ -8629,7 +8629,7 @@
           <p:cNvPr id="2" name="CaixaDeTexto 1">
             <a:extLst>
               <a:ext uri="{FF2B5EF4-FFF2-40B4-BE49-F238E27FC236}">
-                <a16:creationId xmlns:a16="http://schemas.microsoft.com/office/drawing/2014/main" id="{5C79B817-3BC6-2E9B-5B01-27F9D1728012}"/>
+                <a16:creationId xmlns:a16="http://schemas.microsoft.com/office/drawing/2014/main" id="{530E7D58-E9E5-6200-0448-5BD1E53B5E7F}"/>
               </a:ext>
             </a:extLst>
           </p:cNvPr>
@@ -8669,7 +8669,7 @@
           <p:cNvPr id="3" name="Retângulo 2">
             <a:extLst>
               <a:ext uri="{FF2B5EF4-FFF2-40B4-BE49-F238E27FC236}">
-                <a16:creationId xmlns:a16="http://schemas.microsoft.com/office/drawing/2014/main" id="{6BA1315C-C3C1-E918-67FB-1E8889B6776C}"/>
+                <a16:creationId xmlns:a16="http://schemas.microsoft.com/office/drawing/2014/main" id="{7BFED4BC-3AC7-85CB-7A0B-37F3ADA4EC3D}"/>
               </a:ext>
             </a:extLst>
           </p:cNvPr>
@@ -8737,7 +8737,7 @@
           <p:cNvPr id="4" name="Retângulo 3">
             <a:extLst>
               <a:ext uri="{FF2B5EF4-FFF2-40B4-BE49-F238E27FC236}">
-                <a16:creationId xmlns:a16="http://schemas.microsoft.com/office/drawing/2014/main" id="{1980231A-1726-8744-22B8-F1D5312889F6}"/>
+                <a16:creationId xmlns:a16="http://schemas.microsoft.com/office/drawing/2014/main" id="{4387C730-19FB-DF2B-88FD-263CD19B9FF0}"/>
               </a:ext>
             </a:extLst>
           </p:cNvPr>
@@ -8805,7 +8805,7 @@
           <p:cNvPr id="5" name="CaixaDeTexto 4">
             <a:extLst>
               <a:ext uri="{FF2B5EF4-FFF2-40B4-BE49-F238E27FC236}">
-                <a16:creationId xmlns:a16="http://schemas.microsoft.com/office/drawing/2014/main" id="{03A339CC-882C-62B2-5C1B-0A50582C1A83}"/>
+                <a16:creationId xmlns:a16="http://schemas.microsoft.com/office/drawing/2014/main" id="{D2399DEA-6754-6077-66D8-F9C2B68362D0}"/>
               </a:ext>
             </a:extLst>
           </p:cNvPr>
@@ -8845,7 +8845,7 @@
           <p:cNvPr id="6" name="CaixaDeTexto 5">
             <a:extLst>
               <a:ext uri="{FF2B5EF4-FFF2-40B4-BE49-F238E27FC236}">
-                <a16:creationId xmlns:a16="http://schemas.microsoft.com/office/drawing/2014/main" id="{7A9BF355-0531-7B56-5F6A-300C87385EA4}"/>
+                <a16:creationId xmlns:a16="http://schemas.microsoft.com/office/drawing/2014/main" id="{932FE9F1-CB80-B9D1-C2AF-44907411A99D}"/>
               </a:ext>
             </a:extLst>
           </p:cNvPr>
@@ -8886,7 +8886,7 @@
           <p:cNvPr id="7" name="Retângulo: Cantos Arredondados 6">
             <a:extLst>
               <a:ext uri="{FF2B5EF4-FFF2-40B4-BE49-F238E27FC236}">
-                <a16:creationId xmlns:a16="http://schemas.microsoft.com/office/drawing/2014/main" id="{DBA24BC5-9E7C-756A-65D4-16BDC7FAB47A}"/>
+                <a16:creationId xmlns:a16="http://schemas.microsoft.com/office/drawing/2014/main" id="{6FE00ED4-0304-F870-A242-C04704440D35}"/>
               </a:ext>
             </a:extLst>
           </p:cNvPr>
@@ -8940,7 +8940,7 @@
           <p:cNvPr id="8" name="CaixaDeTexto 7">
             <a:extLst>
               <a:ext uri="{FF2B5EF4-FFF2-40B4-BE49-F238E27FC236}">
-                <a16:creationId xmlns:a16="http://schemas.microsoft.com/office/drawing/2014/main" id="{8052CF11-1116-8CE6-A938-78B881C3D861}"/>
+                <a16:creationId xmlns:a16="http://schemas.microsoft.com/office/drawing/2014/main" id="{87A2E611-9EC1-221D-BBEC-76CE97FCA8EC}"/>
               </a:ext>
             </a:extLst>
           </p:cNvPr>
@@ -8980,7 +8980,7 @@
           <p:cNvPr id="9" name="CaixaDeTexto 8">
             <a:extLst>
               <a:ext uri="{FF2B5EF4-FFF2-40B4-BE49-F238E27FC236}">
-                <a16:creationId xmlns:a16="http://schemas.microsoft.com/office/drawing/2014/main" id="{4DFE4C27-8A21-535C-283E-A28CE661C0F3}"/>
+                <a16:creationId xmlns:a16="http://schemas.microsoft.com/office/drawing/2014/main" id="{38FA8B8D-C155-C265-C820-EBADAB17FA80}"/>
               </a:ext>
             </a:extLst>
           </p:cNvPr>
@@ -9073,7 +9073,7 @@
           <p:cNvPr id="10" name="Retângulo: Cantos Arredondados 9">
             <a:extLst>
               <a:ext uri="{FF2B5EF4-FFF2-40B4-BE49-F238E27FC236}">
-                <a16:creationId xmlns:a16="http://schemas.microsoft.com/office/drawing/2014/main" id="{D0C4B12F-9551-6AF1-13D4-DC2D1F0443C2}"/>
+                <a16:creationId xmlns:a16="http://schemas.microsoft.com/office/drawing/2014/main" id="{65C652AD-27EA-BB08-A325-0C7C61B390C6}"/>
               </a:ext>
             </a:extLst>
           </p:cNvPr>
@@ -9127,7 +9127,7 @@
           <p:cNvPr id="11" name="CaixaDeTexto 10">
             <a:extLst>
               <a:ext uri="{FF2B5EF4-FFF2-40B4-BE49-F238E27FC236}">
-                <a16:creationId xmlns:a16="http://schemas.microsoft.com/office/drawing/2014/main" id="{A768721B-BF70-53D2-0FE3-2203294842EE}"/>
+                <a16:creationId xmlns:a16="http://schemas.microsoft.com/office/drawing/2014/main" id="{7437A5E7-C237-FE56-B564-293A020DCD09}"/>
               </a:ext>
             </a:extLst>
           </p:cNvPr>
@@ -9167,7 +9167,7 @@
           <p:cNvPr id="12" name="CaixaDeTexto 11">
             <a:extLst>
               <a:ext uri="{FF2B5EF4-FFF2-40B4-BE49-F238E27FC236}">
-                <a16:creationId xmlns:a16="http://schemas.microsoft.com/office/drawing/2014/main" id="{3E97BEA2-CB23-A61C-6671-7A3D76B58E79}"/>
+                <a16:creationId xmlns:a16="http://schemas.microsoft.com/office/drawing/2014/main" id="{327BFD5D-0770-1EF7-487C-DD5B307C3C64}"/>
               </a:ext>
             </a:extLst>
           </p:cNvPr>
@@ -9260,7 +9260,7 @@
           <p:cNvPr id="13" name="Retângulo: Cantos Arredondados 12">
             <a:extLst>
               <a:ext uri="{FF2B5EF4-FFF2-40B4-BE49-F238E27FC236}">
-                <a16:creationId xmlns:a16="http://schemas.microsoft.com/office/drawing/2014/main" id="{DC4CE10C-1307-7930-2974-7B56B98BB21B}"/>
+                <a16:creationId xmlns:a16="http://schemas.microsoft.com/office/drawing/2014/main" id="{FB32AED1-CB61-DA8C-2A7B-8B9E9396396A}"/>
               </a:ext>
             </a:extLst>
           </p:cNvPr>
@@ -9314,7 +9314,7 @@
           <p:cNvPr id="14" name="CaixaDeTexto 13">
             <a:extLst>
               <a:ext uri="{FF2B5EF4-FFF2-40B4-BE49-F238E27FC236}">
-                <a16:creationId xmlns:a16="http://schemas.microsoft.com/office/drawing/2014/main" id="{A1DDC12D-2D68-8239-740B-929B343D5F14}"/>
+                <a16:creationId xmlns:a16="http://schemas.microsoft.com/office/drawing/2014/main" id="{595E0116-F42F-BF15-ECC3-99194EAD785C}"/>
               </a:ext>
             </a:extLst>
           </p:cNvPr>
@@ -9352,7 +9352,7 @@
     </p:spTree>
     <p:extLst>
       <p:ext uri="{BB962C8B-B14F-4D97-AF65-F5344CB8AC3E}">
-        <p14:creationId xmlns:p14="http://schemas.microsoft.com/office/powerpoint/2010/main" val="3651247398"/>
+        <p14:creationId xmlns:p14="http://schemas.microsoft.com/office/powerpoint/2010/main" val="1314273735"/>
       </p:ext>
     </p:extLst>
   </p:cSld>
@@ -9415,7 +9415,7 @@
           <p:cNvPr id="2" name="CaixaDeTexto 1">
             <a:extLst>
               <a:ext uri="{FF2B5EF4-FFF2-40B4-BE49-F238E27FC236}">
-                <a16:creationId xmlns:a16="http://schemas.microsoft.com/office/drawing/2014/main" id="{5122604C-C38E-D8F9-6D39-34009ED7C844}"/>
+                <a16:creationId xmlns:a16="http://schemas.microsoft.com/office/drawing/2014/main" id="{315AAB70-360F-8925-4D75-CCA1B021328F}"/>
               </a:ext>
             </a:extLst>
           </p:cNvPr>
@@ -9455,7 +9455,7 @@
           <p:cNvPr id="3" name="Retângulo 2">
             <a:extLst>
               <a:ext uri="{FF2B5EF4-FFF2-40B4-BE49-F238E27FC236}">
-                <a16:creationId xmlns:a16="http://schemas.microsoft.com/office/drawing/2014/main" id="{7A191021-4CD8-E916-93C1-FA77286E8111}"/>
+                <a16:creationId xmlns:a16="http://schemas.microsoft.com/office/drawing/2014/main" id="{BD7543DA-7CD9-19CA-617D-88EA0071F8D7}"/>
               </a:ext>
             </a:extLst>
           </p:cNvPr>
@@ -9523,7 +9523,7 @@
           <p:cNvPr id="4" name="Retângulo 3">
             <a:extLst>
               <a:ext uri="{FF2B5EF4-FFF2-40B4-BE49-F238E27FC236}">
-                <a16:creationId xmlns:a16="http://schemas.microsoft.com/office/drawing/2014/main" id="{B2ABDBA3-498E-641B-89F3-133D4FE1535F}"/>
+                <a16:creationId xmlns:a16="http://schemas.microsoft.com/office/drawing/2014/main" id="{4104352D-11DA-9F88-8D9E-4932BBDAAED2}"/>
               </a:ext>
             </a:extLst>
           </p:cNvPr>
@@ -9591,7 +9591,7 @@
           <p:cNvPr id="5" name="CaixaDeTexto 4">
             <a:extLst>
               <a:ext uri="{FF2B5EF4-FFF2-40B4-BE49-F238E27FC236}">
-                <a16:creationId xmlns:a16="http://schemas.microsoft.com/office/drawing/2014/main" id="{993650F0-7C8F-D54C-F333-AC0F5BEF3ECA}"/>
+                <a16:creationId xmlns:a16="http://schemas.microsoft.com/office/drawing/2014/main" id="{75D83402-E287-2757-0B89-1A30D4BF700E}"/>
               </a:ext>
             </a:extLst>
           </p:cNvPr>
@@ -9631,7 +9631,7 @@
           <p:cNvPr id="6" name="CaixaDeTexto 5">
             <a:extLst>
               <a:ext uri="{FF2B5EF4-FFF2-40B4-BE49-F238E27FC236}">
-                <a16:creationId xmlns:a16="http://schemas.microsoft.com/office/drawing/2014/main" id="{FCD2C587-50D0-8A20-AB2B-FACB18DE2A78}"/>
+                <a16:creationId xmlns:a16="http://schemas.microsoft.com/office/drawing/2014/main" id="{E3D774B6-F5D5-7000-59FB-CF4A06C2B1E4}"/>
               </a:ext>
             </a:extLst>
           </p:cNvPr>
@@ -9672,7 +9672,7 @@
           <p:cNvPr id="7" name="Tabela 6">
             <a:extLst>
               <a:ext uri="{FF2B5EF4-FFF2-40B4-BE49-F238E27FC236}">
-                <a16:creationId xmlns:a16="http://schemas.microsoft.com/office/drawing/2014/main" id="{C25FE69E-8BB2-D472-9168-B49C7965310E}"/>
+                <a16:creationId xmlns:a16="http://schemas.microsoft.com/office/drawing/2014/main" id="{2B4A9F0B-0A89-9E3D-8817-9A18439B9D19}"/>
               </a:ext>
             </a:extLst>
           </p:cNvPr>
@@ -9682,7 +9682,7 @@
           <p:nvPr>
             <p:extLst>
               <p:ext uri="{D42A27DB-BD31-4B8C-83A1-F6EECF244321}">
-                <p14:modId xmlns:p14="http://schemas.microsoft.com/office/powerpoint/2010/main" val="2099296104"/>
+                <p14:modId xmlns:p14="http://schemas.microsoft.com/office/powerpoint/2010/main" val="1100898459"/>
               </p:ext>
             </p:extLst>
           </p:nvPr>
@@ -9701,14 +9701,14 @@
                 <a:gridCol w="2032000">
                   <a:extLst>
                     <a:ext uri="{9D8B030D-6E8A-4147-A177-3AD203B41FA5}">
-                      <a16:colId xmlns:a16="http://schemas.microsoft.com/office/drawing/2014/main" val="3250611869"/>
+                      <a16:colId xmlns:a16="http://schemas.microsoft.com/office/drawing/2014/main" val="3533316217"/>
                     </a:ext>
                   </a:extLst>
                 </a:gridCol>
                 <a:gridCol w="8636000">
                   <a:extLst>
                     <a:ext uri="{9D8B030D-6E8A-4147-A177-3AD203B41FA5}">
-                      <a16:colId xmlns:a16="http://schemas.microsoft.com/office/drawing/2014/main" val="4018343344"/>
+                      <a16:colId xmlns:a16="http://schemas.microsoft.com/office/drawing/2014/main" val="833815788"/>
                     </a:ext>
                   </a:extLst>
                 </a:gridCol>
@@ -9762,7 +9762,7 @@
                 </a:tc>
                 <a:extLst>
                   <a:ext uri="{0D108BD9-81ED-4DB2-BD59-A6C34878D82A}">
-                    <a16:rowId xmlns:a16="http://schemas.microsoft.com/office/drawing/2014/main" val="2058346711"/>
+                    <a16:rowId xmlns:a16="http://schemas.microsoft.com/office/drawing/2014/main" val="2602102171"/>
                   </a:ext>
                 </a:extLst>
               </a:tr>
@@ -9815,7 +9815,7 @@
                 </a:tc>
                 <a:extLst>
                   <a:ext uri="{0D108BD9-81ED-4DB2-BD59-A6C34878D82A}">
-                    <a16:rowId xmlns:a16="http://schemas.microsoft.com/office/drawing/2014/main" val="743033636"/>
+                    <a16:rowId xmlns:a16="http://schemas.microsoft.com/office/drawing/2014/main" val="2718979808"/>
                   </a:ext>
                 </a:extLst>
               </a:tr>
@@ -9868,7 +9868,7 @@
                 </a:tc>
                 <a:extLst>
                   <a:ext uri="{0D108BD9-81ED-4DB2-BD59-A6C34878D82A}">
-                    <a16:rowId xmlns:a16="http://schemas.microsoft.com/office/drawing/2014/main" val="842046132"/>
+                    <a16:rowId xmlns:a16="http://schemas.microsoft.com/office/drawing/2014/main" val="2450492884"/>
                   </a:ext>
                 </a:extLst>
               </a:tr>
@@ -9921,7 +9921,7 @@
                 </a:tc>
                 <a:extLst>
                   <a:ext uri="{0D108BD9-81ED-4DB2-BD59-A6C34878D82A}">
-                    <a16:rowId xmlns:a16="http://schemas.microsoft.com/office/drawing/2014/main" val="1451195043"/>
+                    <a16:rowId xmlns:a16="http://schemas.microsoft.com/office/drawing/2014/main" val="2092389412"/>
                   </a:ext>
                 </a:extLst>
               </a:tr>
@@ -9974,7 +9974,7 @@
                 </a:tc>
                 <a:extLst>
                   <a:ext uri="{0D108BD9-81ED-4DB2-BD59-A6C34878D82A}">
-                    <a16:rowId xmlns:a16="http://schemas.microsoft.com/office/drawing/2014/main" val="1622277606"/>
+                    <a16:rowId xmlns:a16="http://schemas.microsoft.com/office/drawing/2014/main" val="3594309504"/>
                   </a:ext>
                 </a:extLst>
               </a:tr>
@@ -9987,7 +9987,7 @@
           <p:cNvPr id="8" name="CaixaDeTexto 7">
             <a:extLst>
               <a:ext uri="{FF2B5EF4-FFF2-40B4-BE49-F238E27FC236}">
-                <a16:creationId xmlns:a16="http://schemas.microsoft.com/office/drawing/2014/main" id="{1C3CA593-3ADE-DC40-60C2-91450EBE746E}"/>
+                <a16:creationId xmlns:a16="http://schemas.microsoft.com/office/drawing/2014/main" id="{C8709B64-73C9-0EDD-92B7-AE99E7CE2057}"/>
               </a:ext>
             </a:extLst>
           </p:cNvPr>
@@ -10080,7 +10080,7 @@
     </p:spTree>
     <p:extLst>
       <p:ext uri="{BB962C8B-B14F-4D97-AF65-F5344CB8AC3E}">
-        <p14:creationId xmlns:p14="http://schemas.microsoft.com/office/powerpoint/2010/main" val="2415278930"/>
+        <p14:creationId xmlns:p14="http://schemas.microsoft.com/office/powerpoint/2010/main" val="1913684508"/>
       </p:ext>
     </p:extLst>
   </p:cSld>
@@ -10143,7 +10143,7 @@
           <p:cNvPr id="2" name="CaixaDeTexto 1">
             <a:extLst>
               <a:ext uri="{FF2B5EF4-FFF2-40B4-BE49-F238E27FC236}">
-                <a16:creationId xmlns:a16="http://schemas.microsoft.com/office/drawing/2014/main" id="{1E2CEBA1-BF21-0CC4-4296-AD443E9A16AB}"/>
+                <a16:creationId xmlns:a16="http://schemas.microsoft.com/office/drawing/2014/main" id="{39E39F37-5DFA-6086-691F-8C45329247D5}"/>
               </a:ext>
             </a:extLst>
           </p:cNvPr>
@@ -10183,7 +10183,7 @@
           <p:cNvPr id="3" name="Retângulo 2">
             <a:extLst>
               <a:ext uri="{FF2B5EF4-FFF2-40B4-BE49-F238E27FC236}">
-                <a16:creationId xmlns:a16="http://schemas.microsoft.com/office/drawing/2014/main" id="{C7AE43A2-5854-A920-A668-770D098FCF70}"/>
+                <a16:creationId xmlns:a16="http://schemas.microsoft.com/office/drawing/2014/main" id="{30ECF6C5-62A8-B299-A55B-DD6BA535B376}"/>
               </a:ext>
             </a:extLst>
           </p:cNvPr>
@@ -10251,7 +10251,7 @@
           <p:cNvPr id="4" name="Retângulo 3">
             <a:extLst>
               <a:ext uri="{FF2B5EF4-FFF2-40B4-BE49-F238E27FC236}">
-                <a16:creationId xmlns:a16="http://schemas.microsoft.com/office/drawing/2014/main" id="{45072349-1639-94A1-50D4-56C155969FDD}"/>
+                <a16:creationId xmlns:a16="http://schemas.microsoft.com/office/drawing/2014/main" id="{8A2B2D98-4C72-5E8F-F83C-9917A0ABE27C}"/>
               </a:ext>
             </a:extLst>
           </p:cNvPr>
@@ -10319,7 +10319,7 @@
           <p:cNvPr id="5" name="CaixaDeTexto 4">
             <a:extLst>
               <a:ext uri="{FF2B5EF4-FFF2-40B4-BE49-F238E27FC236}">
-                <a16:creationId xmlns:a16="http://schemas.microsoft.com/office/drawing/2014/main" id="{0B574188-3875-C7EF-ABD9-B97D7E2DD6EA}"/>
+                <a16:creationId xmlns:a16="http://schemas.microsoft.com/office/drawing/2014/main" id="{34A35BE9-03F4-4B5A-078C-00877FDA14AD}"/>
               </a:ext>
             </a:extLst>
           </p:cNvPr>
@@ -10359,7 +10359,7 @@
           <p:cNvPr id="6" name="CaixaDeTexto 5">
             <a:extLst>
               <a:ext uri="{FF2B5EF4-FFF2-40B4-BE49-F238E27FC236}">
-                <a16:creationId xmlns:a16="http://schemas.microsoft.com/office/drawing/2014/main" id="{A08EE787-A984-3BEB-3AAF-922BD3BD771C}"/>
+                <a16:creationId xmlns:a16="http://schemas.microsoft.com/office/drawing/2014/main" id="{833C826C-DD05-7A33-0F0A-B49C5DAC9A98}"/>
               </a:ext>
             </a:extLst>
           </p:cNvPr>
@@ -10400,7 +10400,7 @@
           <p:cNvPr id="7" name="CaixaDeTexto 6">
             <a:extLst>
               <a:ext uri="{FF2B5EF4-FFF2-40B4-BE49-F238E27FC236}">
-                <a16:creationId xmlns:a16="http://schemas.microsoft.com/office/drawing/2014/main" id="{EFE9AA29-5798-8943-FBC4-3F711A44C99F}"/>
+                <a16:creationId xmlns:a16="http://schemas.microsoft.com/office/drawing/2014/main" id="{0AC54DC7-3E3D-A764-4583-362E8350214A}"/>
               </a:ext>
             </a:extLst>
           </p:cNvPr>
@@ -10631,7 +10631,7 @@
     </p:spTree>
     <p:extLst>
       <p:ext uri="{BB962C8B-B14F-4D97-AF65-F5344CB8AC3E}">
-        <p14:creationId xmlns:p14="http://schemas.microsoft.com/office/powerpoint/2010/main" val="1701886919"/>
+        <p14:creationId xmlns:p14="http://schemas.microsoft.com/office/powerpoint/2010/main" val="2175152031"/>
       </p:ext>
     </p:extLst>
   </p:cSld>
@@ -10694,7 +10694,7 @@
           <p:cNvPr id="2" name="CaixaDeTexto 1">
             <a:extLst>
               <a:ext uri="{FF2B5EF4-FFF2-40B4-BE49-F238E27FC236}">
-                <a16:creationId xmlns:a16="http://schemas.microsoft.com/office/drawing/2014/main" id="{618D5B4F-6DFA-CBB9-1EEA-2A805AE5A407}"/>
+                <a16:creationId xmlns:a16="http://schemas.microsoft.com/office/drawing/2014/main" id="{1E786EBF-FCDE-67F6-6F90-77F6B1BA2973}"/>
               </a:ext>
             </a:extLst>
           </p:cNvPr>
@@ -10734,7 +10734,7 @@
           <p:cNvPr id="3" name="Retângulo 2">
             <a:extLst>
               <a:ext uri="{FF2B5EF4-FFF2-40B4-BE49-F238E27FC236}">
-                <a16:creationId xmlns:a16="http://schemas.microsoft.com/office/drawing/2014/main" id="{B33683AE-56F5-0685-C0FB-55A4355CCFFA}"/>
+                <a16:creationId xmlns:a16="http://schemas.microsoft.com/office/drawing/2014/main" id="{940B2992-EE91-00E4-070F-D8DF73B01FAD}"/>
               </a:ext>
             </a:extLst>
           </p:cNvPr>
@@ -10802,7 +10802,7 @@
           <p:cNvPr id="4" name="Retângulo 3">
             <a:extLst>
               <a:ext uri="{FF2B5EF4-FFF2-40B4-BE49-F238E27FC236}">
-                <a16:creationId xmlns:a16="http://schemas.microsoft.com/office/drawing/2014/main" id="{78780AF2-9089-FE33-DA0C-91442D2C7DFD}"/>
+                <a16:creationId xmlns:a16="http://schemas.microsoft.com/office/drawing/2014/main" id="{9B704B5F-B1B3-0401-56CE-D85EE9249E1C}"/>
               </a:ext>
             </a:extLst>
           </p:cNvPr>
@@ -10870,7 +10870,7 @@
           <p:cNvPr id="5" name="CaixaDeTexto 4">
             <a:extLst>
               <a:ext uri="{FF2B5EF4-FFF2-40B4-BE49-F238E27FC236}">
-                <a16:creationId xmlns:a16="http://schemas.microsoft.com/office/drawing/2014/main" id="{C30A4AB1-3838-0EFD-DB66-C4922B627C1C}"/>
+                <a16:creationId xmlns:a16="http://schemas.microsoft.com/office/drawing/2014/main" id="{D56E3590-023F-A04F-46EB-FB5460CCC5C0}"/>
               </a:ext>
             </a:extLst>
           </p:cNvPr>
@@ -10910,7 +10910,7 @@
           <p:cNvPr id="6" name="CaixaDeTexto 5">
             <a:extLst>
               <a:ext uri="{FF2B5EF4-FFF2-40B4-BE49-F238E27FC236}">
-                <a16:creationId xmlns:a16="http://schemas.microsoft.com/office/drawing/2014/main" id="{4D94B896-273C-ADC7-911D-8D0F9C56947E}"/>
+                <a16:creationId xmlns:a16="http://schemas.microsoft.com/office/drawing/2014/main" id="{64A69813-87F7-E4D4-C100-69B8266DCD7B}"/>
               </a:ext>
             </a:extLst>
           </p:cNvPr>
@@ -10951,7 +10951,7 @@
           <p:cNvPr id="7" name="CaixaDeTexto 6">
             <a:extLst>
               <a:ext uri="{FF2B5EF4-FFF2-40B4-BE49-F238E27FC236}">
-                <a16:creationId xmlns:a16="http://schemas.microsoft.com/office/drawing/2014/main" id="{804378FF-EAF5-A798-821E-2109BBC1C22D}"/>
+                <a16:creationId xmlns:a16="http://schemas.microsoft.com/office/drawing/2014/main" id="{500794F5-C927-84F6-A202-D3AA4AF07022}"/>
               </a:ext>
             </a:extLst>
           </p:cNvPr>
@@ -11182,7 +11182,7 @@
     </p:spTree>
     <p:extLst>
       <p:ext uri="{BB962C8B-B14F-4D97-AF65-F5344CB8AC3E}">
-        <p14:creationId xmlns:p14="http://schemas.microsoft.com/office/powerpoint/2010/main" val="2575935020"/>
+        <p14:creationId xmlns:p14="http://schemas.microsoft.com/office/powerpoint/2010/main" val="3835157019"/>
       </p:ext>
     </p:extLst>
   </p:cSld>
@@ -11245,7 +11245,7 @@
           <p:cNvPr id="2" name="CaixaDeTexto 1">
             <a:extLst>
               <a:ext uri="{FF2B5EF4-FFF2-40B4-BE49-F238E27FC236}">
-                <a16:creationId xmlns:a16="http://schemas.microsoft.com/office/drawing/2014/main" id="{1196421A-468C-C293-019B-E3ECC01E8E89}"/>
+                <a16:creationId xmlns:a16="http://schemas.microsoft.com/office/drawing/2014/main" id="{FC5313A2-8061-0EC3-006D-2762EF8E7948}"/>
               </a:ext>
             </a:extLst>
           </p:cNvPr>
@@ -11285,7 +11285,7 @@
           <p:cNvPr id="3" name="Retângulo 2">
             <a:extLst>
               <a:ext uri="{FF2B5EF4-FFF2-40B4-BE49-F238E27FC236}">
-                <a16:creationId xmlns:a16="http://schemas.microsoft.com/office/drawing/2014/main" id="{5D0F3E56-3EE9-390E-D2C9-655AA5804A18}"/>
+                <a16:creationId xmlns:a16="http://schemas.microsoft.com/office/drawing/2014/main" id="{BF7CDEA3-841E-AA1B-2EE2-89D74385545B}"/>
               </a:ext>
             </a:extLst>
           </p:cNvPr>
@@ -11353,7 +11353,7 @@
           <p:cNvPr id="4" name="Retângulo 3">
             <a:extLst>
               <a:ext uri="{FF2B5EF4-FFF2-40B4-BE49-F238E27FC236}">
-                <a16:creationId xmlns:a16="http://schemas.microsoft.com/office/drawing/2014/main" id="{EF38F4C7-CD50-45C7-756F-B41A5FF3D01B}"/>
+                <a16:creationId xmlns:a16="http://schemas.microsoft.com/office/drawing/2014/main" id="{31325348-1D23-2272-B244-28A6F067973C}"/>
               </a:ext>
             </a:extLst>
           </p:cNvPr>
@@ -11421,7 +11421,7 @@
           <p:cNvPr id="5" name="CaixaDeTexto 4">
             <a:extLst>
               <a:ext uri="{FF2B5EF4-FFF2-40B4-BE49-F238E27FC236}">
-                <a16:creationId xmlns:a16="http://schemas.microsoft.com/office/drawing/2014/main" id="{2E94B223-057D-04E1-4966-A44D24B63E50}"/>
+                <a16:creationId xmlns:a16="http://schemas.microsoft.com/office/drawing/2014/main" id="{87BBC82D-22B5-CFDC-F8F3-BD1134A05553}"/>
               </a:ext>
             </a:extLst>
           </p:cNvPr>
@@ -11461,7 +11461,7 @@
           <p:cNvPr id="6" name="CaixaDeTexto 5">
             <a:extLst>
               <a:ext uri="{FF2B5EF4-FFF2-40B4-BE49-F238E27FC236}">
-                <a16:creationId xmlns:a16="http://schemas.microsoft.com/office/drawing/2014/main" id="{6028426E-1037-9B87-7AA6-481220C0AEAC}"/>
+                <a16:creationId xmlns:a16="http://schemas.microsoft.com/office/drawing/2014/main" id="{8CA23B17-9186-2681-2597-102EA93F8D34}"/>
               </a:ext>
             </a:extLst>
           </p:cNvPr>
@@ -11502,7 +11502,7 @@
           <p:cNvPr id="7" name="CaixaDeTexto 6">
             <a:extLst>
               <a:ext uri="{FF2B5EF4-FFF2-40B4-BE49-F238E27FC236}">
-                <a16:creationId xmlns:a16="http://schemas.microsoft.com/office/drawing/2014/main" id="{D3C89B2E-EE26-173A-B4C6-54989F6797E5}"/>
+                <a16:creationId xmlns:a16="http://schemas.microsoft.com/office/drawing/2014/main" id="{487DA424-C124-AB9F-D97E-61061F4A6970}"/>
               </a:ext>
             </a:extLst>
           </p:cNvPr>
@@ -11733,7 +11733,7 @@
     </p:spTree>
     <p:extLst>
       <p:ext uri="{BB962C8B-B14F-4D97-AF65-F5344CB8AC3E}">
-        <p14:creationId xmlns:p14="http://schemas.microsoft.com/office/powerpoint/2010/main" val="4153683930"/>
+        <p14:creationId xmlns:p14="http://schemas.microsoft.com/office/powerpoint/2010/main" val="2202393392"/>
       </p:ext>
     </p:extLst>
   </p:cSld>
@@ -11796,7 +11796,7 @@
           <p:cNvPr id="2" name="CaixaDeTexto 1">
             <a:extLst>
               <a:ext uri="{FF2B5EF4-FFF2-40B4-BE49-F238E27FC236}">
-                <a16:creationId xmlns:a16="http://schemas.microsoft.com/office/drawing/2014/main" id="{3829A667-6E9F-B5F8-F9C2-93E4C5EF7BBA}"/>
+                <a16:creationId xmlns:a16="http://schemas.microsoft.com/office/drawing/2014/main" id="{0A31BB71-DF6B-207C-360E-A3254A27DE55}"/>
               </a:ext>
             </a:extLst>
           </p:cNvPr>
@@ -11836,7 +11836,7 @@
           <p:cNvPr id="3" name="Retângulo 2">
             <a:extLst>
               <a:ext uri="{FF2B5EF4-FFF2-40B4-BE49-F238E27FC236}">
-                <a16:creationId xmlns:a16="http://schemas.microsoft.com/office/drawing/2014/main" id="{0F1CA96F-C297-E420-A987-628B44AAB795}"/>
+                <a16:creationId xmlns:a16="http://schemas.microsoft.com/office/drawing/2014/main" id="{4461C7B6-0E8D-6B8C-5767-32CB5AF65523}"/>
               </a:ext>
             </a:extLst>
           </p:cNvPr>
@@ -11904,7 +11904,7 @@
           <p:cNvPr id="4" name="Retângulo 3">
             <a:extLst>
               <a:ext uri="{FF2B5EF4-FFF2-40B4-BE49-F238E27FC236}">
-                <a16:creationId xmlns:a16="http://schemas.microsoft.com/office/drawing/2014/main" id="{09EE9A81-F1A2-DBB4-4161-BA1809990678}"/>
+                <a16:creationId xmlns:a16="http://schemas.microsoft.com/office/drawing/2014/main" id="{D996EBEC-499F-27F1-A815-744F7DAFE038}"/>
               </a:ext>
             </a:extLst>
           </p:cNvPr>
@@ -11972,7 +11972,7 @@
           <p:cNvPr id="5" name="CaixaDeTexto 4">
             <a:extLst>
               <a:ext uri="{FF2B5EF4-FFF2-40B4-BE49-F238E27FC236}">
-                <a16:creationId xmlns:a16="http://schemas.microsoft.com/office/drawing/2014/main" id="{EAE59108-29D7-70F8-6514-23EB95171666}"/>
+                <a16:creationId xmlns:a16="http://schemas.microsoft.com/office/drawing/2014/main" id="{B5F09D82-CA08-AC0D-D11A-E130F3DE6179}"/>
               </a:ext>
             </a:extLst>
           </p:cNvPr>
@@ -12012,7 +12012,7 @@
           <p:cNvPr id="6" name="CaixaDeTexto 5">
             <a:extLst>
               <a:ext uri="{FF2B5EF4-FFF2-40B4-BE49-F238E27FC236}">
-                <a16:creationId xmlns:a16="http://schemas.microsoft.com/office/drawing/2014/main" id="{5B0B5CE5-DA22-3970-9D19-EA6F375EFCA7}"/>
+                <a16:creationId xmlns:a16="http://schemas.microsoft.com/office/drawing/2014/main" id="{D45F9C36-1B0F-237B-AF5D-929E58070588}"/>
               </a:ext>
             </a:extLst>
           </p:cNvPr>
@@ -12053,7 +12053,7 @@
           <p:cNvPr id="7" name="Tabela 6">
             <a:extLst>
               <a:ext uri="{FF2B5EF4-FFF2-40B4-BE49-F238E27FC236}">
-                <a16:creationId xmlns:a16="http://schemas.microsoft.com/office/drawing/2014/main" id="{ACEB7E33-E80B-2267-4B9B-75B30F7B82D3}"/>
+                <a16:creationId xmlns:a16="http://schemas.microsoft.com/office/drawing/2014/main" id="{C0263DC8-15F4-92E3-3F6E-FB83DCC245B5}"/>
               </a:ext>
             </a:extLst>
           </p:cNvPr>
@@ -12063,7 +12063,7 @@
           <p:nvPr>
             <p:extLst>
               <p:ext uri="{D42A27DB-BD31-4B8C-83A1-F6EECF244321}">
-                <p14:modId xmlns:p14="http://schemas.microsoft.com/office/powerpoint/2010/main" val="1072908673"/>
+                <p14:modId xmlns:p14="http://schemas.microsoft.com/office/powerpoint/2010/main" val="3105129147"/>
               </p:ext>
             </p:extLst>
           </p:nvPr>
@@ -12082,21 +12082,21 @@
                 <a:gridCol w="3810000">
                   <a:extLst>
                     <a:ext uri="{9D8B030D-6E8A-4147-A177-3AD203B41FA5}">
-                      <a16:colId xmlns:a16="http://schemas.microsoft.com/office/drawing/2014/main" val="1795700182"/>
+                      <a16:colId xmlns:a16="http://schemas.microsoft.com/office/drawing/2014/main" val="3440613077"/>
                     </a:ext>
                   </a:extLst>
                 </a:gridCol>
                 <a:gridCol w="3048000">
                   <a:extLst>
                     <a:ext uri="{9D8B030D-6E8A-4147-A177-3AD203B41FA5}">
-                      <a16:colId xmlns:a16="http://schemas.microsoft.com/office/drawing/2014/main" val="2173204960"/>
+                      <a16:colId xmlns:a16="http://schemas.microsoft.com/office/drawing/2014/main" val="2025571836"/>
                     </a:ext>
                   </a:extLst>
                 </a:gridCol>
                 <a:gridCol w="3810000">
                   <a:extLst>
                     <a:ext uri="{9D8B030D-6E8A-4147-A177-3AD203B41FA5}">
-                      <a16:colId xmlns:a16="http://schemas.microsoft.com/office/drawing/2014/main" val="287324697"/>
+                      <a16:colId xmlns:a16="http://schemas.microsoft.com/office/drawing/2014/main" val="2730843812"/>
                     </a:ext>
                   </a:extLst>
                 </a:gridCol>
@@ -12173,7 +12173,7 @@
                 </a:tc>
                 <a:extLst>
                   <a:ext uri="{0D108BD9-81ED-4DB2-BD59-A6C34878D82A}">
-                    <a16:rowId xmlns:a16="http://schemas.microsoft.com/office/drawing/2014/main" val="2510886133"/>
+                    <a16:rowId xmlns:a16="http://schemas.microsoft.com/office/drawing/2014/main" val="3720913535"/>
                   </a:ext>
                 </a:extLst>
               </a:tr>
@@ -12249,7 +12249,7 @@
                 </a:tc>
                 <a:extLst>
                   <a:ext uri="{0D108BD9-81ED-4DB2-BD59-A6C34878D82A}">
-                    <a16:rowId xmlns:a16="http://schemas.microsoft.com/office/drawing/2014/main" val="2942917878"/>
+                    <a16:rowId xmlns:a16="http://schemas.microsoft.com/office/drawing/2014/main" val="4275198258"/>
                   </a:ext>
                 </a:extLst>
               </a:tr>
@@ -12325,7 +12325,7 @@
                 </a:tc>
                 <a:extLst>
                   <a:ext uri="{0D108BD9-81ED-4DB2-BD59-A6C34878D82A}">
-                    <a16:rowId xmlns:a16="http://schemas.microsoft.com/office/drawing/2014/main" val="1027283712"/>
+                    <a16:rowId xmlns:a16="http://schemas.microsoft.com/office/drawing/2014/main" val="813022140"/>
                   </a:ext>
                 </a:extLst>
               </a:tr>
@@ -12401,7 +12401,7 @@
                 </a:tc>
                 <a:extLst>
                   <a:ext uri="{0D108BD9-81ED-4DB2-BD59-A6C34878D82A}">
-                    <a16:rowId xmlns:a16="http://schemas.microsoft.com/office/drawing/2014/main" val="958162802"/>
+                    <a16:rowId xmlns:a16="http://schemas.microsoft.com/office/drawing/2014/main" val="3317343820"/>
                   </a:ext>
                 </a:extLst>
               </a:tr>
@@ -12477,7 +12477,7 @@
                 </a:tc>
                 <a:extLst>
                   <a:ext uri="{0D108BD9-81ED-4DB2-BD59-A6C34878D82A}">
-                    <a16:rowId xmlns:a16="http://schemas.microsoft.com/office/drawing/2014/main" val="3868485546"/>
+                    <a16:rowId xmlns:a16="http://schemas.microsoft.com/office/drawing/2014/main" val="2214186494"/>
                   </a:ext>
                 </a:extLst>
               </a:tr>
@@ -12553,7 +12553,7 @@
                 </a:tc>
                 <a:extLst>
                   <a:ext uri="{0D108BD9-81ED-4DB2-BD59-A6C34878D82A}">
-                    <a16:rowId xmlns:a16="http://schemas.microsoft.com/office/drawing/2014/main" val="270547480"/>
+                    <a16:rowId xmlns:a16="http://schemas.microsoft.com/office/drawing/2014/main" val="1286239150"/>
                   </a:ext>
                 </a:extLst>
               </a:tr>
@@ -12629,7 +12629,7 @@
                 </a:tc>
                 <a:extLst>
                   <a:ext uri="{0D108BD9-81ED-4DB2-BD59-A6C34878D82A}">
-                    <a16:rowId xmlns:a16="http://schemas.microsoft.com/office/drawing/2014/main" val="379753266"/>
+                    <a16:rowId xmlns:a16="http://schemas.microsoft.com/office/drawing/2014/main" val="205755426"/>
                   </a:ext>
                 </a:extLst>
               </a:tr>
@@ -12711,7 +12711,7 @@
                 </a:tc>
                 <a:extLst>
                   <a:ext uri="{0D108BD9-81ED-4DB2-BD59-A6C34878D82A}">
-                    <a16:rowId xmlns:a16="http://schemas.microsoft.com/office/drawing/2014/main" val="636637916"/>
+                    <a16:rowId xmlns:a16="http://schemas.microsoft.com/office/drawing/2014/main" val="3529302818"/>
                   </a:ext>
                 </a:extLst>
               </a:tr>
@@ -12787,7 +12787,7 @@
                 </a:tc>
                 <a:extLst>
                   <a:ext uri="{0D108BD9-81ED-4DB2-BD59-A6C34878D82A}">
-                    <a16:rowId xmlns:a16="http://schemas.microsoft.com/office/drawing/2014/main" val="825792279"/>
+                    <a16:rowId xmlns:a16="http://schemas.microsoft.com/office/drawing/2014/main" val="2130241565"/>
                   </a:ext>
                 </a:extLst>
               </a:tr>
@@ -12800,7 +12800,7 @@
           <p:cNvPr id="8" name="CaixaDeTexto 7">
             <a:extLst>
               <a:ext uri="{FF2B5EF4-FFF2-40B4-BE49-F238E27FC236}">
-                <a16:creationId xmlns:a16="http://schemas.microsoft.com/office/drawing/2014/main" id="{5A031867-9DAD-3C8B-E940-0CA43EB16922}"/>
+                <a16:creationId xmlns:a16="http://schemas.microsoft.com/office/drawing/2014/main" id="{1486E95B-F4AE-CED3-D8FA-B4EA16E898A7}"/>
               </a:ext>
             </a:extLst>
           </p:cNvPr>
@@ -12838,7 +12838,7 @@
     </p:spTree>
     <p:extLst>
       <p:ext uri="{BB962C8B-B14F-4D97-AF65-F5344CB8AC3E}">
-        <p14:creationId xmlns:p14="http://schemas.microsoft.com/office/powerpoint/2010/main" val="3135109904"/>
+        <p14:creationId xmlns:p14="http://schemas.microsoft.com/office/powerpoint/2010/main" val="842269670"/>
       </p:ext>
     </p:extLst>
   </p:cSld>
@@ -12901,7 +12901,7 @@
           <p:cNvPr id="2" name="CaixaDeTexto 1">
             <a:extLst>
               <a:ext uri="{FF2B5EF4-FFF2-40B4-BE49-F238E27FC236}">
-                <a16:creationId xmlns:a16="http://schemas.microsoft.com/office/drawing/2014/main" id="{E544C29E-53D5-3675-6912-BD1DEE51BF6B}"/>
+                <a16:creationId xmlns:a16="http://schemas.microsoft.com/office/drawing/2014/main" id="{A672DBB5-EF14-BA3A-2FB5-2C181866780B}"/>
               </a:ext>
             </a:extLst>
           </p:cNvPr>
@@ -12941,7 +12941,7 @@
           <p:cNvPr id="3" name="Retângulo 2">
             <a:extLst>
               <a:ext uri="{FF2B5EF4-FFF2-40B4-BE49-F238E27FC236}">
-                <a16:creationId xmlns:a16="http://schemas.microsoft.com/office/drawing/2014/main" id="{330648B2-81DE-1A04-7169-46F09F37D4F8}"/>
+                <a16:creationId xmlns:a16="http://schemas.microsoft.com/office/drawing/2014/main" id="{4DF09C33-CAC5-C12C-D0B2-B88893CD696F}"/>
               </a:ext>
             </a:extLst>
           </p:cNvPr>
@@ -13009,7 +13009,7 @@
           <p:cNvPr id="4" name="Retângulo 3">
             <a:extLst>
               <a:ext uri="{FF2B5EF4-FFF2-40B4-BE49-F238E27FC236}">
-                <a16:creationId xmlns:a16="http://schemas.microsoft.com/office/drawing/2014/main" id="{F6901E2E-1577-0DDD-BA89-DF4A2CA9340D}"/>
+                <a16:creationId xmlns:a16="http://schemas.microsoft.com/office/drawing/2014/main" id="{3E25E638-55CF-A57E-EC30-65ED4BC4327A}"/>
               </a:ext>
             </a:extLst>
           </p:cNvPr>
@@ -13077,7 +13077,7 @@
           <p:cNvPr id="5" name="CaixaDeTexto 4">
             <a:extLst>
               <a:ext uri="{FF2B5EF4-FFF2-40B4-BE49-F238E27FC236}">
-                <a16:creationId xmlns:a16="http://schemas.microsoft.com/office/drawing/2014/main" id="{92711AF9-3368-37B3-6BA6-55D3A61DACCF}"/>
+                <a16:creationId xmlns:a16="http://schemas.microsoft.com/office/drawing/2014/main" id="{DBF5FEDD-7F2B-C9F8-5CCD-B3CEA1FB69E8}"/>
               </a:ext>
             </a:extLst>
           </p:cNvPr>
@@ -13117,7 +13117,7 @@
           <p:cNvPr id="6" name="CaixaDeTexto 5">
             <a:extLst>
               <a:ext uri="{FF2B5EF4-FFF2-40B4-BE49-F238E27FC236}">
-                <a16:creationId xmlns:a16="http://schemas.microsoft.com/office/drawing/2014/main" id="{D1789664-B5A2-0007-C9EF-E2939C0E4D4C}"/>
+                <a16:creationId xmlns:a16="http://schemas.microsoft.com/office/drawing/2014/main" id="{854EC72A-0A71-C5B6-3546-20A3C547B04F}"/>
               </a:ext>
             </a:extLst>
           </p:cNvPr>
@@ -13158,7 +13158,7 @@
           <p:cNvPr id="7" name="Retângulo: Cantos Arredondados 6">
             <a:extLst>
               <a:ext uri="{FF2B5EF4-FFF2-40B4-BE49-F238E27FC236}">
-                <a16:creationId xmlns:a16="http://schemas.microsoft.com/office/drawing/2014/main" id="{0E10B3B4-8F29-E40A-CED9-F840D767E081}"/>
+                <a16:creationId xmlns:a16="http://schemas.microsoft.com/office/drawing/2014/main" id="{2DF759D2-3828-D2AA-276B-7E1B2D9FBE8A}"/>
               </a:ext>
             </a:extLst>
           </p:cNvPr>
@@ -13212,7 +13212,7 @@
           <p:cNvPr id="8" name="CaixaDeTexto 7">
             <a:extLst>
               <a:ext uri="{FF2B5EF4-FFF2-40B4-BE49-F238E27FC236}">
-                <a16:creationId xmlns:a16="http://schemas.microsoft.com/office/drawing/2014/main" id="{F945477B-009E-3F70-9E20-D31B8048D11A}"/>
+                <a16:creationId xmlns:a16="http://schemas.microsoft.com/office/drawing/2014/main" id="{2AC66CB8-D242-E366-5195-29A842847D62}"/>
               </a:ext>
             </a:extLst>
           </p:cNvPr>
@@ -13252,7 +13252,7 @@
           <p:cNvPr id="9" name="CaixaDeTexto 8">
             <a:extLst>
               <a:ext uri="{FF2B5EF4-FFF2-40B4-BE49-F238E27FC236}">
-                <a16:creationId xmlns:a16="http://schemas.microsoft.com/office/drawing/2014/main" id="{B5E76711-2220-7EC4-3A75-C0FA4F2F0AD0}"/>
+                <a16:creationId xmlns:a16="http://schemas.microsoft.com/office/drawing/2014/main" id="{B5B90D99-2EC4-C9CC-C283-307A9806B9EB}"/>
               </a:ext>
             </a:extLst>
           </p:cNvPr>
@@ -13361,7 +13361,7 @@
           <p:cNvPr id="10" name="Retângulo: Cantos Arredondados 9">
             <a:extLst>
               <a:ext uri="{FF2B5EF4-FFF2-40B4-BE49-F238E27FC236}">
-                <a16:creationId xmlns:a16="http://schemas.microsoft.com/office/drawing/2014/main" id="{911FC4EC-61D2-C04F-96DE-C7DFEBC3A97C}"/>
+                <a16:creationId xmlns:a16="http://schemas.microsoft.com/office/drawing/2014/main" id="{79B1C33B-1438-C7BA-E5A7-179F0445C015}"/>
               </a:ext>
             </a:extLst>
           </p:cNvPr>
@@ -13415,7 +13415,7 @@
           <p:cNvPr id="11" name="CaixaDeTexto 10">
             <a:extLst>
               <a:ext uri="{FF2B5EF4-FFF2-40B4-BE49-F238E27FC236}">
-                <a16:creationId xmlns:a16="http://schemas.microsoft.com/office/drawing/2014/main" id="{7D20F359-E686-32F7-8FB5-00B17AC97C5D}"/>
+                <a16:creationId xmlns:a16="http://schemas.microsoft.com/office/drawing/2014/main" id="{5BC70DEF-185F-C722-197B-D721F6E0465D}"/>
               </a:ext>
             </a:extLst>
           </p:cNvPr>
@@ -13455,7 +13455,7 @@
           <p:cNvPr id="12" name="CaixaDeTexto 11">
             <a:extLst>
               <a:ext uri="{FF2B5EF4-FFF2-40B4-BE49-F238E27FC236}">
-                <a16:creationId xmlns:a16="http://schemas.microsoft.com/office/drawing/2014/main" id="{E203DB75-D98B-1AA2-35B5-7E971BDB07C0}"/>
+                <a16:creationId xmlns:a16="http://schemas.microsoft.com/office/drawing/2014/main" id="{33F03966-28BC-2FB2-0381-A72A0ED0D832}"/>
               </a:ext>
             </a:extLst>
           </p:cNvPr>
@@ -13564,7 +13564,7 @@
           <p:cNvPr id="13" name="Retângulo: Cantos Arredondados 12">
             <a:extLst>
               <a:ext uri="{FF2B5EF4-FFF2-40B4-BE49-F238E27FC236}">
-                <a16:creationId xmlns:a16="http://schemas.microsoft.com/office/drawing/2014/main" id="{006B1413-1AB8-1E03-F3D8-E8C36EF4016E}"/>
+                <a16:creationId xmlns:a16="http://schemas.microsoft.com/office/drawing/2014/main" id="{058E496F-EC8F-2953-92CC-B9B7D27F6B7C}"/>
               </a:ext>
             </a:extLst>
           </p:cNvPr>
@@ -13618,7 +13618,7 @@
           <p:cNvPr id="14" name="CaixaDeTexto 13">
             <a:extLst>
               <a:ext uri="{FF2B5EF4-FFF2-40B4-BE49-F238E27FC236}">
-                <a16:creationId xmlns:a16="http://schemas.microsoft.com/office/drawing/2014/main" id="{92219798-783C-EA51-5195-E02E28D4DB5A}"/>
+                <a16:creationId xmlns:a16="http://schemas.microsoft.com/office/drawing/2014/main" id="{EF651B9E-163D-0BC9-E1F1-F4E70BD626C0}"/>
               </a:ext>
             </a:extLst>
           </p:cNvPr>
@@ -13656,7 +13656,7 @@
     </p:spTree>
     <p:extLst>
       <p:ext uri="{BB962C8B-B14F-4D97-AF65-F5344CB8AC3E}">
-        <p14:creationId xmlns:p14="http://schemas.microsoft.com/office/powerpoint/2010/main" val="3952539062"/>
+        <p14:creationId xmlns:p14="http://schemas.microsoft.com/office/powerpoint/2010/main" val="3830244310"/>
       </p:ext>
     </p:extLst>
   </p:cSld>
@@ -13719,7 +13719,7 @@
           <p:cNvPr id="2" name="CaixaDeTexto 1">
             <a:extLst>
               <a:ext uri="{FF2B5EF4-FFF2-40B4-BE49-F238E27FC236}">
-                <a16:creationId xmlns:a16="http://schemas.microsoft.com/office/drawing/2014/main" id="{E1856B27-ABE1-956C-7F1B-94C25438E786}"/>
+                <a16:creationId xmlns:a16="http://schemas.microsoft.com/office/drawing/2014/main" id="{01B99F15-C70A-78E9-0A30-00BD3CE38AC3}"/>
               </a:ext>
             </a:extLst>
           </p:cNvPr>
@@ -13759,7 +13759,7 @@
           <p:cNvPr id="3" name="Retângulo 2">
             <a:extLst>
               <a:ext uri="{FF2B5EF4-FFF2-40B4-BE49-F238E27FC236}">
-                <a16:creationId xmlns:a16="http://schemas.microsoft.com/office/drawing/2014/main" id="{47B78300-0A17-33CF-975D-670A847552B8}"/>
+                <a16:creationId xmlns:a16="http://schemas.microsoft.com/office/drawing/2014/main" id="{B0ED041A-079D-D083-A322-C3C5A85CD851}"/>
               </a:ext>
             </a:extLst>
           </p:cNvPr>
@@ -13827,7 +13827,7 @@
           <p:cNvPr id="4" name="Retângulo 3">
             <a:extLst>
               <a:ext uri="{FF2B5EF4-FFF2-40B4-BE49-F238E27FC236}">
-                <a16:creationId xmlns:a16="http://schemas.microsoft.com/office/drawing/2014/main" id="{E3D31B42-26A7-EDB2-6308-DB7DB293DD3E}"/>
+                <a16:creationId xmlns:a16="http://schemas.microsoft.com/office/drawing/2014/main" id="{AE31E42E-C579-AD67-A36B-854EA540F6A1}"/>
               </a:ext>
             </a:extLst>
           </p:cNvPr>
@@ -13895,7 +13895,7 @@
           <p:cNvPr id="5" name="CaixaDeTexto 4">
             <a:extLst>
               <a:ext uri="{FF2B5EF4-FFF2-40B4-BE49-F238E27FC236}">
-                <a16:creationId xmlns:a16="http://schemas.microsoft.com/office/drawing/2014/main" id="{F831FC47-8091-4142-3703-08085682E490}"/>
+                <a16:creationId xmlns:a16="http://schemas.microsoft.com/office/drawing/2014/main" id="{D8596399-3305-8BC3-6D8C-0C437D40CDEF}"/>
               </a:ext>
             </a:extLst>
           </p:cNvPr>
@@ -13935,7 +13935,7 @@
           <p:cNvPr id="6" name="CaixaDeTexto 5">
             <a:extLst>
               <a:ext uri="{FF2B5EF4-FFF2-40B4-BE49-F238E27FC236}">
-                <a16:creationId xmlns:a16="http://schemas.microsoft.com/office/drawing/2014/main" id="{22925AAC-1BF6-32FB-D9B2-A2A587049AE9}"/>
+                <a16:creationId xmlns:a16="http://schemas.microsoft.com/office/drawing/2014/main" id="{ADAF2561-B9A9-E3BC-6DE6-C8886EC30D1F}"/>
               </a:ext>
             </a:extLst>
           </p:cNvPr>
@@ -13976,7 +13976,7 @@
           <p:cNvPr id="7" name="Tabela 6">
             <a:extLst>
               <a:ext uri="{FF2B5EF4-FFF2-40B4-BE49-F238E27FC236}">
-                <a16:creationId xmlns:a16="http://schemas.microsoft.com/office/drawing/2014/main" id="{76854704-BF80-D231-09F0-016AA58CBAA8}"/>
+                <a16:creationId xmlns:a16="http://schemas.microsoft.com/office/drawing/2014/main" id="{FC98C32F-1325-5297-D088-D43DB1FA2A4E}"/>
               </a:ext>
             </a:extLst>
           </p:cNvPr>
@@ -13986,7 +13986,7 @@
           <p:nvPr>
             <p:extLst>
               <p:ext uri="{D42A27DB-BD31-4B8C-83A1-F6EECF244321}">
-                <p14:modId xmlns:p14="http://schemas.microsoft.com/office/powerpoint/2010/main" val="2244256028"/>
+                <p14:modId xmlns:p14="http://schemas.microsoft.com/office/powerpoint/2010/main" val="177724111"/>
               </p:ext>
             </p:extLst>
           </p:nvPr>
@@ -14005,14 +14005,14 @@
                 <a:gridCol w="2540000">
                   <a:extLst>
                     <a:ext uri="{9D8B030D-6E8A-4147-A177-3AD203B41FA5}">
-                      <a16:colId xmlns:a16="http://schemas.microsoft.com/office/drawing/2014/main" val="1280565264"/>
+                      <a16:colId xmlns:a16="http://schemas.microsoft.com/office/drawing/2014/main" val="1733331501"/>
                     </a:ext>
                   </a:extLst>
                 </a:gridCol>
                 <a:gridCol w="8128000">
                   <a:extLst>
                     <a:ext uri="{9D8B030D-6E8A-4147-A177-3AD203B41FA5}">
-                      <a16:colId xmlns:a16="http://schemas.microsoft.com/office/drawing/2014/main" val="1701758709"/>
+                      <a16:colId xmlns:a16="http://schemas.microsoft.com/office/drawing/2014/main" val="1041378117"/>
                     </a:ext>
                   </a:extLst>
                 </a:gridCol>
@@ -14066,7 +14066,7 @@
                 </a:tc>
                 <a:extLst>
                   <a:ext uri="{0D108BD9-81ED-4DB2-BD59-A6C34878D82A}">
-                    <a16:rowId xmlns:a16="http://schemas.microsoft.com/office/drawing/2014/main" val="2238700001"/>
+                    <a16:rowId xmlns:a16="http://schemas.microsoft.com/office/drawing/2014/main" val="2971534650"/>
                   </a:ext>
                 </a:extLst>
               </a:tr>
@@ -14119,7 +14119,7 @@
                 </a:tc>
                 <a:extLst>
                   <a:ext uri="{0D108BD9-81ED-4DB2-BD59-A6C34878D82A}">
-                    <a16:rowId xmlns:a16="http://schemas.microsoft.com/office/drawing/2014/main" val="2535409495"/>
+                    <a16:rowId xmlns:a16="http://schemas.microsoft.com/office/drawing/2014/main" val="1115404525"/>
                   </a:ext>
                 </a:extLst>
               </a:tr>
@@ -14172,7 +14172,7 @@
                 </a:tc>
                 <a:extLst>
                   <a:ext uri="{0D108BD9-81ED-4DB2-BD59-A6C34878D82A}">
-                    <a16:rowId xmlns:a16="http://schemas.microsoft.com/office/drawing/2014/main" val="482483181"/>
+                    <a16:rowId xmlns:a16="http://schemas.microsoft.com/office/drawing/2014/main" val="37718801"/>
                   </a:ext>
                 </a:extLst>
               </a:tr>
@@ -14225,7 +14225,7 @@
                 </a:tc>
                 <a:extLst>
                   <a:ext uri="{0D108BD9-81ED-4DB2-BD59-A6C34878D82A}">
-                    <a16:rowId xmlns:a16="http://schemas.microsoft.com/office/drawing/2014/main" val="1844930551"/>
+                    <a16:rowId xmlns:a16="http://schemas.microsoft.com/office/drawing/2014/main" val="2976096009"/>
                   </a:ext>
                 </a:extLst>
               </a:tr>
@@ -14278,7 +14278,7 @@
                 </a:tc>
                 <a:extLst>
                   <a:ext uri="{0D108BD9-81ED-4DB2-BD59-A6C34878D82A}">
-                    <a16:rowId xmlns:a16="http://schemas.microsoft.com/office/drawing/2014/main" val="515474936"/>
+                    <a16:rowId xmlns:a16="http://schemas.microsoft.com/office/drawing/2014/main" val="3274698267"/>
                   </a:ext>
                 </a:extLst>
               </a:tr>
@@ -14331,7 +14331,7 @@
                 </a:tc>
                 <a:extLst>
                   <a:ext uri="{0D108BD9-81ED-4DB2-BD59-A6C34878D82A}">
-                    <a16:rowId xmlns:a16="http://schemas.microsoft.com/office/drawing/2014/main" val="3749212094"/>
+                    <a16:rowId xmlns:a16="http://schemas.microsoft.com/office/drawing/2014/main" val="4264401957"/>
                   </a:ext>
                 </a:extLst>
               </a:tr>
@@ -14384,7 +14384,7 @@
                 </a:tc>
                 <a:extLst>
                   <a:ext uri="{0D108BD9-81ED-4DB2-BD59-A6C34878D82A}">
-                    <a16:rowId xmlns:a16="http://schemas.microsoft.com/office/drawing/2014/main" val="2371625602"/>
+                    <a16:rowId xmlns:a16="http://schemas.microsoft.com/office/drawing/2014/main" val="2759149963"/>
                   </a:ext>
                 </a:extLst>
               </a:tr>
@@ -14437,7 +14437,7 @@
                 </a:tc>
                 <a:extLst>
                   <a:ext uri="{0D108BD9-81ED-4DB2-BD59-A6C34878D82A}">
-                    <a16:rowId xmlns:a16="http://schemas.microsoft.com/office/drawing/2014/main" val="3119952038"/>
+                    <a16:rowId xmlns:a16="http://schemas.microsoft.com/office/drawing/2014/main" val="1694672915"/>
                   </a:ext>
                 </a:extLst>
               </a:tr>
@@ -14450,7 +14450,7 @@
           <p:cNvPr id="8" name="Retângulo: Cantos Arredondados 7">
             <a:extLst>
               <a:ext uri="{FF2B5EF4-FFF2-40B4-BE49-F238E27FC236}">
-                <a16:creationId xmlns:a16="http://schemas.microsoft.com/office/drawing/2014/main" id="{D62A5C78-AD21-DEAA-3568-9C091B10A273}"/>
+                <a16:creationId xmlns:a16="http://schemas.microsoft.com/office/drawing/2014/main" id="{3FE44CB5-186E-C61F-D947-CFDFAD801E4C}"/>
               </a:ext>
             </a:extLst>
           </p:cNvPr>
@@ -14504,7 +14504,7 @@
           <p:cNvPr id="9" name="CaixaDeTexto 8">
             <a:extLst>
               <a:ext uri="{FF2B5EF4-FFF2-40B4-BE49-F238E27FC236}">
-                <a16:creationId xmlns:a16="http://schemas.microsoft.com/office/drawing/2014/main" id="{6790C404-B912-A562-39A6-C0CF85E8F3B1}"/>
+                <a16:creationId xmlns:a16="http://schemas.microsoft.com/office/drawing/2014/main" id="{B7D4094D-4A65-0360-6799-050592008E3A}"/>
               </a:ext>
             </a:extLst>
           </p:cNvPr>
@@ -14542,7 +14542,7 @@
     </p:spTree>
     <p:extLst>
       <p:ext uri="{BB962C8B-B14F-4D97-AF65-F5344CB8AC3E}">
-        <p14:creationId xmlns:p14="http://schemas.microsoft.com/office/powerpoint/2010/main" val="2722261580"/>
+        <p14:creationId xmlns:p14="http://schemas.microsoft.com/office/powerpoint/2010/main" val="464553703"/>
       </p:ext>
     </p:extLst>
   </p:cSld>
@@ -14605,7 +14605,7 @@
           <p:cNvPr id="2" name="CaixaDeTexto 1">
             <a:extLst>
               <a:ext uri="{FF2B5EF4-FFF2-40B4-BE49-F238E27FC236}">
-                <a16:creationId xmlns:a16="http://schemas.microsoft.com/office/drawing/2014/main" id="{3B122E7E-8FEA-0D1C-C129-5D1E3140CA3F}"/>
+                <a16:creationId xmlns:a16="http://schemas.microsoft.com/office/drawing/2014/main" id="{231AC73F-2C76-F48B-9329-B3F167DC60B3}"/>
               </a:ext>
             </a:extLst>
           </p:cNvPr>
@@ -14645,7 +14645,7 @@
           <p:cNvPr id="3" name="Retângulo 2">
             <a:extLst>
               <a:ext uri="{FF2B5EF4-FFF2-40B4-BE49-F238E27FC236}">
-                <a16:creationId xmlns:a16="http://schemas.microsoft.com/office/drawing/2014/main" id="{8E0F8553-9E6C-9F67-30D6-CAF3EA7E304E}"/>
+                <a16:creationId xmlns:a16="http://schemas.microsoft.com/office/drawing/2014/main" id="{4021CF7E-16CA-C71B-19D5-D6261DD274D8}"/>
               </a:ext>
             </a:extLst>
           </p:cNvPr>
@@ -14713,7 +14713,7 @@
           <p:cNvPr id="4" name="Retângulo 3">
             <a:extLst>
               <a:ext uri="{FF2B5EF4-FFF2-40B4-BE49-F238E27FC236}">
-                <a16:creationId xmlns:a16="http://schemas.microsoft.com/office/drawing/2014/main" id="{FEF5DA27-D19E-F7CE-2218-5C6C8520FFBE}"/>
+                <a16:creationId xmlns:a16="http://schemas.microsoft.com/office/drawing/2014/main" id="{5071D97D-26D4-16CA-8C6A-10FEA4374E8D}"/>
               </a:ext>
             </a:extLst>
           </p:cNvPr>
@@ -14781,7 +14781,7 @@
           <p:cNvPr id="5" name="CaixaDeTexto 4">
             <a:extLst>
               <a:ext uri="{FF2B5EF4-FFF2-40B4-BE49-F238E27FC236}">
-                <a16:creationId xmlns:a16="http://schemas.microsoft.com/office/drawing/2014/main" id="{918783DF-22CF-A8C4-062E-0B993CBF5ADD}"/>
+                <a16:creationId xmlns:a16="http://schemas.microsoft.com/office/drawing/2014/main" id="{972256B2-5022-F474-E695-0232DBE31099}"/>
               </a:ext>
             </a:extLst>
           </p:cNvPr>
@@ -14821,7 +14821,7 @@
           <p:cNvPr id="6" name="CaixaDeTexto 5">
             <a:extLst>
               <a:ext uri="{FF2B5EF4-FFF2-40B4-BE49-F238E27FC236}">
-                <a16:creationId xmlns:a16="http://schemas.microsoft.com/office/drawing/2014/main" id="{0367F6DF-7240-7895-4C93-B286D74C4850}"/>
+                <a16:creationId xmlns:a16="http://schemas.microsoft.com/office/drawing/2014/main" id="{60B90169-B68F-875A-FFB2-D7762FAB106A}"/>
               </a:ext>
             </a:extLst>
           </p:cNvPr>
@@ -14862,7 +14862,7 @@
           <p:cNvPr id="7" name="Retângulo: Cantos Arredondados 6">
             <a:extLst>
               <a:ext uri="{FF2B5EF4-FFF2-40B4-BE49-F238E27FC236}">
-                <a16:creationId xmlns:a16="http://schemas.microsoft.com/office/drawing/2014/main" id="{90D94793-C992-F6D9-B922-AC95363ACA1C}"/>
+                <a16:creationId xmlns:a16="http://schemas.microsoft.com/office/drawing/2014/main" id="{5215A86F-33D2-39D1-4A5E-682017119716}"/>
               </a:ext>
             </a:extLst>
           </p:cNvPr>
@@ -14916,7 +14916,7 @@
           <p:cNvPr id="8" name="CaixaDeTexto 7">
             <a:extLst>
               <a:ext uri="{FF2B5EF4-FFF2-40B4-BE49-F238E27FC236}">
-                <a16:creationId xmlns:a16="http://schemas.microsoft.com/office/drawing/2014/main" id="{F904CA30-0839-FBD8-B04A-3982A9C15D7F}"/>
+                <a16:creationId xmlns:a16="http://schemas.microsoft.com/office/drawing/2014/main" id="{E9A32826-74F0-5AE6-0DF0-1B8CC112F508}"/>
               </a:ext>
             </a:extLst>
           </p:cNvPr>
@@ -14956,7 +14956,7 @@
           <p:cNvPr id="9" name="CaixaDeTexto 8">
             <a:extLst>
               <a:ext uri="{FF2B5EF4-FFF2-40B4-BE49-F238E27FC236}">
-                <a16:creationId xmlns:a16="http://schemas.microsoft.com/office/drawing/2014/main" id="{CEA52F48-E82F-B481-BFA4-9B412AE10A74}"/>
+                <a16:creationId xmlns:a16="http://schemas.microsoft.com/office/drawing/2014/main" id="{A6FFF1DF-7E22-467C-5410-77C2C4347139}"/>
               </a:ext>
             </a:extLst>
           </p:cNvPr>
@@ -15065,7 +15065,7 @@
           <p:cNvPr id="10" name="Retângulo: Cantos Arredondados 9">
             <a:extLst>
               <a:ext uri="{FF2B5EF4-FFF2-40B4-BE49-F238E27FC236}">
-                <a16:creationId xmlns:a16="http://schemas.microsoft.com/office/drawing/2014/main" id="{20789B70-5549-8F4D-C18C-E68FB19FAAA5}"/>
+                <a16:creationId xmlns:a16="http://schemas.microsoft.com/office/drawing/2014/main" id="{CE57088E-2B79-42FD-22E4-D9C3F4C82575}"/>
               </a:ext>
             </a:extLst>
           </p:cNvPr>
@@ -15119,7 +15119,7 @@
           <p:cNvPr id="11" name="CaixaDeTexto 10">
             <a:extLst>
               <a:ext uri="{FF2B5EF4-FFF2-40B4-BE49-F238E27FC236}">
-                <a16:creationId xmlns:a16="http://schemas.microsoft.com/office/drawing/2014/main" id="{E4FA3C90-3A28-837A-7081-E0FDA6F75F68}"/>
+                <a16:creationId xmlns:a16="http://schemas.microsoft.com/office/drawing/2014/main" id="{C00CD1D7-6C8B-6566-B111-1CE8F8444695}"/>
               </a:ext>
             </a:extLst>
           </p:cNvPr>
@@ -15159,7 +15159,7 @@
           <p:cNvPr id="12" name="CaixaDeTexto 11">
             <a:extLst>
               <a:ext uri="{FF2B5EF4-FFF2-40B4-BE49-F238E27FC236}">
-                <a16:creationId xmlns:a16="http://schemas.microsoft.com/office/drawing/2014/main" id="{A1CC90CD-276B-3A86-7989-09559861C997}"/>
+                <a16:creationId xmlns:a16="http://schemas.microsoft.com/office/drawing/2014/main" id="{92DB9B09-AA8E-9FD6-D354-F1C609FD47A8}"/>
               </a:ext>
             </a:extLst>
           </p:cNvPr>
@@ -15268,7 +15268,7 @@
           <p:cNvPr id="13" name="Retângulo: Cantos Arredondados 12">
             <a:extLst>
               <a:ext uri="{FF2B5EF4-FFF2-40B4-BE49-F238E27FC236}">
-                <a16:creationId xmlns:a16="http://schemas.microsoft.com/office/drawing/2014/main" id="{CF3DD7E6-A353-353A-575E-B5532F87D4B5}"/>
+                <a16:creationId xmlns:a16="http://schemas.microsoft.com/office/drawing/2014/main" id="{824BC6AC-D556-B4A4-1DE7-A22FBB194328}"/>
               </a:ext>
             </a:extLst>
           </p:cNvPr>
@@ -15322,7 +15322,7 @@
           <p:cNvPr id="14" name="CaixaDeTexto 13">
             <a:extLst>
               <a:ext uri="{FF2B5EF4-FFF2-40B4-BE49-F238E27FC236}">
-                <a16:creationId xmlns:a16="http://schemas.microsoft.com/office/drawing/2014/main" id="{AB5E7BC5-8923-2B06-735D-B8A3F21F4147}"/>
+                <a16:creationId xmlns:a16="http://schemas.microsoft.com/office/drawing/2014/main" id="{63662204-127F-CA25-F03D-56969FA27741}"/>
               </a:ext>
             </a:extLst>
           </p:cNvPr>
@@ -15360,7 +15360,7 @@
     </p:spTree>
     <p:extLst>
       <p:ext uri="{BB962C8B-B14F-4D97-AF65-F5344CB8AC3E}">
-        <p14:creationId xmlns:p14="http://schemas.microsoft.com/office/powerpoint/2010/main" val="1912148391"/>
+        <p14:creationId xmlns:p14="http://schemas.microsoft.com/office/powerpoint/2010/main" val="4210835614"/>
       </p:ext>
     </p:extLst>
   </p:cSld>
@@ -15423,7 +15423,7 @@
           <p:cNvPr id="2" name="CaixaDeTexto 1">
             <a:extLst>
               <a:ext uri="{FF2B5EF4-FFF2-40B4-BE49-F238E27FC236}">
-                <a16:creationId xmlns:a16="http://schemas.microsoft.com/office/drawing/2014/main" id="{DD9142FA-E778-2993-A423-4EAAE7A0F4CB}"/>
+                <a16:creationId xmlns:a16="http://schemas.microsoft.com/office/drawing/2014/main" id="{84E224D6-2014-59BD-9A73-851C0EBF5822}"/>
               </a:ext>
             </a:extLst>
           </p:cNvPr>
@@ -15463,7 +15463,7 @@
           <p:cNvPr id="3" name="Retângulo 2">
             <a:extLst>
               <a:ext uri="{FF2B5EF4-FFF2-40B4-BE49-F238E27FC236}">
-                <a16:creationId xmlns:a16="http://schemas.microsoft.com/office/drawing/2014/main" id="{1402F0B2-23BE-D708-4E44-7AE992CCC265}"/>
+                <a16:creationId xmlns:a16="http://schemas.microsoft.com/office/drawing/2014/main" id="{74DBB5C4-2DD0-0366-AE7E-523C50E07649}"/>
               </a:ext>
             </a:extLst>
           </p:cNvPr>
@@ -15531,7 +15531,7 @@
           <p:cNvPr id="4" name="Retângulo 3">
             <a:extLst>
               <a:ext uri="{FF2B5EF4-FFF2-40B4-BE49-F238E27FC236}">
-                <a16:creationId xmlns:a16="http://schemas.microsoft.com/office/drawing/2014/main" id="{CEA82506-E4E3-0B0E-F55D-A3F125868952}"/>
+                <a16:creationId xmlns:a16="http://schemas.microsoft.com/office/drawing/2014/main" id="{243E99A9-FA57-2809-8E7B-87614C41B96F}"/>
               </a:ext>
             </a:extLst>
           </p:cNvPr>
@@ -15599,7 +15599,7 @@
           <p:cNvPr id="5" name="CaixaDeTexto 4">
             <a:extLst>
               <a:ext uri="{FF2B5EF4-FFF2-40B4-BE49-F238E27FC236}">
-                <a16:creationId xmlns:a16="http://schemas.microsoft.com/office/drawing/2014/main" id="{181D093C-F7E1-DBEB-5581-48BAFC158962}"/>
+                <a16:creationId xmlns:a16="http://schemas.microsoft.com/office/drawing/2014/main" id="{0DE56E1C-F309-3FB4-F77C-3729D0B85A1F}"/>
               </a:ext>
             </a:extLst>
           </p:cNvPr>
@@ -15639,7 +15639,7 @@
           <p:cNvPr id="6" name="CaixaDeTexto 5">
             <a:extLst>
               <a:ext uri="{FF2B5EF4-FFF2-40B4-BE49-F238E27FC236}">
-                <a16:creationId xmlns:a16="http://schemas.microsoft.com/office/drawing/2014/main" id="{BDB2D701-DD46-36DD-686D-33E5F235199F}"/>
+                <a16:creationId xmlns:a16="http://schemas.microsoft.com/office/drawing/2014/main" id="{195AB575-7F46-2D0A-942D-3D193E9B8C3D}"/>
               </a:ext>
             </a:extLst>
           </p:cNvPr>
@@ -15680,7 +15680,7 @@
           <p:cNvPr id="7" name="CaixaDeTexto 6">
             <a:extLst>
               <a:ext uri="{FF2B5EF4-FFF2-40B4-BE49-F238E27FC236}">
-                <a16:creationId xmlns:a16="http://schemas.microsoft.com/office/drawing/2014/main" id="{A791B9C5-DC39-C914-9EE0-B8543F000A06}"/>
+                <a16:creationId xmlns:a16="http://schemas.microsoft.com/office/drawing/2014/main" id="{4D9B7EA1-845F-243B-9D09-CEC76B7DE28B}"/>
               </a:ext>
             </a:extLst>
           </p:cNvPr>
@@ -15835,7 +15835,7 @@
                 </a:solidFill>
                 <a:latin typeface="Segoe UI" panose="020B0502040204020203" pitchFamily="34" charset="0"/>
               </a:rPr>
-              <a:t> - 257 testes xUnit (OllamaArena.Tests); validacao = build + testes + execucao manual.</a:t>
+              <a:t> - 410 testes xUnit em 31 classes (OllamaArena.Tests); validacao = build + testes + execucao manual.</a:t>
             </a:r>
           </a:p>
           <a:p>
@@ -15913,7 +15913,7 @@
           <p:cNvPr id="8" name="Retângulo: Cantos Arredondados 7">
             <a:extLst>
               <a:ext uri="{FF2B5EF4-FFF2-40B4-BE49-F238E27FC236}">
-                <a16:creationId xmlns:a16="http://schemas.microsoft.com/office/drawing/2014/main" id="{ED7B9CD6-7553-F24A-7A4F-2BF907D1C6E5}"/>
+                <a16:creationId xmlns:a16="http://schemas.microsoft.com/office/drawing/2014/main" id="{78BF47AD-3DF3-7BA8-09D1-9F3012D76922}"/>
               </a:ext>
             </a:extLst>
           </p:cNvPr>
@@ -15967,7 +15967,7 @@
           <p:cNvPr id="9" name="CaixaDeTexto 8">
             <a:extLst>
               <a:ext uri="{FF2B5EF4-FFF2-40B4-BE49-F238E27FC236}">
-                <a16:creationId xmlns:a16="http://schemas.microsoft.com/office/drawing/2014/main" id="{EDF6AFC8-1465-A808-F85C-FCAB57EF5964}"/>
+                <a16:creationId xmlns:a16="http://schemas.microsoft.com/office/drawing/2014/main" id="{6EB278F6-CD81-8B92-EE1B-928E4FD92C23}"/>
               </a:ext>
             </a:extLst>
           </p:cNvPr>
@@ -16005,7 +16005,7 @@
     </p:spTree>
     <p:extLst>
       <p:ext uri="{BB962C8B-B14F-4D97-AF65-F5344CB8AC3E}">
-        <p14:creationId xmlns:p14="http://schemas.microsoft.com/office/powerpoint/2010/main" val="3584416333"/>
+        <p14:creationId xmlns:p14="http://schemas.microsoft.com/office/powerpoint/2010/main" val="3253009517"/>
       </p:ext>
     </p:extLst>
   </p:cSld>
@@ -16068,7 +16068,7 @@
           <p:cNvPr id="2" name="CaixaDeTexto 1">
             <a:extLst>
               <a:ext uri="{FF2B5EF4-FFF2-40B4-BE49-F238E27FC236}">
-                <a16:creationId xmlns:a16="http://schemas.microsoft.com/office/drawing/2014/main" id="{8FB2560A-5AA6-3481-2AF5-7992F8E64BA5}"/>
+                <a16:creationId xmlns:a16="http://schemas.microsoft.com/office/drawing/2014/main" id="{392C56C8-C206-7E8B-E435-5C9C0AD7647E}"/>
               </a:ext>
             </a:extLst>
           </p:cNvPr>
@@ -16108,7 +16108,7 @@
           <p:cNvPr id="3" name="Retângulo 2">
             <a:extLst>
               <a:ext uri="{FF2B5EF4-FFF2-40B4-BE49-F238E27FC236}">
-                <a16:creationId xmlns:a16="http://schemas.microsoft.com/office/drawing/2014/main" id="{46179906-8FA6-174C-C73A-0EC629FF6E7A}"/>
+                <a16:creationId xmlns:a16="http://schemas.microsoft.com/office/drawing/2014/main" id="{9841E47F-5D0E-404C-5C7E-0D2CCC238C7F}"/>
               </a:ext>
             </a:extLst>
           </p:cNvPr>
@@ -16176,7 +16176,7 @@
           <p:cNvPr id="4" name="Retângulo 3">
             <a:extLst>
               <a:ext uri="{FF2B5EF4-FFF2-40B4-BE49-F238E27FC236}">
-                <a16:creationId xmlns:a16="http://schemas.microsoft.com/office/drawing/2014/main" id="{84AB6DE9-5AD5-3EC4-EF08-DB85628F907A}"/>
+                <a16:creationId xmlns:a16="http://schemas.microsoft.com/office/drawing/2014/main" id="{1B6523CA-30C7-8BCA-3712-F5CC120FF5D9}"/>
               </a:ext>
             </a:extLst>
           </p:cNvPr>
@@ -16244,7 +16244,7 @@
           <p:cNvPr id="5" name="CaixaDeTexto 4">
             <a:extLst>
               <a:ext uri="{FF2B5EF4-FFF2-40B4-BE49-F238E27FC236}">
-                <a16:creationId xmlns:a16="http://schemas.microsoft.com/office/drawing/2014/main" id="{90D193E0-70B0-69F0-9F4E-5B030486F61D}"/>
+                <a16:creationId xmlns:a16="http://schemas.microsoft.com/office/drawing/2014/main" id="{F5639331-8536-6F50-2082-8C2FBCD7AA9B}"/>
               </a:ext>
             </a:extLst>
           </p:cNvPr>
@@ -16284,7 +16284,7 @@
           <p:cNvPr id="6" name="CaixaDeTexto 5">
             <a:extLst>
               <a:ext uri="{FF2B5EF4-FFF2-40B4-BE49-F238E27FC236}">
-                <a16:creationId xmlns:a16="http://schemas.microsoft.com/office/drawing/2014/main" id="{8E5BD1F3-05E7-ED95-0F1C-778D61A7A744}"/>
+                <a16:creationId xmlns:a16="http://schemas.microsoft.com/office/drawing/2014/main" id="{6342CF8C-FB91-4519-359B-17EEE882FA85}"/>
               </a:ext>
             </a:extLst>
           </p:cNvPr>
@@ -16325,7 +16325,7 @@
           <p:cNvPr id="7" name="Tabela 6">
             <a:extLst>
               <a:ext uri="{FF2B5EF4-FFF2-40B4-BE49-F238E27FC236}">
-                <a16:creationId xmlns:a16="http://schemas.microsoft.com/office/drawing/2014/main" id="{52161740-293C-C46C-D71D-51618CD302E1}"/>
+                <a16:creationId xmlns:a16="http://schemas.microsoft.com/office/drawing/2014/main" id="{D3280590-B85A-AA41-C8AF-F5809F652EE7}"/>
               </a:ext>
             </a:extLst>
           </p:cNvPr>
@@ -16335,7 +16335,7 @@
           <p:nvPr>
             <p:extLst>
               <p:ext uri="{D42A27DB-BD31-4B8C-83A1-F6EECF244321}">
-                <p14:modId xmlns:p14="http://schemas.microsoft.com/office/powerpoint/2010/main" val="1524510642"/>
+                <p14:modId xmlns:p14="http://schemas.microsoft.com/office/powerpoint/2010/main" val="1988862805"/>
               </p:ext>
             </p:extLst>
           </p:nvPr>
@@ -16354,14 +16354,14 @@
                 <a:gridCol w="2667000">
                   <a:extLst>
                     <a:ext uri="{9D8B030D-6E8A-4147-A177-3AD203B41FA5}">
-                      <a16:colId xmlns:a16="http://schemas.microsoft.com/office/drawing/2014/main" val="1326147410"/>
+                      <a16:colId xmlns:a16="http://schemas.microsoft.com/office/drawing/2014/main" val="3821339311"/>
                     </a:ext>
                   </a:extLst>
                 </a:gridCol>
                 <a:gridCol w="8001000">
                   <a:extLst>
                     <a:ext uri="{9D8B030D-6E8A-4147-A177-3AD203B41FA5}">
-                      <a16:colId xmlns:a16="http://schemas.microsoft.com/office/drawing/2014/main" val="2245296454"/>
+                      <a16:colId xmlns:a16="http://schemas.microsoft.com/office/drawing/2014/main" val="3796080400"/>
                     </a:ext>
                   </a:extLst>
                 </a:gridCol>
@@ -16415,7 +16415,7 @@
                 </a:tc>
                 <a:extLst>
                   <a:ext uri="{0D108BD9-81ED-4DB2-BD59-A6C34878D82A}">
-                    <a16:rowId xmlns:a16="http://schemas.microsoft.com/office/drawing/2014/main" val="651005855"/>
+                    <a16:rowId xmlns:a16="http://schemas.microsoft.com/office/drawing/2014/main" val="3757040805"/>
                   </a:ext>
                 </a:extLst>
               </a:tr>
@@ -16468,7 +16468,7 @@
                 </a:tc>
                 <a:extLst>
                   <a:ext uri="{0D108BD9-81ED-4DB2-BD59-A6C34878D82A}">
-                    <a16:rowId xmlns:a16="http://schemas.microsoft.com/office/drawing/2014/main" val="1596032514"/>
+                    <a16:rowId xmlns:a16="http://schemas.microsoft.com/office/drawing/2014/main" val="2318190498"/>
                   </a:ext>
                 </a:extLst>
               </a:tr>
@@ -16521,7 +16521,7 @@
                 </a:tc>
                 <a:extLst>
                   <a:ext uri="{0D108BD9-81ED-4DB2-BD59-A6C34878D82A}">
-                    <a16:rowId xmlns:a16="http://schemas.microsoft.com/office/drawing/2014/main" val="9864371"/>
+                    <a16:rowId xmlns:a16="http://schemas.microsoft.com/office/drawing/2014/main" val="1131667151"/>
                   </a:ext>
                 </a:extLst>
               </a:tr>
@@ -16574,7 +16574,7 @@
                 </a:tc>
                 <a:extLst>
                   <a:ext uri="{0D108BD9-81ED-4DB2-BD59-A6C34878D82A}">
-                    <a16:rowId xmlns:a16="http://schemas.microsoft.com/office/drawing/2014/main" val="2741362438"/>
+                    <a16:rowId xmlns:a16="http://schemas.microsoft.com/office/drawing/2014/main" val="1486509855"/>
                   </a:ext>
                 </a:extLst>
               </a:tr>
@@ -16627,7 +16627,7 @@
                 </a:tc>
                 <a:extLst>
                   <a:ext uri="{0D108BD9-81ED-4DB2-BD59-A6C34878D82A}">
-                    <a16:rowId xmlns:a16="http://schemas.microsoft.com/office/drawing/2014/main" val="2317726404"/>
+                    <a16:rowId xmlns:a16="http://schemas.microsoft.com/office/drawing/2014/main" val="1761894134"/>
                   </a:ext>
                 </a:extLst>
               </a:tr>
@@ -16680,7 +16680,7 @@
                 </a:tc>
                 <a:extLst>
                   <a:ext uri="{0D108BD9-81ED-4DB2-BD59-A6C34878D82A}">
-                    <a16:rowId xmlns:a16="http://schemas.microsoft.com/office/drawing/2014/main" val="2654761835"/>
+                    <a16:rowId xmlns:a16="http://schemas.microsoft.com/office/drawing/2014/main" val="2481605796"/>
                   </a:ext>
                 </a:extLst>
               </a:tr>
@@ -16733,7 +16733,7 @@
                 </a:tc>
                 <a:extLst>
                   <a:ext uri="{0D108BD9-81ED-4DB2-BD59-A6C34878D82A}">
-                    <a16:rowId xmlns:a16="http://schemas.microsoft.com/office/drawing/2014/main" val="3408134070"/>
+                    <a16:rowId xmlns:a16="http://schemas.microsoft.com/office/drawing/2014/main" val="2390391305"/>
                   </a:ext>
                 </a:extLst>
               </a:tr>
@@ -16746,7 +16746,7 @@
           <p:cNvPr id="8" name="Retângulo: Cantos Arredondados 7">
             <a:extLst>
               <a:ext uri="{FF2B5EF4-FFF2-40B4-BE49-F238E27FC236}">
-                <a16:creationId xmlns:a16="http://schemas.microsoft.com/office/drawing/2014/main" id="{353C1BF8-1223-83FF-C4A0-5A71B47AD50C}"/>
+                <a16:creationId xmlns:a16="http://schemas.microsoft.com/office/drawing/2014/main" id="{29E2F21E-DEB1-3768-71BD-89DE7DE55A39}"/>
               </a:ext>
             </a:extLst>
           </p:cNvPr>
@@ -16800,7 +16800,7 @@
           <p:cNvPr id="9" name="CaixaDeTexto 8">
             <a:extLst>
               <a:ext uri="{FF2B5EF4-FFF2-40B4-BE49-F238E27FC236}">
-                <a16:creationId xmlns:a16="http://schemas.microsoft.com/office/drawing/2014/main" id="{D3521F13-FC97-B455-BDF1-44843EAA2DCD}"/>
+                <a16:creationId xmlns:a16="http://schemas.microsoft.com/office/drawing/2014/main" id="{EAB64C06-A043-F3E0-BA9F-B6A15B8ED4A1}"/>
               </a:ext>
             </a:extLst>
           </p:cNvPr>
@@ -16838,7 +16838,7 @@
     </p:spTree>
     <p:extLst>
       <p:ext uri="{BB962C8B-B14F-4D97-AF65-F5344CB8AC3E}">
-        <p14:creationId xmlns:p14="http://schemas.microsoft.com/office/powerpoint/2010/main" val="2701434053"/>
+        <p14:creationId xmlns:p14="http://schemas.microsoft.com/office/powerpoint/2010/main" val="709071427"/>
       </p:ext>
     </p:extLst>
   </p:cSld>
@@ -16901,7 +16901,7 @@
           <p:cNvPr id="2" name="CaixaDeTexto 1">
             <a:extLst>
               <a:ext uri="{FF2B5EF4-FFF2-40B4-BE49-F238E27FC236}">
-                <a16:creationId xmlns:a16="http://schemas.microsoft.com/office/drawing/2014/main" id="{989D1741-E97D-28E6-3596-CFF6AC0E01B7}"/>
+                <a16:creationId xmlns:a16="http://schemas.microsoft.com/office/drawing/2014/main" id="{B701053D-C446-4BEA-F754-21C439D0FE14}"/>
               </a:ext>
             </a:extLst>
           </p:cNvPr>
@@ -16941,7 +16941,7 @@
           <p:cNvPr id="3" name="Retângulo 2">
             <a:extLst>
               <a:ext uri="{FF2B5EF4-FFF2-40B4-BE49-F238E27FC236}">
-                <a16:creationId xmlns:a16="http://schemas.microsoft.com/office/drawing/2014/main" id="{5DCDA52C-6475-8774-065C-1720C908F92F}"/>
+                <a16:creationId xmlns:a16="http://schemas.microsoft.com/office/drawing/2014/main" id="{4BCF091E-F11B-1856-057A-3E7989B6F8E0}"/>
               </a:ext>
             </a:extLst>
           </p:cNvPr>
@@ -17009,7 +17009,7 @@
           <p:cNvPr id="4" name="Retângulo 3">
             <a:extLst>
               <a:ext uri="{FF2B5EF4-FFF2-40B4-BE49-F238E27FC236}">
-                <a16:creationId xmlns:a16="http://schemas.microsoft.com/office/drawing/2014/main" id="{CB3362A3-33C0-A201-74CE-02DB99F1F55B}"/>
+                <a16:creationId xmlns:a16="http://schemas.microsoft.com/office/drawing/2014/main" id="{753BF850-FB07-4A35-CCFC-8810330B86FD}"/>
               </a:ext>
             </a:extLst>
           </p:cNvPr>
@@ -17077,7 +17077,7 @@
           <p:cNvPr id="5" name="CaixaDeTexto 4">
             <a:extLst>
               <a:ext uri="{FF2B5EF4-FFF2-40B4-BE49-F238E27FC236}">
-                <a16:creationId xmlns:a16="http://schemas.microsoft.com/office/drawing/2014/main" id="{E9E11A95-3766-B297-9C5B-3448CF0BC778}"/>
+                <a16:creationId xmlns:a16="http://schemas.microsoft.com/office/drawing/2014/main" id="{86752026-53B9-04EE-C9F8-D556D0A6DF23}"/>
               </a:ext>
             </a:extLst>
           </p:cNvPr>
@@ -17117,7 +17117,7 @@
           <p:cNvPr id="6" name="CaixaDeTexto 5">
             <a:extLst>
               <a:ext uri="{FF2B5EF4-FFF2-40B4-BE49-F238E27FC236}">
-                <a16:creationId xmlns:a16="http://schemas.microsoft.com/office/drawing/2014/main" id="{F9318765-F9BF-5FCC-C7F4-01B7111538D9}"/>
+                <a16:creationId xmlns:a16="http://schemas.microsoft.com/office/drawing/2014/main" id="{D114D024-EF38-E551-56D8-0D2F1B93848E}"/>
               </a:ext>
             </a:extLst>
           </p:cNvPr>
@@ -17158,7 +17158,7 @@
           <p:cNvPr id="7" name="CaixaDeTexto 6">
             <a:extLst>
               <a:ext uri="{FF2B5EF4-FFF2-40B4-BE49-F238E27FC236}">
-                <a16:creationId xmlns:a16="http://schemas.microsoft.com/office/drawing/2014/main" id="{3B828360-59F3-3E1F-060E-D1AE4C9953DD}"/>
+                <a16:creationId xmlns:a16="http://schemas.microsoft.com/office/drawing/2014/main" id="{129C34A9-2D0F-543D-084E-A8BE29CDE5DA}"/>
               </a:ext>
             </a:extLst>
           </p:cNvPr>
@@ -17405,7 +17405,7 @@
     </p:spTree>
     <p:extLst>
       <p:ext uri="{BB962C8B-B14F-4D97-AF65-F5344CB8AC3E}">
-        <p14:creationId xmlns:p14="http://schemas.microsoft.com/office/powerpoint/2010/main" val="685585954"/>
+        <p14:creationId xmlns:p14="http://schemas.microsoft.com/office/powerpoint/2010/main" val="3823874703"/>
       </p:ext>
     </p:extLst>
   </p:cSld>
@@ -17468,7 +17468,7 @@
           <p:cNvPr id="2" name="CaixaDeTexto 1">
             <a:extLst>
               <a:ext uri="{FF2B5EF4-FFF2-40B4-BE49-F238E27FC236}">
-                <a16:creationId xmlns:a16="http://schemas.microsoft.com/office/drawing/2014/main" id="{4242B86A-138F-A9F7-9CB3-A6A1794761FC}"/>
+                <a16:creationId xmlns:a16="http://schemas.microsoft.com/office/drawing/2014/main" id="{7726E164-B34B-30B6-05FA-D5D6A7DA880D}"/>
               </a:ext>
             </a:extLst>
           </p:cNvPr>
@@ -17508,7 +17508,7 @@
           <p:cNvPr id="3" name="Retângulo 2">
             <a:extLst>
               <a:ext uri="{FF2B5EF4-FFF2-40B4-BE49-F238E27FC236}">
-                <a16:creationId xmlns:a16="http://schemas.microsoft.com/office/drawing/2014/main" id="{66CD8D79-BDA0-58A7-6C01-0358348A03EF}"/>
+                <a16:creationId xmlns:a16="http://schemas.microsoft.com/office/drawing/2014/main" id="{93D8D384-3A7D-2C57-412B-3FC65BB94AC7}"/>
               </a:ext>
             </a:extLst>
           </p:cNvPr>
@@ -17576,7 +17576,7 @@
           <p:cNvPr id="4" name="Retângulo 3">
             <a:extLst>
               <a:ext uri="{FF2B5EF4-FFF2-40B4-BE49-F238E27FC236}">
-                <a16:creationId xmlns:a16="http://schemas.microsoft.com/office/drawing/2014/main" id="{B6CF0F7E-1337-C070-4FC3-07493DDCD4C4}"/>
+                <a16:creationId xmlns:a16="http://schemas.microsoft.com/office/drawing/2014/main" id="{73746FCC-4753-4AD2-72B5-8DF1CBBB8848}"/>
               </a:ext>
             </a:extLst>
           </p:cNvPr>
@@ -17644,7 +17644,7 @@
           <p:cNvPr id="5" name="CaixaDeTexto 4">
             <a:extLst>
               <a:ext uri="{FF2B5EF4-FFF2-40B4-BE49-F238E27FC236}">
-                <a16:creationId xmlns:a16="http://schemas.microsoft.com/office/drawing/2014/main" id="{63EBE5CF-25B3-2ABA-E2E0-F628A8A6691D}"/>
+                <a16:creationId xmlns:a16="http://schemas.microsoft.com/office/drawing/2014/main" id="{37E766F7-0575-83DA-58E9-EE5FB5810825}"/>
               </a:ext>
             </a:extLst>
           </p:cNvPr>
@@ -17684,7 +17684,7 @@
           <p:cNvPr id="6" name="CaixaDeTexto 5">
             <a:extLst>
               <a:ext uri="{FF2B5EF4-FFF2-40B4-BE49-F238E27FC236}">
-                <a16:creationId xmlns:a16="http://schemas.microsoft.com/office/drawing/2014/main" id="{CCD7685F-232D-08F1-A675-B6EC8044AD41}"/>
+                <a16:creationId xmlns:a16="http://schemas.microsoft.com/office/drawing/2014/main" id="{5572C929-9AE1-CB82-CD6E-CD8A7AADEA6F}"/>
               </a:ext>
             </a:extLst>
           </p:cNvPr>
@@ -17725,7 +17725,7 @@
           <p:cNvPr id="7" name="Tabela 6">
             <a:extLst>
               <a:ext uri="{FF2B5EF4-FFF2-40B4-BE49-F238E27FC236}">
-                <a16:creationId xmlns:a16="http://schemas.microsoft.com/office/drawing/2014/main" id="{D25DFDFC-92E1-7D0F-EB7D-63DA4B761370}"/>
+                <a16:creationId xmlns:a16="http://schemas.microsoft.com/office/drawing/2014/main" id="{1FE78E7B-5414-75D5-192A-16470BE6C4D6}"/>
               </a:ext>
             </a:extLst>
           </p:cNvPr>
@@ -17735,7 +17735,7 @@
           <p:nvPr>
             <p:extLst>
               <p:ext uri="{D42A27DB-BD31-4B8C-83A1-F6EECF244321}">
-                <p14:modId xmlns:p14="http://schemas.microsoft.com/office/powerpoint/2010/main" val="2902332361"/>
+                <p14:modId xmlns:p14="http://schemas.microsoft.com/office/powerpoint/2010/main" val="3963344950"/>
               </p:ext>
             </p:extLst>
           </p:nvPr>
@@ -17754,21 +17754,21 @@
                 <a:gridCol w="2540000">
                   <a:extLst>
                     <a:ext uri="{9D8B030D-6E8A-4147-A177-3AD203B41FA5}">
-                      <a16:colId xmlns:a16="http://schemas.microsoft.com/office/drawing/2014/main" val="834661035"/>
+                      <a16:colId xmlns:a16="http://schemas.microsoft.com/office/drawing/2014/main" val="3859689318"/>
                     </a:ext>
                   </a:extLst>
                 </a:gridCol>
                 <a:gridCol w="2921000">
                   <a:extLst>
                     <a:ext uri="{9D8B030D-6E8A-4147-A177-3AD203B41FA5}">
-                      <a16:colId xmlns:a16="http://schemas.microsoft.com/office/drawing/2014/main" val="1533677271"/>
+                      <a16:colId xmlns:a16="http://schemas.microsoft.com/office/drawing/2014/main" val="3853674944"/>
                     </a:ext>
                   </a:extLst>
                 </a:gridCol>
                 <a:gridCol w="5207000">
                   <a:extLst>
                     <a:ext uri="{9D8B030D-6E8A-4147-A177-3AD203B41FA5}">
-                      <a16:colId xmlns:a16="http://schemas.microsoft.com/office/drawing/2014/main" val="2984900939"/>
+                      <a16:colId xmlns:a16="http://schemas.microsoft.com/office/drawing/2014/main" val="2055940943"/>
                     </a:ext>
                   </a:extLst>
                 </a:gridCol>
@@ -17845,7 +17845,7 @@
                 </a:tc>
                 <a:extLst>
                   <a:ext uri="{0D108BD9-81ED-4DB2-BD59-A6C34878D82A}">
-                    <a16:rowId xmlns:a16="http://schemas.microsoft.com/office/drawing/2014/main" val="2844971224"/>
+                    <a16:rowId xmlns:a16="http://schemas.microsoft.com/office/drawing/2014/main" val="4077450787"/>
                   </a:ext>
                 </a:extLst>
               </a:tr>
@@ -17921,7 +17921,7 @@
                 </a:tc>
                 <a:extLst>
                   <a:ext uri="{0D108BD9-81ED-4DB2-BD59-A6C34878D82A}">
-                    <a16:rowId xmlns:a16="http://schemas.microsoft.com/office/drawing/2014/main" val="2159373341"/>
+                    <a16:rowId xmlns:a16="http://schemas.microsoft.com/office/drawing/2014/main" val="3510034759"/>
                   </a:ext>
                 </a:extLst>
               </a:tr>
@@ -17997,7 +17997,7 @@
                 </a:tc>
                 <a:extLst>
                   <a:ext uri="{0D108BD9-81ED-4DB2-BD59-A6C34878D82A}">
-                    <a16:rowId xmlns:a16="http://schemas.microsoft.com/office/drawing/2014/main" val="71030394"/>
+                    <a16:rowId xmlns:a16="http://schemas.microsoft.com/office/drawing/2014/main" val="1246219417"/>
                   </a:ext>
                 </a:extLst>
               </a:tr>
@@ -18073,7 +18073,7 @@
                 </a:tc>
                 <a:extLst>
                   <a:ext uri="{0D108BD9-81ED-4DB2-BD59-A6C34878D82A}">
-                    <a16:rowId xmlns:a16="http://schemas.microsoft.com/office/drawing/2014/main" val="3973359009"/>
+                    <a16:rowId xmlns:a16="http://schemas.microsoft.com/office/drawing/2014/main" val="3601823655"/>
                   </a:ext>
                 </a:extLst>
               </a:tr>
@@ -18149,7 +18149,7 @@
                 </a:tc>
                 <a:extLst>
                   <a:ext uri="{0D108BD9-81ED-4DB2-BD59-A6C34878D82A}">
-                    <a16:rowId xmlns:a16="http://schemas.microsoft.com/office/drawing/2014/main" val="2899269730"/>
+                    <a16:rowId xmlns:a16="http://schemas.microsoft.com/office/drawing/2014/main" val="423484801"/>
                   </a:ext>
                 </a:extLst>
               </a:tr>
@@ -18225,7 +18225,7 @@
                 </a:tc>
                 <a:extLst>
                   <a:ext uri="{0D108BD9-81ED-4DB2-BD59-A6C34878D82A}">
-                    <a16:rowId xmlns:a16="http://schemas.microsoft.com/office/drawing/2014/main" val="44807309"/>
+                    <a16:rowId xmlns:a16="http://schemas.microsoft.com/office/drawing/2014/main" val="2446638952"/>
                   </a:ext>
                 </a:extLst>
               </a:tr>
@@ -18301,7 +18301,7 @@
                 </a:tc>
                 <a:extLst>
                   <a:ext uri="{0D108BD9-81ED-4DB2-BD59-A6C34878D82A}">
-                    <a16:rowId xmlns:a16="http://schemas.microsoft.com/office/drawing/2014/main" val="3457380212"/>
+                    <a16:rowId xmlns:a16="http://schemas.microsoft.com/office/drawing/2014/main" val="2123565481"/>
                   </a:ext>
                 </a:extLst>
               </a:tr>
@@ -18377,7 +18377,7 @@
                 </a:tc>
                 <a:extLst>
                   <a:ext uri="{0D108BD9-81ED-4DB2-BD59-A6C34878D82A}">
-                    <a16:rowId xmlns:a16="http://schemas.microsoft.com/office/drawing/2014/main" val="3568675254"/>
+                    <a16:rowId xmlns:a16="http://schemas.microsoft.com/office/drawing/2014/main" val="4016154034"/>
                   </a:ext>
                 </a:extLst>
               </a:tr>
@@ -18453,7 +18453,7 @@
                 </a:tc>
                 <a:extLst>
                   <a:ext uri="{0D108BD9-81ED-4DB2-BD59-A6C34878D82A}">
-                    <a16:rowId xmlns:a16="http://schemas.microsoft.com/office/drawing/2014/main" val="3998096596"/>
+                    <a16:rowId xmlns:a16="http://schemas.microsoft.com/office/drawing/2014/main" val="1312377272"/>
                   </a:ext>
                 </a:extLst>
               </a:tr>
@@ -18529,7 +18529,7 @@
                 </a:tc>
                 <a:extLst>
                   <a:ext uri="{0D108BD9-81ED-4DB2-BD59-A6C34878D82A}">
-                    <a16:rowId xmlns:a16="http://schemas.microsoft.com/office/drawing/2014/main" val="1853625612"/>
+                    <a16:rowId xmlns:a16="http://schemas.microsoft.com/office/drawing/2014/main" val="942531152"/>
                   </a:ext>
                 </a:extLst>
               </a:tr>
@@ -18542,7 +18542,7 @@
           <p:cNvPr id="8" name="CaixaDeTexto 7">
             <a:extLst>
               <a:ext uri="{FF2B5EF4-FFF2-40B4-BE49-F238E27FC236}">
-                <a16:creationId xmlns:a16="http://schemas.microsoft.com/office/drawing/2014/main" id="{C748D5C1-3DC7-4118-0BF3-CAC38C3B6472}"/>
+                <a16:creationId xmlns:a16="http://schemas.microsoft.com/office/drawing/2014/main" id="{EFC6C9E7-EC6A-E09C-54F6-96229E2098DB}"/>
               </a:ext>
             </a:extLst>
           </p:cNvPr>
@@ -18580,7 +18580,7 @@
     </p:spTree>
     <p:extLst>
       <p:ext uri="{BB962C8B-B14F-4D97-AF65-F5344CB8AC3E}">
-        <p14:creationId xmlns:p14="http://schemas.microsoft.com/office/powerpoint/2010/main" val="3159446586"/>
+        <p14:creationId xmlns:p14="http://schemas.microsoft.com/office/powerpoint/2010/main" val="1885556358"/>
       </p:ext>
     </p:extLst>
   </p:cSld>
@@ -18643,7 +18643,7 @@
           <p:cNvPr id="2" name="CaixaDeTexto 1">
             <a:extLst>
               <a:ext uri="{FF2B5EF4-FFF2-40B4-BE49-F238E27FC236}">
-                <a16:creationId xmlns:a16="http://schemas.microsoft.com/office/drawing/2014/main" id="{008D7EE7-9547-C558-E8F2-798A168FCF6A}"/>
+                <a16:creationId xmlns:a16="http://schemas.microsoft.com/office/drawing/2014/main" id="{227C588B-18EF-8E80-D373-71188254C741}"/>
               </a:ext>
             </a:extLst>
           </p:cNvPr>
@@ -18683,7 +18683,7 @@
           <p:cNvPr id="3" name="Retângulo 2">
             <a:extLst>
               <a:ext uri="{FF2B5EF4-FFF2-40B4-BE49-F238E27FC236}">
-                <a16:creationId xmlns:a16="http://schemas.microsoft.com/office/drawing/2014/main" id="{AB4EAC73-2FD2-D4E2-B9D7-898BA88A20C1}"/>
+                <a16:creationId xmlns:a16="http://schemas.microsoft.com/office/drawing/2014/main" id="{660203FC-2819-26ED-14A6-78D1C1AE5BF9}"/>
               </a:ext>
             </a:extLst>
           </p:cNvPr>
@@ -18751,7 +18751,7 @@
           <p:cNvPr id="4" name="Retângulo 3">
             <a:extLst>
               <a:ext uri="{FF2B5EF4-FFF2-40B4-BE49-F238E27FC236}">
-                <a16:creationId xmlns:a16="http://schemas.microsoft.com/office/drawing/2014/main" id="{DABBEEA9-95F8-B3A7-13F3-444AFD2E4D7F}"/>
+                <a16:creationId xmlns:a16="http://schemas.microsoft.com/office/drawing/2014/main" id="{FFF8B733-2EAE-D248-CFA9-36E70E9E3E37}"/>
               </a:ext>
             </a:extLst>
           </p:cNvPr>
@@ -18819,7 +18819,7 @@
           <p:cNvPr id="5" name="CaixaDeTexto 4">
             <a:extLst>
               <a:ext uri="{FF2B5EF4-FFF2-40B4-BE49-F238E27FC236}">
-                <a16:creationId xmlns:a16="http://schemas.microsoft.com/office/drawing/2014/main" id="{DD838BBF-A937-A56C-E855-9AC6A7BC7323}"/>
+                <a16:creationId xmlns:a16="http://schemas.microsoft.com/office/drawing/2014/main" id="{5EE57B45-BF9F-B6C8-FAB1-12D02D8367E7}"/>
               </a:ext>
             </a:extLst>
           </p:cNvPr>
@@ -18859,7 +18859,7 @@
           <p:cNvPr id="6" name="CaixaDeTexto 5">
             <a:extLst>
               <a:ext uri="{FF2B5EF4-FFF2-40B4-BE49-F238E27FC236}">
-                <a16:creationId xmlns:a16="http://schemas.microsoft.com/office/drawing/2014/main" id="{15BCF8EC-1B0D-C0ED-0528-7E075C071164}"/>
+                <a16:creationId xmlns:a16="http://schemas.microsoft.com/office/drawing/2014/main" id="{101F6A24-9416-71C6-33A9-401AE65D2FD4}"/>
               </a:ext>
             </a:extLst>
           </p:cNvPr>
@@ -18900,7 +18900,7 @@
           <p:cNvPr id="7" name="Retângulo: Cantos Arredondados 6">
             <a:extLst>
               <a:ext uri="{FF2B5EF4-FFF2-40B4-BE49-F238E27FC236}">
-                <a16:creationId xmlns:a16="http://schemas.microsoft.com/office/drawing/2014/main" id="{C2496A0D-B20B-5C30-BFF1-B0FD341DAB61}"/>
+                <a16:creationId xmlns:a16="http://schemas.microsoft.com/office/drawing/2014/main" id="{A08611FB-6A72-CF04-7864-3E63497D1ED2}"/>
               </a:ext>
             </a:extLst>
           </p:cNvPr>
@@ -18954,7 +18954,7 @@
           <p:cNvPr id="8" name="CaixaDeTexto 7">
             <a:extLst>
               <a:ext uri="{FF2B5EF4-FFF2-40B4-BE49-F238E27FC236}">
-                <a16:creationId xmlns:a16="http://schemas.microsoft.com/office/drawing/2014/main" id="{F2B7816E-F2D7-6244-5F54-B504AA4523B5}"/>
+                <a16:creationId xmlns:a16="http://schemas.microsoft.com/office/drawing/2014/main" id="{1DB5837E-DD1A-463C-7A37-0B96A8779613}"/>
               </a:ext>
             </a:extLst>
           </p:cNvPr>
@@ -18994,7 +18994,7 @@
           <p:cNvPr id="9" name="CaixaDeTexto 8">
             <a:extLst>
               <a:ext uri="{FF2B5EF4-FFF2-40B4-BE49-F238E27FC236}">
-                <a16:creationId xmlns:a16="http://schemas.microsoft.com/office/drawing/2014/main" id="{0ABF6F4B-017F-5778-D97A-301C0C91AF71}"/>
+                <a16:creationId xmlns:a16="http://schemas.microsoft.com/office/drawing/2014/main" id="{7D8428B1-0B64-B81E-ACFF-C2A12013498F}"/>
               </a:ext>
             </a:extLst>
           </p:cNvPr>
@@ -19087,7 +19087,7 @@
           <p:cNvPr id="10" name="Retângulo: Cantos Arredondados 9">
             <a:extLst>
               <a:ext uri="{FF2B5EF4-FFF2-40B4-BE49-F238E27FC236}">
-                <a16:creationId xmlns:a16="http://schemas.microsoft.com/office/drawing/2014/main" id="{08525868-4D97-D145-3A8D-42C65735957C}"/>
+                <a16:creationId xmlns:a16="http://schemas.microsoft.com/office/drawing/2014/main" id="{764B761F-CBB5-8971-0019-36FB3F6D913E}"/>
               </a:ext>
             </a:extLst>
           </p:cNvPr>
@@ -19141,7 +19141,7 @@
           <p:cNvPr id="11" name="CaixaDeTexto 10">
             <a:extLst>
               <a:ext uri="{FF2B5EF4-FFF2-40B4-BE49-F238E27FC236}">
-                <a16:creationId xmlns:a16="http://schemas.microsoft.com/office/drawing/2014/main" id="{0B3E22E6-B306-1D94-5BEB-B36EADD10DDF}"/>
+                <a16:creationId xmlns:a16="http://schemas.microsoft.com/office/drawing/2014/main" id="{854B660E-4C3D-BF41-19C6-2DD368016414}"/>
               </a:ext>
             </a:extLst>
           </p:cNvPr>
@@ -19181,7 +19181,7 @@
           <p:cNvPr id="12" name="CaixaDeTexto 11">
             <a:extLst>
               <a:ext uri="{FF2B5EF4-FFF2-40B4-BE49-F238E27FC236}">
-                <a16:creationId xmlns:a16="http://schemas.microsoft.com/office/drawing/2014/main" id="{6C38E736-55E9-71E7-B9CD-30741543B22F}"/>
+                <a16:creationId xmlns:a16="http://schemas.microsoft.com/office/drawing/2014/main" id="{A7B3B292-AEFA-70DE-E4A3-812A71625C56}"/>
               </a:ext>
             </a:extLst>
           </p:cNvPr>
@@ -19274,7 +19274,7 @@
           <p:cNvPr id="13" name="Retângulo: Cantos Arredondados 12">
             <a:extLst>
               <a:ext uri="{FF2B5EF4-FFF2-40B4-BE49-F238E27FC236}">
-                <a16:creationId xmlns:a16="http://schemas.microsoft.com/office/drawing/2014/main" id="{1878D088-DEA8-35B9-9266-6095EDD2315C}"/>
+                <a16:creationId xmlns:a16="http://schemas.microsoft.com/office/drawing/2014/main" id="{6209A813-97E4-07C8-80F0-C88884BD69EC}"/>
               </a:ext>
             </a:extLst>
           </p:cNvPr>
@@ -19328,7 +19328,7 @@
           <p:cNvPr id="14" name="CaixaDeTexto 13">
             <a:extLst>
               <a:ext uri="{FF2B5EF4-FFF2-40B4-BE49-F238E27FC236}">
-                <a16:creationId xmlns:a16="http://schemas.microsoft.com/office/drawing/2014/main" id="{E6A094E9-C1BF-B9E5-F9F0-A6F03EF7ED57}"/>
+                <a16:creationId xmlns:a16="http://schemas.microsoft.com/office/drawing/2014/main" id="{6B14A66D-AE02-EBBD-4D52-E43FF162B5CD}"/>
               </a:ext>
             </a:extLst>
           </p:cNvPr>
@@ -19366,7 +19366,7 @@
     </p:spTree>
     <p:extLst>
       <p:ext uri="{BB962C8B-B14F-4D97-AF65-F5344CB8AC3E}">
-        <p14:creationId xmlns:p14="http://schemas.microsoft.com/office/powerpoint/2010/main" val="867866867"/>
+        <p14:creationId xmlns:p14="http://schemas.microsoft.com/office/powerpoint/2010/main" val="543555686"/>
       </p:ext>
     </p:extLst>
   </p:cSld>
@@ -19429,7 +19429,7 @@
           <p:cNvPr id="2" name="CaixaDeTexto 1">
             <a:extLst>
               <a:ext uri="{FF2B5EF4-FFF2-40B4-BE49-F238E27FC236}">
-                <a16:creationId xmlns:a16="http://schemas.microsoft.com/office/drawing/2014/main" id="{392465E3-C3EC-9787-BFCF-2ED0A6C3EABA}"/>
+                <a16:creationId xmlns:a16="http://schemas.microsoft.com/office/drawing/2014/main" id="{AABC2976-A75C-2336-6849-C13CB6D46F06}"/>
               </a:ext>
             </a:extLst>
           </p:cNvPr>
@@ -19469,7 +19469,7 @@
           <p:cNvPr id="3" name="Retângulo 2">
             <a:extLst>
               <a:ext uri="{FF2B5EF4-FFF2-40B4-BE49-F238E27FC236}">
-                <a16:creationId xmlns:a16="http://schemas.microsoft.com/office/drawing/2014/main" id="{637E3D40-AD14-0E48-17B2-D56C8CAFD8D3}"/>
+                <a16:creationId xmlns:a16="http://schemas.microsoft.com/office/drawing/2014/main" id="{A62AB66D-6CFD-96EE-8FBD-32662E017A4A}"/>
               </a:ext>
             </a:extLst>
           </p:cNvPr>
@@ -19537,7 +19537,7 @@
           <p:cNvPr id="4" name="Retângulo 3">
             <a:extLst>
               <a:ext uri="{FF2B5EF4-FFF2-40B4-BE49-F238E27FC236}">
-                <a16:creationId xmlns:a16="http://schemas.microsoft.com/office/drawing/2014/main" id="{FC531997-3D4B-37DE-52E8-1459C7AB3474}"/>
+                <a16:creationId xmlns:a16="http://schemas.microsoft.com/office/drawing/2014/main" id="{EEA0D7B3-DDD9-2A84-34BC-AA1BC84CCA85}"/>
               </a:ext>
             </a:extLst>
           </p:cNvPr>
@@ -19605,7 +19605,7 @@
           <p:cNvPr id="5" name="CaixaDeTexto 4">
             <a:extLst>
               <a:ext uri="{FF2B5EF4-FFF2-40B4-BE49-F238E27FC236}">
-                <a16:creationId xmlns:a16="http://schemas.microsoft.com/office/drawing/2014/main" id="{89F08326-306E-3FED-2CE4-D4AAC1CBA559}"/>
+                <a16:creationId xmlns:a16="http://schemas.microsoft.com/office/drawing/2014/main" id="{33B7DC57-2C89-F229-22DE-6BDEF7DA3E8A}"/>
               </a:ext>
             </a:extLst>
           </p:cNvPr>
@@ -19645,7 +19645,7 @@
           <p:cNvPr id="6" name="CaixaDeTexto 5">
             <a:extLst>
               <a:ext uri="{FF2B5EF4-FFF2-40B4-BE49-F238E27FC236}">
-                <a16:creationId xmlns:a16="http://schemas.microsoft.com/office/drawing/2014/main" id="{6F0962DF-574B-7FA6-E78E-280FD5EF9A49}"/>
+                <a16:creationId xmlns:a16="http://schemas.microsoft.com/office/drawing/2014/main" id="{B7AC8E52-38F4-6DC8-2102-94B550D4D8CE}"/>
               </a:ext>
             </a:extLst>
           </p:cNvPr>
@@ -19686,7 +19686,7 @@
           <p:cNvPr id="7" name="CaixaDeTexto 6">
             <a:extLst>
               <a:ext uri="{FF2B5EF4-FFF2-40B4-BE49-F238E27FC236}">
-                <a16:creationId xmlns:a16="http://schemas.microsoft.com/office/drawing/2014/main" id="{5CFB7772-9C07-6760-4774-B9F746A761EC}"/>
+                <a16:creationId xmlns:a16="http://schemas.microsoft.com/office/drawing/2014/main" id="{0D0E7FBB-6150-B276-ECE2-FF2D34541F12}"/>
               </a:ext>
             </a:extLst>
           </p:cNvPr>
@@ -19917,7 +19917,7 @@
     </p:spTree>
     <p:extLst>
       <p:ext uri="{BB962C8B-B14F-4D97-AF65-F5344CB8AC3E}">
-        <p14:creationId xmlns:p14="http://schemas.microsoft.com/office/powerpoint/2010/main" val="1627904267"/>
+        <p14:creationId xmlns:p14="http://schemas.microsoft.com/office/powerpoint/2010/main" val="1443260445"/>
       </p:ext>
     </p:extLst>
   </p:cSld>
@@ -19980,7 +19980,7 @@
           <p:cNvPr id="2" name="CaixaDeTexto 1">
             <a:extLst>
               <a:ext uri="{FF2B5EF4-FFF2-40B4-BE49-F238E27FC236}">
-                <a16:creationId xmlns:a16="http://schemas.microsoft.com/office/drawing/2014/main" id="{A96D2EC6-8458-04C8-B13B-DFA3D4B9BFA5}"/>
+                <a16:creationId xmlns:a16="http://schemas.microsoft.com/office/drawing/2014/main" id="{0215433D-8E04-8D0E-D008-22A41B77E704}"/>
               </a:ext>
             </a:extLst>
           </p:cNvPr>
@@ -20020,7 +20020,7 @@
           <p:cNvPr id="3" name="Retângulo 2">
             <a:extLst>
               <a:ext uri="{FF2B5EF4-FFF2-40B4-BE49-F238E27FC236}">
-                <a16:creationId xmlns:a16="http://schemas.microsoft.com/office/drawing/2014/main" id="{FC349AB5-E2BA-12EA-28F3-EC82933AC28B}"/>
+                <a16:creationId xmlns:a16="http://schemas.microsoft.com/office/drawing/2014/main" id="{967C48C2-74B4-1CAA-FFF1-3F165FEB71A1}"/>
               </a:ext>
             </a:extLst>
           </p:cNvPr>
@@ -20088,7 +20088,7 @@
           <p:cNvPr id="4" name="Retângulo 3">
             <a:extLst>
               <a:ext uri="{FF2B5EF4-FFF2-40B4-BE49-F238E27FC236}">
-                <a16:creationId xmlns:a16="http://schemas.microsoft.com/office/drawing/2014/main" id="{FF22C756-385F-E6DB-B65A-1067D9904BF0}"/>
+                <a16:creationId xmlns:a16="http://schemas.microsoft.com/office/drawing/2014/main" id="{F03DDAD9-0FDB-0977-64AA-DB2B583A75D3}"/>
               </a:ext>
             </a:extLst>
           </p:cNvPr>
@@ -20156,7 +20156,7 @@
           <p:cNvPr id="5" name="CaixaDeTexto 4">
             <a:extLst>
               <a:ext uri="{FF2B5EF4-FFF2-40B4-BE49-F238E27FC236}">
-                <a16:creationId xmlns:a16="http://schemas.microsoft.com/office/drawing/2014/main" id="{A4C5222F-C7B6-04ED-2F72-99DF733304C1}"/>
+                <a16:creationId xmlns:a16="http://schemas.microsoft.com/office/drawing/2014/main" id="{149C1BD6-03B7-E92D-EECB-5DB5F809DD75}"/>
               </a:ext>
             </a:extLst>
           </p:cNvPr>
@@ -20196,7 +20196,7 @@
           <p:cNvPr id="6" name="CaixaDeTexto 5">
             <a:extLst>
               <a:ext uri="{FF2B5EF4-FFF2-40B4-BE49-F238E27FC236}">
-                <a16:creationId xmlns:a16="http://schemas.microsoft.com/office/drawing/2014/main" id="{908995BD-D968-F932-F1D8-F873F1C5A510}"/>
+                <a16:creationId xmlns:a16="http://schemas.microsoft.com/office/drawing/2014/main" id="{3582E63B-2875-214E-4720-D0024A2819D6}"/>
               </a:ext>
             </a:extLst>
           </p:cNvPr>
@@ -20237,7 +20237,7 @@
           <p:cNvPr id="7" name="Retângulo 6">
             <a:extLst>
               <a:ext uri="{FF2B5EF4-FFF2-40B4-BE49-F238E27FC236}">
-                <a16:creationId xmlns:a16="http://schemas.microsoft.com/office/drawing/2014/main" id="{7D0F4CA9-6F1B-CE13-8EF4-AD0058DB831A}"/>
+                <a16:creationId xmlns:a16="http://schemas.microsoft.com/office/drawing/2014/main" id="{E56FC946-9AEE-7E01-FF3D-C4F8CBDE5EE3}"/>
               </a:ext>
             </a:extLst>
           </p:cNvPr>
@@ -20305,7 +20305,7 @@
           <p:cNvPr id="8" name="Oval 7">
             <a:extLst>
               <a:ext uri="{FF2B5EF4-FFF2-40B4-BE49-F238E27FC236}">
-                <a16:creationId xmlns:a16="http://schemas.microsoft.com/office/drawing/2014/main" id="{039D3F27-71C6-74DC-10A3-E859C24B2BC1}"/>
+                <a16:creationId xmlns:a16="http://schemas.microsoft.com/office/drawing/2014/main" id="{5F3AAAA6-0CE6-9057-7029-CD67EB9DDEC7}"/>
               </a:ext>
             </a:extLst>
           </p:cNvPr>
@@ -20381,7 +20381,7 @@
           <p:cNvPr id="9" name="CaixaDeTexto 8">
             <a:extLst>
               <a:ext uri="{FF2B5EF4-FFF2-40B4-BE49-F238E27FC236}">
-                <a16:creationId xmlns:a16="http://schemas.microsoft.com/office/drawing/2014/main" id="{1980C472-22A1-E72B-35C2-EDA75BC9B247}"/>
+                <a16:creationId xmlns:a16="http://schemas.microsoft.com/office/drawing/2014/main" id="{EFD04B69-636C-11E1-726D-30ED4692DBD2}"/>
               </a:ext>
             </a:extLst>
           </p:cNvPr>
@@ -20421,7 +20421,7 @@
           <p:cNvPr id="10" name="CaixaDeTexto 9">
             <a:extLst>
               <a:ext uri="{FF2B5EF4-FFF2-40B4-BE49-F238E27FC236}">
-                <a16:creationId xmlns:a16="http://schemas.microsoft.com/office/drawing/2014/main" id="{AAC77937-DAE4-C699-EE10-AAE4FFF3CB88}"/>
+                <a16:creationId xmlns:a16="http://schemas.microsoft.com/office/drawing/2014/main" id="{3C64DC2C-FC4E-6C71-A4E8-B5430F0E3709}"/>
               </a:ext>
             </a:extLst>
           </p:cNvPr>
@@ -20461,7 +20461,7 @@
           <p:cNvPr id="11" name="Retângulo 10">
             <a:extLst>
               <a:ext uri="{FF2B5EF4-FFF2-40B4-BE49-F238E27FC236}">
-                <a16:creationId xmlns:a16="http://schemas.microsoft.com/office/drawing/2014/main" id="{CD45E35D-1D3D-13D1-FE2B-A19F071937DD}"/>
+                <a16:creationId xmlns:a16="http://schemas.microsoft.com/office/drawing/2014/main" id="{D89C8972-4CB2-8C18-DF2A-CD9AB05C5C5F}"/>
               </a:ext>
             </a:extLst>
           </p:cNvPr>
@@ -20529,7 +20529,7 @@
           <p:cNvPr id="12" name="Oval 11">
             <a:extLst>
               <a:ext uri="{FF2B5EF4-FFF2-40B4-BE49-F238E27FC236}">
-                <a16:creationId xmlns:a16="http://schemas.microsoft.com/office/drawing/2014/main" id="{519733ED-B267-A421-2B15-1B1B17C4BA6F}"/>
+                <a16:creationId xmlns:a16="http://schemas.microsoft.com/office/drawing/2014/main" id="{AFBE341D-9B2C-CD95-B86F-A9B230096D05}"/>
               </a:ext>
             </a:extLst>
           </p:cNvPr>
@@ -20605,7 +20605,7 @@
           <p:cNvPr id="13" name="CaixaDeTexto 12">
             <a:extLst>
               <a:ext uri="{FF2B5EF4-FFF2-40B4-BE49-F238E27FC236}">
-                <a16:creationId xmlns:a16="http://schemas.microsoft.com/office/drawing/2014/main" id="{0A9A8804-62E7-1ABC-BC12-BAC155CC9D6A}"/>
+                <a16:creationId xmlns:a16="http://schemas.microsoft.com/office/drawing/2014/main" id="{81A8B4CF-FFDC-596E-DA39-4123FDE64C32}"/>
               </a:ext>
             </a:extLst>
           </p:cNvPr>
@@ -20645,7 +20645,7 @@
           <p:cNvPr id="14" name="CaixaDeTexto 13">
             <a:extLst>
               <a:ext uri="{FF2B5EF4-FFF2-40B4-BE49-F238E27FC236}">
-                <a16:creationId xmlns:a16="http://schemas.microsoft.com/office/drawing/2014/main" id="{E48391B8-7AC0-645E-9EC1-18D58CC4B6F2}"/>
+                <a16:creationId xmlns:a16="http://schemas.microsoft.com/office/drawing/2014/main" id="{21D627AD-8DB2-3335-CBFE-584C29AF0B29}"/>
               </a:ext>
             </a:extLst>
           </p:cNvPr>
@@ -20685,7 +20685,7 @@
           <p:cNvPr id="15" name="Retângulo 14">
             <a:extLst>
               <a:ext uri="{FF2B5EF4-FFF2-40B4-BE49-F238E27FC236}">
-                <a16:creationId xmlns:a16="http://schemas.microsoft.com/office/drawing/2014/main" id="{A2350172-6989-7947-144B-217959F100BE}"/>
+                <a16:creationId xmlns:a16="http://schemas.microsoft.com/office/drawing/2014/main" id="{0BA8DA32-FE14-290B-DC81-4AB94DD81D08}"/>
               </a:ext>
             </a:extLst>
           </p:cNvPr>
@@ -20753,7 +20753,7 @@
           <p:cNvPr id="16" name="Oval 15">
             <a:extLst>
               <a:ext uri="{FF2B5EF4-FFF2-40B4-BE49-F238E27FC236}">
-                <a16:creationId xmlns:a16="http://schemas.microsoft.com/office/drawing/2014/main" id="{F6C25A34-CB9A-A297-F70B-85C4061B381A}"/>
+                <a16:creationId xmlns:a16="http://schemas.microsoft.com/office/drawing/2014/main" id="{1E73107E-0705-7124-2706-5B829460B8B9}"/>
               </a:ext>
             </a:extLst>
           </p:cNvPr>
@@ -20829,7 +20829,7 @@
           <p:cNvPr id="17" name="CaixaDeTexto 16">
             <a:extLst>
               <a:ext uri="{FF2B5EF4-FFF2-40B4-BE49-F238E27FC236}">
-                <a16:creationId xmlns:a16="http://schemas.microsoft.com/office/drawing/2014/main" id="{E604B5E4-3B34-89E2-88AE-BF87C515DBDA}"/>
+                <a16:creationId xmlns:a16="http://schemas.microsoft.com/office/drawing/2014/main" id="{088CA5D4-90D8-2E12-44EE-479BC3165D63}"/>
               </a:ext>
             </a:extLst>
           </p:cNvPr>
@@ -20869,7 +20869,7 @@
           <p:cNvPr id="18" name="CaixaDeTexto 17">
             <a:extLst>
               <a:ext uri="{FF2B5EF4-FFF2-40B4-BE49-F238E27FC236}">
-                <a16:creationId xmlns:a16="http://schemas.microsoft.com/office/drawing/2014/main" id="{1A53837E-38A6-36A4-1F02-9DF98AE4DB4C}"/>
+                <a16:creationId xmlns:a16="http://schemas.microsoft.com/office/drawing/2014/main" id="{8388288A-4370-E971-5BDB-5029661799E1}"/>
               </a:ext>
             </a:extLst>
           </p:cNvPr>
@@ -20909,7 +20909,7 @@
           <p:cNvPr id="19" name="Retângulo 18">
             <a:extLst>
               <a:ext uri="{FF2B5EF4-FFF2-40B4-BE49-F238E27FC236}">
-                <a16:creationId xmlns:a16="http://schemas.microsoft.com/office/drawing/2014/main" id="{DDA57A76-F9F9-42F0-53BD-4419CA31FDD0}"/>
+                <a16:creationId xmlns:a16="http://schemas.microsoft.com/office/drawing/2014/main" id="{EB7495D2-0C87-2887-C8EE-1A08464B7369}"/>
               </a:ext>
             </a:extLst>
           </p:cNvPr>
@@ -20977,7 +20977,7 @@
           <p:cNvPr id="20" name="Oval 19">
             <a:extLst>
               <a:ext uri="{FF2B5EF4-FFF2-40B4-BE49-F238E27FC236}">
-                <a16:creationId xmlns:a16="http://schemas.microsoft.com/office/drawing/2014/main" id="{2E5644AD-CBD9-E463-E4F3-37316E03AC2A}"/>
+                <a16:creationId xmlns:a16="http://schemas.microsoft.com/office/drawing/2014/main" id="{816F0AB9-142D-F296-65FF-191127AF766D}"/>
               </a:ext>
             </a:extLst>
           </p:cNvPr>
@@ -21053,7 +21053,7 @@
           <p:cNvPr id="21" name="CaixaDeTexto 20">
             <a:extLst>
               <a:ext uri="{FF2B5EF4-FFF2-40B4-BE49-F238E27FC236}">
-                <a16:creationId xmlns:a16="http://schemas.microsoft.com/office/drawing/2014/main" id="{8AEFE57A-07CF-AD98-D303-BF5B0D379E41}"/>
+                <a16:creationId xmlns:a16="http://schemas.microsoft.com/office/drawing/2014/main" id="{8C0A26AE-13AE-287B-32F8-4BC19AC1E7DA}"/>
               </a:ext>
             </a:extLst>
           </p:cNvPr>
@@ -21093,7 +21093,7 @@
           <p:cNvPr id="22" name="CaixaDeTexto 21">
             <a:extLst>
               <a:ext uri="{FF2B5EF4-FFF2-40B4-BE49-F238E27FC236}">
-                <a16:creationId xmlns:a16="http://schemas.microsoft.com/office/drawing/2014/main" id="{9C933F3E-6CB8-C68B-B905-C093BC7C992A}"/>
+                <a16:creationId xmlns:a16="http://schemas.microsoft.com/office/drawing/2014/main" id="{301235A8-8B2B-FBA2-A2C9-F4E55769640F}"/>
               </a:ext>
             </a:extLst>
           </p:cNvPr>
@@ -21139,7 +21139,7 @@
           <p:cNvPr id="23" name="Retângulo 22">
             <a:extLst>
               <a:ext uri="{FF2B5EF4-FFF2-40B4-BE49-F238E27FC236}">
-                <a16:creationId xmlns:a16="http://schemas.microsoft.com/office/drawing/2014/main" id="{EDDE8D8A-EF25-8AC5-8C08-B427AB575AEF}"/>
+                <a16:creationId xmlns:a16="http://schemas.microsoft.com/office/drawing/2014/main" id="{3DC1036E-0361-C901-30B0-7F9E7E95E8F8}"/>
               </a:ext>
             </a:extLst>
           </p:cNvPr>
@@ -21207,7 +21207,7 @@
           <p:cNvPr id="24" name="Oval 23">
             <a:extLst>
               <a:ext uri="{FF2B5EF4-FFF2-40B4-BE49-F238E27FC236}">
-                <a16:creationId xmlns:a16="http://schemas.microsoft.com/office/drawing/2014/main" id="{3EB2C7AB-D437-D790-615C-9551C76E6D5B}"/>
+                <a16:creationId xmlns:a16="http://schemas.microsoft.com/office/drawing/2014/main" id="{A7F7E44E-9B53-C9EE-CE7A-5F0CE78966D6}"/>
               </a:ext>
             </a:extLst>
           </p:cNvPr>
@@ -21283,7 +21283,7 @@
           <p:cNvPr id="25" name="CaixaDeTexto 24">
             <a:extLst>
               <a:ext uri="{FF2B5EF4-FFF2-40B4-BE49-F238E27FC236}">
-                <a16:creationId xmlns:a16="http://schemas.microsoft.com/office/drawing/2014/main" id="{5443758E-0E3F-0748-546C-E2E65CFBA3C9}"/>
+                <a16:creationId xmlns:a16="http://schemas.microsoft.com/office/drawing/2014/main" id="{0A7B588B-AB43-79A3-32DD-1A7790F223F8}"/>
               </a:ext>
             </a:extLst>
           </p:cNvPr>
@@ -21323,7 +21323,7 @@
           <p:cNvPr id="26" name="CaixaDeTexto 25">
             <a:extLst>
               <a:ext uri="{FF2B5EF4-FFF2-40B4-BE49-F238E27FC236}">
-                <a16:creationId xmlns:a16="http://schemas.microsoft.com/office/drawing/2014/main" id="{269C1CA8-5788-F751-93FF-5B1387C6A69C}"/>
+                <a16:creationId xmlns:a16="http://schemas.microsoft.com/office/drawing/2014/main" id="{02182716-C4B2-6291-FA0A-706C57D1446B}"/>
               </a:ext>
             </a:extLst>
           </p:cNvPr>
@@ -21361,7 +21361,7 @@
     </p:spTree>
     <p:extLst>
       <p:ext uri="{BB962C8B-B14F-4D97-AF65-F5344CB8AC3E}">
-        <p14:creationId xmlns:p14="http://schemas.microsoft.com/office/powerpoint/2010/main" val="2591828125"/>
+        <p14:creationId xmlns:p14="http://schemas.microsoft.com/office/powerpoint/2010/main" val="356495283"/>
       </p:ext>
     </p:extLst>
   </p:cSld>
@@ -21424,7 +21424,7 @@
           <p:cNvPr id="2" name="CaixaDeTexto 1">
             <a:extLst>
               <a:ext uri="{FF2B5EF4-FFF2-40B4-BE49-F238E27FC236}">
-                <a16:creationId xmlns:a16="http://schemas.microsoft.com/office/drawing/2014/main" id="{A67A5592-3EF1-37E6-3337-1F765ECB5888}"/>
+                <a16:creationId xmlns:a16="http://schemas.microsoft.com/office/drawing/2014/main" id="{52B261CB-F42C-018E-8CA3-5CD9C9D602D3}"/>
               </a:ext>
             </a:extLst>
           </p:cNvPr>
@@ -21464,7 +21464,7 @@
           <p:cNvPr id="3" name="Retângulo 2">
             <a:extLst>
               <a:ext uri="{FF2B5EF4-FFF2-40B4-BE49-F238E27FC236}">
-                <a16:creationId xmlns:a16="http://schemas.microsoft.com/office/drawing/2014/main" id="{C3185298-B415-CC11-963A-5C3A979D0597}"/>
+                <a16:creationId xmlns:a16="http://schemas.microsoft.com/office/drawing/2014/main" id="{8CE29D6C-2857-9F88-0078-EE78A36AAAFD}"/>
               </a:ext>
             </a:extLst>
           </p:cNvPr>
@@ -21532,7 +21532,7 @@
           <p:cNvPr id="4" name="Retângulo 3">
             <a:extLst>
               <a:ext uri="{FF2B5EF4-FFF2-40B4-BE49-F238E27FC236}">
-                <a16:creationId xmlns:a16="http://schemas.microsoft.com/office/drawing/2014/main" id="{71C902F7-9A1C-52BF-5320-C0FC3904002D}"/>
+                <a16:creationId xmlns:a16="http://schemas.microsoft.com/office/drawing/2014/main" id="{CF6F7F4E-7768-977F-CBF1-2584273E9D85}"/>
               </a:ext>
             </a:extLst>
           </p:cNvPr>
@@ -21600,7 +21600,7 @@
           <p:cNvPr id="5" name="CaixaDeTexto 4">
             <a:extLst>
               <a:ext uri="{FF2B5EF4-FFF2-40B4-BE49-F238E27FC236}">
-                <a16:creationId xmlns:a16="http://schemas.microsoft.com/office/drawing/2014/main" id="{74A8636E-DC32-E71B-D8EC-FDD95E8E67D3}"/>
+                <a16:creationId xmlns:a16="http://schemas.microsoft.com/office/drawing/2014/main" id="{BFFA6E51-A488-9036-DB8F-1F8AEE6F43EE}"/>
               </a:ext>
             </a:extLst>
           </p:cNvPr>
@@ -21640,7 +21640,7 @@
           <p:cNvPr id="6" name="CaixaDeTexto 5">
             <a:extLst>
               <a:ext uri="{FF2B5EF4-FFF2-40B4-BE49-F238E27FC236}">
-                <a16:creationId xmlns:a16="http://schemas.microsoft.com/office/drawing/2014/main" id="{56734556-E79C-9599-FE1E-664F4C56AFC5}"/>
+                <a16:creationId xmlns:a16="http://schemas.microsoft.com/office/drawing/2014/main" id="{D9C200E4-1E7B-C147-2B6F-B6023DE41564}"/>
               </a:ext>
             </a:extLst>
           </p:cNvPr>
@@ -21681,7 +21681,7 @@
           <p:cNvPr id="7" name="CaixaDeTexto 6">
             <a:extLst>
               <a:ext uri="{FF2B5EF4-FFF2-40B4-BE49-F238E27FC236}">
-                <a16:creationId xmlns:a16="http://schemas.microsoft.com/office/drawing/2014/main" id="{A735235E-E485-EDB2-C797-38E1976E20C0}"/>
+                <a16:creationId xmlns:a16="http://schemas.microsoft.com/office/drawing/2014/main" id="{ED52EA5A-9E5F-9ECD-A85A-8B3F43EF97C1}"/>
               </a:ext>
             </a:extLst>
           </p:cNvPr>
@@ -21928,7 +21928,7 @@
     </p:spTree>
     <p:extLst>
       <p:ext uri="{BB962C8B-B14F-4D97-AF65-F5344CB8AC3E}">
-        <p14:creationId xmlns:p14="http://schemas.microsoft.com/office/powerpoint/2010/main" val="279465224"/>
+        <p14:creationId xmlns:p14="http://schemas.microsoft.com/office/powerpoint/2010/main" val="3234954739"/>
       </p:ext>
     </p:extLst>
   </p:cSld>

</xml_diff>